<commit_message>
feat: integrate real credible images across all presentation slides and verify calculations
</commit_message>
<xml_diff>
--- a/Car_Buying_Project/Buying_Your_First_Car_Presentation.pptx
+++ b/Car_Buying_Project/Buying_Your_First_Car_Presentation.pptx
@@ -3108,7 +3108,7 @@
             <a:avLst/>
           </a:prstGeom>
           <a:solidFill>
-            <a:srgbClr val="F8FAFC"/>
+            <a:srgbClr val="F5F7FA"/>
           </a:solidFill>
           <a:ln>
             <a:noFill/>
@@ -3151,7 +3151,7 @@
             <a:avLst/>
           </a:prstGeom>
           <a:solidFill>
-            <a:srgbClr val="182646"/>
+            <a:srgbClr val="0F172A"/>
           </a:solidFill>
           <a:ln>
             <a:noFill/>
@@ -3187,14 +3187,14 @@
         </p:nvSpPr>
         <p:spPr>
           <a:xfrm>
-            <a:off x="731520" y="182880"/>
-            <a:ext cx="2103120" cy="320040"/>
+            <a:off x="731520" y="164592"/>
+            <a:ext cx="2194560" cy="292608"/>
           </a:xfrm>
           <a:prstGeom prst="roundRect">
             <a:avLst/>
           </a:prstGeom>
           <a:solidFill>
-            <a:srgbClr val="1D4ED8"/>
+            <a:srgbClr val="DC2626"/>
           </a:solidFill>
           <a:ln>
             <a:noFill/>
@@ -3215,14 +3215,15 @@
           </a:fontRef>
         </p:style>
         <p:txBody>
-          <a:bodyPr rtlCol="0" anchor="ctr" wrap="square" tIns="18288" bIns="18288"/>
+          <a:bodyPr rtlCol="0" anchor="ctr" wrap="square" tIns="0"/>
           <a:lstStyle/>
           <a:p>
             <a:pPr algn="ctr">
-              <a:defRPr sz="1100" b="1">
+              <a:defRPr sz="1050" b="1">
                 <a:solidFill>
                   <a:srgbClr val="FFFFFF"/>
                 </a:solidFill>
+                <a:latin typeface="Calibri"/>
               </a:defRPr>
             </a:pPr>
             <a:r>
@@ -3239,8 +3240,8 @@
         </p:nvSpPr>
         <p:spPr>
           <a:xfrm>
-            <a:off x="731520" y="530352"/>
-            <a:ext cx="8686800" cy="457200"/>
+            <a:off x="731520" y="502920"/>
+            <a:ext cx="8229600" cy="502920"/>
           </a:xfrm>
           <a:prstGeom prst="rect">
             <a:avLst/>
@@ -3254,10 +3255,11 @@
           <a:lstStyle/>
           <a:p>
             <a:pPr>
-              <a:defRPr sz="2000" b="1">
+              <a:defRPr sz="2100" b="1">
                 <a:solidFill>
                   <a:srgbClr val="FFFFFF"/>
                 </a:solidFill>
+                <a:latin typeface="Calibri"/>
               </a:defRPr>
             </a:pPr>
             <a:r>
@@ -3274,7 +3276,7 @@
         </p:nvSpPr>
         <p:spPr>
           <a:xfrm>
-            <a:off x="7772400" y="228600"/>
+            <a:off x="7772400" y="182880"/>
             <a:ext cx="3657600" cy="685800"/>
           </a:xfrm>
           <a:prstGeom prst="rect">
@@ -3289,10 +3291,11 @@
           <a:lstStyle/>
           <a:p>
             <a:pPr algn="r">
-              <a:defRPr sz="1200">
+              <a:defRPr sz="1100">
                 <a:solidFill>
                   <a:srgbClr val="94A3B8"/>
                 </a:solidFill>
+                <a:latin typeface="Calibri"/>
               </a:defRPr>
             </a:pPr>
             <a:r>
@@ -3301,14 +3304,15 @@
           </a:p>
           <a:p>
             <a:pPr algn="r">
-              <a:defRPr sz="1100" b="1">
+              <a:defRPr sz="1200" b="1">
                 <a:solidFill>
                   <a:srgbClr val="E2E8F0"/>
                 </a:solidFill>
-              </a:defRPr>
-            </a:pPr>
-            <a:r>
-              <a:t>Student: Rehan Mangar  |  Slide 1 of 6</a:t>
+                <a:latin typeface="Calibri"/>
+              </a:defRPr>
+            </a:pPr>
+            <a:r>
+              <a:t>Student: Rehan Mangar  •  Slide 1 of 6</a:t>
             </a:r>
           </a:p>
         </p:txBody>
@@ -3321,8 +3325,8 @@
         </p:nvSpPr>
         <p:spPr>
           <a:xfrm>
-            <a:off x="731520" y="1280160"/>
-            <a:ext cx="5486400" cy="5120640"/>
+            <a:off x="731520" y="1234440"/>
+            <a:ext cx="5577840" cy="5212080"/>
           </a:xfrm>
           <a:prstGeom prst="roundRect">
             <a:avLst/>
@@ -3351,33 +3355,35 @@
           </a:fontRef>
         </p:style>
         <p:txBody>
-          <a:bodyPr rtlCol="0" anchor="ctr" lIns="320040" rIns="320040" tIns="320040"/>
+          <a:bodyPr rtlCol="0" anchor="ctr" lIns="320040" rIns="320040" tIns="274320"/>
           <a:lstStyle/>
           <a:p>
             <a:pPr algn="ctr">
-              <a:defRPr sz="1300" b="1">
-                <a:solidFill>
-                  <a:srgbClr val="1D4ED8"/>
-                </a:solidFill>
-              </a:defRPr>
-            </a:pPr>
-            <a:r>
-              <a:t>EMPLOYMENT INFORMATION</a:t>
+              <a:defRPr sz="1200" b="1">
+                <a:solidFill>
+                  <a:srgbClr val="DC2626"/>
+                </a:solidFill>
+                <a:latin typeface="Calibri"/>
+              </a:defRPr>
+            </a:pPr>
+            <a:r>
+              <a:t>JOB PROFILE &amp; EARNINGS</a:t>
             </a:r>
           </a:p>
           <a:p>
             <a:pPr>
               <a:spcAft>
-                <a:spcPts val="1400"/>
+                <a:spcPts val="1200"/>
               </a:spcAft>
-              <a:defRPr sz="2000" b="1">
+              <a:defRPr sz="2200" b="1">
                 <a:solidFill>
                   <a:srgbClr val="0F172A"/>
                 </a:solidFill>
-              </a:defRPr>
-            </a:pPr>
-            <a:r>
-              <a:t>Assigned Job: Target Team Member</a:t>
+                <a:latin typeface="Calibri"/>
+              </a:defRPr>
+            </a:pPr>
+            <a:r>
+              <a:t>Target Team Member</a:t>
             </a:r>
           </a:p>
           <a:p>
@@ -3386,33 +3392,102 @@
                 <a:solidFill>
                   <a:srgbClr val="0F172A"/>
                 </a:solidFill>
-              </a:defRPr>
-            </a:pPr>
-            <a:r>
-              <a:t>• Hourly Wage: </a:t>
-            </a:r>
-            <a:r>
-              <a:rPr b="1" sz="1500">
+                <a:latin typeface="Calibri"/>
+              </a:defRPr>
+            </a:pPr>
+            <a:r>
+              <a:t>• Position / Company: </a:t>
+            </a:r>
+            <a:r>
+              <a:rPr b="1" sz="1400">
                 <a:solidFill>
                   <a:srgbClr val="1D4ED8"/>
                 </a:solidFill>
+                <a:latin typeface="Calibri"/>
+              </a:rPr>
+              <a:t>Target (Sales Floor / Cashier)</a:t>
+            </a:r>
+          </a:p>
+          <a:p>
+            <a:pPr>
+              <a:defRPr b="1" sz="1300">
+                <a:solidFill>
+                  <a:srgbClr val="0F172A"/>
+                </a:solidFill>
+                <a:latin typeface="Calibri"/>
+              </a:defRPr>
+            </a:pPr>
+            <a:r>
+              <a:t>• Hourly Pay Rate: </a:t>
+            </a:r>
+            <a:r>
+              <a:rPr b="1" sz="1400">
+                <a:solidFill>
+                  <a:srgbClr val="1D4ED8"/>
+                </a:solidFill>
+                <a:latin typeface="Calibri"/>
               </a:rPr>
               <a:t>$14.25 / hour</a:t>
             </a:r>
           </a:p>
           <a:p>
             <a:pPr>
+              <a:defRPr b="1" sz="1300">
+                <a:solidFill>
+                  <a:srgbClr val="0F172A"/>
+                </a:solidFill>
+                <a:latin typeface="Calibri"/>
+              </a:defRPr>
+            </a:pPr>
+            <a:r>
+              <a:t>• Weekly Hours Scheduled: </a:t>
+            </a:r>
+            <a:r>
+              <a:rPr b="1" sz="1400">
+                <a:solidFill>
+                  <a:srgbClr val="1D4ED8"/>
+                </a:solidFill>
+                <a:latin typeface="Calibri"/>
+              </a:rPr>
+              <a:t>24 hours / week</a:t>
+            </a:r>
+          </a:p>
+          <a:p>
+            <a:pPr>
+              <a:defRPr b="1" sz="1300">
+                <a:solidFill>
+                  <a:srgbClr val="0F172A"/>
+                </a:solidFill>
+                <a:latin typeface="Calibri"/>
+              </a:defRPr>
+            </a:pPr>
+            <a:r>
+              <a:t>• Gross Weekly Income: </a:t>
+            </a:r>
+            <a:r>
+              <a:rPr b="1" sz="1400">
+                <a:solidFill>
+                  <a:srgbClr val="1D4ED8"/>
+                </a:solidFill>
+                <a:latin typeface="Calibri"/>
+              </a:rPr>
+              <a:t>$342.00 / week</a:t>
+            </a:r>
+          </a:p>
+          <a:p>
+            <a:pPr>
               <a:spcAft>
-                <a:spcPts val="800"/>
+                <a:spcPts val="400"/>
               </a:spcAft>
               <a:defRPr sz="1050">
                 <a:solidFill>
                   <a:srgbClr val="64748B"/>
                 </a:solidFill>
-              </a:defRPr>
-            </a:pPr>
-            <a:r>
-              <a:t>   (Starting entry-level pay rate)</a:t>
+                <a:latin typeface="Calibri"/>
+              </a:defRPr>
+            </a:pPr>
+            <a:r>
+              <a:t>   (24 hrs × $14.25 / hr)</a:t>
             </a:r>
           </a:p>
           <a:p>
@@ -3421,33 +3496,36 @@
                 <a:solidFill>
                   <a:srgbClr val="0F172A"/>
                 </a:solidFill>
-              </a:defRPr>
-            </a:pPr>
-            <a:r>
-              <a:t>• Work Schedule: </a:t>
-            </a:r>
-            <a:r>
-              <a:rPr b="1" sz="1500">
+                <a:latin typeface="Calibri"/>
+              </a:defRPr>
+            </a:pPr>
+            <a:r>
+              <a:t>• Gross Monthly Income: </a:t>
+            </a:r>
+            <a:r>
+              <a:rPr b="1" sz="1400">
                 <a:solidFill>
                   <a:srgbClr val="1D4ED8"/>
                 </a:solidFill>
+                <a:latin typeface="Calibri"/>
               </a:rPr>
-              <a:t>24 hours / week</a:t>
+              <a:t>$1,368.00 / month</a:t>
             </a:r>
           </a:p>
           <a:p>
             <a:pPr>
               <a:spcAft>
-                <a:spcPts val="800"/>
+                <a:spcPts val="400"/>
               </a:spcAft>
               <a:defRPr sz="1050">
                 <a:solidFill>
                   <a:srgbClr val="64748B"/>
                 </a:solidFill>
-              </a:defRPr>
-            </a:pPr>
-            <a:r>
-              <a:t>   (Part-time school-year schedule)</a:t>
+                <a:latin typeface="Calibri"/>
+              </a:defRPr>
+            </a:pPr>
+            <a:r>
+              <a:t>   ($342.00 × 4 weeks)</a:t>
             </a:r>
           </a:p>
           <a:p>
@@ -3456,103 +3534,36 @@
                 <a:solidFill>
                   <a:srgbClr val="0F172A"/>
                 </a:solidFill>
-              </a:defRPr>
-            </a:pPr>
-            <a:r>
-              <a:t>• Gross Weekly Pay: </a:t>
-            </a:r>
-            <a:r>
-              <a:rPr b="1" sz="1500">
-                <a:solidFill>
-                  <a:srgbClr val="1D4ED8"/>
-                </a:solidFill>
+                <a:latin typeface="Calibri"/>
+              </a:defRPr>
+            </a:pPr>
+            <a:r>
+              <a:t>• Transportation Budget (11%): </a:t>
+            </a:r>
+            <a:r>
+              <a:rPr b="1" sz="1400">
+                <a:solidFill>
+                  <a:srgbClr val="DC2626"/>
+                </a:solidFill>
+                <a:latin typeface="Calibri"/>
               </a:rPr>
-              <a:t>$342.00 / week</a:t>
+              <a:t>$150.48 / month</a:t>
             </a:r>
           </a:p>
           <a:p>
             <a:pPr>
               <a:spcAft>
-                <a:spcPts val="800"/>
+                <a:spcPts val="400"/>
               </a:spcAft>
               <a:defRPr sz="1050">
                 <a:solidFill>
                   <a:srgbClr val="64748B"/>
                 </a:solidFill>
-              </a:defRPr>
-            </a:pPr>
-            <a:r>
-              <a:t>   (Calculation: 24 hrs × $14.25/hr)</a:t>
-            </a:r>
-          </a:p>
-          <a:p>
-            <a:pPr>
-              <a:defRPr b="1" sz="1300">
-                <a:solidFill>
-                  <a:srgbClr val="0F172A"/>
-                </a:solidFill>
-              </a:defRPr>
-            </a:pPr>
-            <a:r>
-              <a:t>• Gross Monthly Pay: </a:t>
-            </a:r>
-            <a:r>
-              <a:rPr b="1" sz="1500">
-                <a:solidFill>
-                  <a:srgbClr val="1D4ED8"/>
-                </a:solidFill>
-              </a:rPr>
-              <a:t>$1,368.00 / month</a:t>
-            </a:r>
-          </a:p>
-          <a:p>
-            <a:pPr>
-              <a:spcAft>
-                <a:spcPts val="800"/>
-              </a:spcAft>
-              <a:defRPr sz="1050">
-                <a:solidFill>
-                  <a:srgbClr val="64748B"/>
-                </a:solidFill>
-              </a:defRPr>
-            </a:pPr>
-            <a:r>
-              <a:t>   (Calculation: $342.00 × 4 weeks)</a:t>
-            </a:r>
-          </a:p>
-          <a:p>
-            <a:pPr>
-              <a:defRPr b="1" sz="1300">
-                <a:solidFill>
-                  <a:srgbClr val="0F172A"/>
-                </a:solidFill>
-              </a:defRPr>
-            </a:pPr>
-            <a:r>
-              <a:t>• Transportation Budget (11%): </a:t>
-            </a:r>
-            <a:r>
-              <a:rPr b="1" sz="1500">
-                <a:solidFill>
-                  <a:srgbClr val="DC2626"/>
-                </a:solidFill>
-              </a:rPr>
-              <a:t>$150.48 / month</a:t>
-            </a:r>
-          </a:p>
-          <a:p>
-            <a:pPr>
-              <a:spcAft>
-                <a:spcPts val="800"/>
-              </a:spcAft>
-              <a:defRPr sz="1050">
-                <a:solidFill>
-                  <a:srgbClr val="64748B"/>
-                </a:solidFill>
-              </a:defRPr>
-            </a:pPr>
-            <a:r>
-              <a:t>   (Rule: 11% of gross monthly income ($1,368 × 0.11))</a:t>
+                <a:latin typeface="Calibri"/>
+              </a:defRPr>
+            </a:pPr>
+            <a:r>
+              <a:t>   ($1,368.00 × 0.11)</a:t>
             </a:r>
           </a:p>
         </p:txBody>
@@ -3565,8 +3576,8 @@
         </p:nvSpPr>
         <p:spPr>
           <a:xfrm>
-            <a:off x="6492240" y="1280160"/>
-            <a:ext cx="4937760" cy="5120640"/>
+            <a:off x="6492240" y="1234440"/>
+            <a:ext cx="4937760" cy="5212080"/>
           </a:xfrm>
           <a:prstGeom prst="roundRect">
             <a:avLst/>
@@ -3618,8 +3629,8 @@
         </p:blipFill>
         <p:spPr>
           <a:xfrm>
-            <a:off x="6720840" y="1508760"/>
-            <a:ext cx="4480560" cy="2834640"/>
+            <a:off x="6720840" y="1463040"/>
+            <a:ext cx="4480560" cy="2926080"/>
           </a:xfrm>
           <a:prstGeom prst="rect">
             <a:avLst/>
@@ -3635,7 +3646,7 @@
         <p:spPr>
           <a:xfrm>
             <a:off x="6720840" y="4572000"/>
-            <a:ext cx="4480560" cy="1600200"/>
+            <a:ext cx="4480560" cy="1645920"/>
           </a:xfrm>
           <a:prstGeom prst="roundRect">
             <a:avLst/>
@@ -3664,30 +3675,32 @@
           </a:fontRef>
         </p:style>
         <p:txBody>
-          <a:bodyPr rtlCol="0" anchor="ctr" lIns="228600" rIns="228600" tIns="182880"/>
+          <a:bodyPr rtlCol="0" anchor="ctr" lIns="228600" rIns="228600" tIns="164592"/>
           <a:lstStyle/>
           <a:p>
             <a:pPr algn="ctr">
-              <a:defRPr sz="1200" b="1">
+              <a:defRPr sz="1150" b="1">
                 <a:solidFill>
                   <a:srgbClr val="1D4ED8"/>
                 </a:solidFill>
-              </a:defRPr>
-            </a:pPr>
-            <a:r>
-              <a:t>TARGET EMPLOYMENT SUMMARY</a:t>
+                <a:latin typeface="Calibri"/>
+              </a:defRPr>
+            </a:pPr>
+            <a:r>
+              <a:t>BUDGET FOUNDATION &amp; GOALS</a:t>
             </a:r>
           </a:p>
           <a:p>
             <a:pPr>
-              <a:defRPr sz="1100">
-                <a:solidFill>
-                  <a:srgbClr val="0F172A"/>
-                </a:solidFill>
-              </a:defRPr>
-            </a:pPr>
-            <a:r>
-              <a:t>Steady income allows starting car financing, but keeping total transportation costs aligned with the $150.48/mo guideline requires diligent budget planning and disciplined saving.</a:t>
+              <a:defRPr sz="1050">
+                <a:solidFill>
+                  <a:srgbClr val="334155"/>
+                </a:solidFill>
+                <a:latin typeface="Calibri"/>
+              </a:defRPr>
+            </a:pPr>
+            <a:r>
+              <a:t>At 24 hours/week, working at Target generates $1,368 gross monthly. The standard 11% transportation guideline allocates $150.48/month for vehicle expenses. Any car loan and insurance must be planned carefully around this baseline.</a:t>
             </a:r>
           </a:p>
         </p:txBody>
@@ -3725,7 +3738,7 @@
             <a:avLst/>
           </a:prstGeom>
           <a:solidFill>
-            <a:srgbClr val="F8FAFC"/>
+            <a:srgbClr val="F5F7FA"/>
           </a:solidFill>
           <a:ln>
             <a:noFill/>
@@ -3768,7 +3781,7 @@
             <a:avLst/>
           </a:prstGeom>
           <a:solidFill>
-            <a:srgbClr val="182646"/>
+            <a:srgbClr val="0F172A"/>
           </a:solidFill>
           <a:ln>
             <a:noFill/>
@@ -3804,8 +3817,8 @@
         </p:nvSpPr>
         <p:spPr>
           <a:xfrm>
-            <a:off x="731520" y="182880"/>
-            <a:ext cx="2103120" cy="320040"/>
+            <a:off x="731520" y="164592"/>
+            <a:ext cx="2194560" cy="292608"/>
           </a:xfrm>
           <a:prstGeom prst="roundRect">
             <a:avLst/>
@@ -3832,14 +3845,15 @@
           </a:fontRef>
         </p:style>
         <p:txBody>
-          <a:bodyPr rtlCol="0" anchor="ctr" wrap="square" tIns="18288" bIns="18288"/>
+          <a:bodyPr rtlCol="0" anchor="ctr" wrap="square" tIns="0"/>
           <a:lstStyle/>
           <a:p>
             <a:pPr algn="ctr">
-              <a:defRPr sz="1100" b="1">
+              <a:defRPr sz="1050" b="1">
                 <a:solidFill>
                   <a:srgbClr val="FFFFFF"/>
                 </a:solidFill>
+                <a:latin typeface="Calibri"/>
               </a:defRPr>
             </a:pPr>
             <a:r>
@@ -3856,8 +3870,8 @@
         </p:nvSpPr>
         <p:spPr>
           <a:xfrm>
-            <a:off x="731520" y="530352"/>
-            <a:ext cx="8686800" cy="457200"/>
+            <a:off x="731520" y="502920"/>
+            <a:ext cx="8229600" cy="502920"/>
           </a:xfrm>
           <a:prstGeom prst="rect">
             <a:avLst/>
@@ -3871,10 +3885,11 @@
           <a:lstStyle/>
           <a:p>
             <a:pPr>
-              <a:defRPr sz="2000" b="1">
+              <a:defRPr sz="2100" b="1">
                 <a:solidFill>
                   <a:srgbClr val="FFFFFF"/>
                 </a:solidFill>
+                <a:latin typeface="Calibri"/>
               </a:defRPr>
             </a:pPr>
             <a:r>
@@ -3891,7 +3906,7 @@
         </p:nvSpPr>
         <p:spPr>
           <a:xfrm>
-            <a:off x="7772400" y="228600"/>
+            <a:off x="7772400" y="182880"/>
             <a:ext cx="3657600" cy="685800"/>
           </a:xfrm>
           <a:prstGeom prst="rect">
@@ -3906,10 +3921,11 @@
           <a:lstStyle/>
           <a:p>
             <a:pPr algn="r">
-              <a:defRPr sz="1200">
+              <a:defRPr sz="1100">
                 <a:solidFill>
                   <a:srgbClr val="94A3B8"/>
                 </a:solidFill>
+                <a:latin typeface="Calibri"/>
               </a:defRPr>
             </a:pPr>
             <a:r>
@@ -3918,14 +3934,15 @@
           </a:p>
           <a:p>
             <a:pPr algn="r">
-              <a:defRPr sz="1100" b="1">
+              <a:defRPr sz="1200" b="1">
                 <a:solidFill>
                   <a:srgbClr val="E2E8F0"/>
                 </a:solidFill>
-              </a:defRPr>
-            </a:pPr>
-            <a:r>
-              <a:t>Student: Rehan Mangar  |  Slide 2 of 6</a:t>
+                <a:latin typeface="Calibri"/>
+              </a:defRPr>
+            </a:pPr>
+            <a:r>
+              <a:t>Student: Rehan Mangar  •  Slide 2 of 6</a:t>
             </a:r>
           </a:p>
         </p:txBody>
@@ -3938,8 +3955,8 @@
         </p:nvSpPr>
         <p:spPr>
           <a:xfrm>
-            <a:off x="731520" y="1280160"/>
-            <a:ext cx="5029200" cy="5120640"/>
+            <a:off x="731520" y="1234440"/>
+            <a:ext cx="5029200" cy="5212080"/>
           </a:xfrm>
           <a:prstGeom prst="roundRect">
             <a:avLst/>
@@ -3947,7 +3964,7 @@
           <a:solidFill>
             <a:srgbClr val="FFFFFF"/>
           </a:solidFill>
-          <a:ln>
+          <a:ln w="19050">
             <a:solidFill>
               <a:srgbClr val="E2E8F0"/>
             </a:solidFill>
@@ -3991,8 +4008,8 @@
         </p:blipFill>
         <p:spPr>
           <a:xfrm>
-            <a:off x="914400" y="1463040"/>
-            <a:ext cx="4663440" cy="2926080"/>
+            <a:off x="960120" y="1463040"/>
+            <a:ext cx="4572000" cy="2880360"/>
           </a:xfrm>
           <a:prstGeom prst="rect">
             <a:avLst/>
@@ -4007,8 +4024,8 @@
         </p:nvSpPr>
         <p:spPr>
           <a:xfrm>
-            <a:off x="914400" y="4617720"/>
-            <a:ext cx="2240280" cy="1554480"/>
+            <a:off x="960120" y="4526280"/>
+            <a:ext cx="2194560" cy="1645920"/>
           </a:xfrm>
           <a:prstGeom prst="roundRect">
             <a:avLst/>
@@ -4037,7 +4054,7 @@
           </a:fontRef>
         </p:style>
         <p:txBody>
-          <a:bodyPr rtlCol="0" anchor="ctr" tIns="137160"/>
+          <a:bodyPr rtlCol="0" anchor="ctr" tIns="164592"/>
           <a:lstStyle/>
           <a:p>
             <a:pPr algn="ctr">
@@ -4045,6 +4062,7 @@
                 <a:solidFill>
                   <a:srgbClr val="1D4ED8"/>
                 </a:solidFill>
+                <a:latin typeface="Calibri"/>
               </a:defRPr>
             </a:pPr>
             <a:r>
@@ -4057,6 +4075,7 @@
                 <a:solidFill>
                   <a:srgbClr val="0F172A"/>
                 </a:solidFill>
+                <a:latin typeface="Calibri"/>
               </a:defRPr>
             </a:pPr>
             <a:r>
@@ -4069,10 +4088,11 @@
                 <a:solidFill>
                   <a:srgbClr val="64748B"/>
                 </a:solidFill>
-              </a:defRPr>
-            </a:pPr>
-            <a:r>
-              <a:t>Under $20K project budget</a:t>
+                <a:latin typeface="Calibri"/>
+              </a:defRPr>
+            </a:pPr>
+            <a:r>
+              <a:t>Under $20K budget limit</a:t>
             </a:r>
           </a:p>
         </p:txBody>
@@ -4085,8 +4105,8 @@
         </p:nvSpPr>
         <p:spPr>
           <a:xfrm>
-            <a:off x="3337560" y="4617720"/>
-            <a:ext cx="2240280" cy="1554480"/>
+            <a:off x="3337560" y="4526280"/>
+            <a:ext cx="2194560" cy="1645920"/>
           </a:xfrm>
           <a:prstGeom prst="roundRect">
             <a:avLst/>
@@ -4115,7 +4135,7 @@
           </a:fontRef>
         </p:style>
         <p:txBody>
-          <a:bodyPr rtlCol="0" anchor="ctr" tIns="137160"/>
+          <a:bodyPr rtlCol="0" anchor="ctr" tIns="164592"/>
           <a:lstStyle/>
           <a:p>
             <a:pPr algn="ctr">
@@ -4123,6 +4143,7 @@
                 <a:solidFill>
                   <a:srgbClr val="D97706"/>
                 </a:solidFill>
+                <a:latin typeface="Calibri"/>
               </a:defRPr>
             </a:pPr>
             <a:r>
@@ -4135,6 +4156,7 @@
                 <a:solidFill>
                   <a:srgbClr val="0F172A"/>
                 </a:solidFill>
+                <a:latin typeface="Calibri"/>
               </a:defRPr>
             </a:pPr>
             <a:r>
@@ -4147,10 +4169,11 @@
                 <a:solidFill>
                   <a:srgbClr val="64748B"/>
                 </a:solidFill>
-              </a:defRPr>
-            </a:pPr>
-            <a:r>
-              <a:t>14.5 Gal × $3.89/gal</a:t>
+                <a:latin typeface="Calibri"/>
+              </a:defRPr>
+            </a:pPr>
+            <a:r>
+              <a:t>14.5 Gallons × $3.89/gal</a:t>
             </a:r>
           </a:p>
         </p:txBody>
@@ -4163,8 +4186,8 @@
         </p:nvSpPr>
         <p:spPr>
           <a:xfrm>
-            <a:off x="6035040" y="1280160"/>
-            <a:ext cx="5394960" cy="5120640"/>
+            <a:off x="5989320" y="1234440"/>
+            <a:ext cx="5486400" cy="5212080"/>
           </a:xfrm>
           <a:prstGeom prst="roundRect">
             <a:avLst/>
@@ -4172,7 +4195,7 @@
           <a:solidFill>
             <a:srgbClr val="FFFFFF"/>
           </a:solidFill>
-          <a:ln>
+          <a:ln w="19050">
             <a:solidFill>
               <a:srgbClr val="E2E8F0"/>
             </a:solidFill>
@@ -4193,14 +4216,15 @@
           </a:fontRef>
         </p:style>
         <p:txBody>
-          <a:bodyPr rtlCol="0" anchor="ctr" lIns="320040" rIns="320040" tIns="274320"/>
+          <a:bodyPr rtlCol="0" anchor="ctr" lIns="320040" rIns="320040" tIns="256032"/>
           <a:lstStyle/>
           <a:p>
             <a:pPr algn="ctr">
-              <a:defRPr sz="1200" b="1">
+              <a:defRPr sz="1150" b="1">
                 <a:solidFill>
                   <a:srgbClr val="1D4ED8"/>
                 </a:solidFill>
+                <a:latin typeface="Calibri"/>
               </a:defRPr>
             </a:pPr>
             <a:r>
@@ -4210,12 +4234,13 @@
           <a:p>
             <a:pPr>
               <a:spcAft>
-                <a:spcPts val="1000"/>
+                <a:spcPts val="800"/>
               </a:spcAft>
               <a:defRPr sz="1800" b="1">
                 <a:solidFill>
                   <a:srgbClr val="0F172A"/>
                 </a:solidFill>
+                <a:latin typeface="Calibri"/>
               </a:defRPr>
             </a:pPr>
             <a:r>
@@ -4224,10 +4249,11 @@
           </a:p>
           <a:p>
             <a:pPr>
-              <a:defRPr b="1" sz="1300">
+              <a:defRPr b="1" sz="1250">
                 <a:solidFill>
                   <a:srgbClr val="0F172A"/>
                 </a:solidFill>
+                <a:latin typeface="Calibri"/>
               </a:defRPr>
             </a:pPr>
             <a:r>
@@ -4237,91 +4263,96 @@
           <a:p>
             <a:pPr>
               <a:spcAft>
-                <a:spcPts val="1000"/>
+                <a:spcPts val="800"/>
               </a:spcAft>
               <a:defRPr sz="1100">
                 <a:solidFill>
+                  <a:srgbClr val="334155"/>
+                </a:solidFill>
+                <a:latin typeface="Calibri"/>
+              </a:defRPr>
+            </a:pPr>
+            <a:r>
+              <a:t>• Apple CarPlay &amp; Android Auto integration</a:t>
+            </a:r>
+            <a:br/>
+            <a:r>
+              <a:t>• Keyless start &amp; remote entry with push-button ignition</a:t>
+            </a:r>
+            <a:br/>
+            <a:r>
+              <a:t>• Bluetooth hands-free phone &amp; audio streaming</a:t>
+            </a:r>
+            <a:br/>
+            <a:r>
+              <a:t>• Rearview backup camera &amp; automatic parking assistance</a:t>
+            </a:r>
+          </a:p>
+          <a:p>
+            <a:pPr>
+              <a:defRPr b="1" sz="1250">
+                <a:solidFill>
                   <a:srgbClr val="0F172A"/>
                 </a:solidFill>
-              </a:defRPr>
-            </a:pPr>
-            <a:r>
-              <a:t>• Apple CarPlay &amp; Android Auto integration with Bluetooth</a:t>
-            </a:r>
-            <a:br/>
-            <a:r>
-              <a:t>• Keyless entry with push-button start</a:t>
-            </a:r>
-            <a:br/>
-            <a:r>
-              <a:t>• Rearview backup camera &amp; automatic parking assistance</a:t>
-            </a:r>
-            <a:br/>
-            <a:r>
-              <a:t>• 8-inch digital infotainment touchscreen</a:t>
-            </a:r>
-          </a:p>
-          <a:p>
-            <a:pPr>
-              <a:defRPr b="1" sz="1300">
-                <a:solidFill>
-                  <a:srgbClr val="0F172A"/>
-                </a:solidFill>
-              </a:defRPr>
-            </a:pPr>
-            <a:r>
-              <a:t>Safety &amp; Driver Assist Features:</a:t>
+                <a:latin typeface="Calibri"/>
+              </a:defRPr>
+            </a:pPr>
+            <a:r>
+              <a:t>Safety &amp; Driver Assistance:</a:t>
             </a:r>
           </a:p>
           <a:p>
             <a:pPr>
               <a:spcAft>
-                <a:spcPts val="1000"/>
+                <a:spcPts val="800"/>
               </a:spcAft>
               <a:defRPr sz="1100">
                 <a:solidFill>
+                  <a:srgbClr val="334155"/>
+                </a:solidFill>
+                <a:latin typeface="Calibri"/>
+              </a:defRPr>
+            </a:pPr>
+            <a:r>
+              <a:t>• All-Wheel Drive (AWD / 4WD) for winter snow &amp; rain control</a:t>
+            </a:r>
+            <a:br/>
+            <a:r>
+              <a:t>• Lane Departure Warning &amp; Blind Spot Warning</a:t>
+            </a:r>
+            <a:br/>
+            <a:r>
+              <a:t>• Automatic Emergency Braking with pedestrian detection</a:t>
+            </a:r>
+            <a:br/>
+            <a:r>
+              <a:t>• Rear Cross-Traffic Alert &amp; advanced airbag protection</a:t>
+            </a:r>
+          </a:p>
+          <a:p>
+            <a:pPr>
+              <a:defRPr b="1" sz="1250">
+                <a:solidFill>
                   <a:srgbClr val="0F172A"/>
                 </a:solidFill>
-              </a:defRPr>
-            </a:pPr>
-            <a:r>
-              <a:t>• All-Wheel Drive (AWD / 4WD) for safe snow and rain driving</a:t>
-            </a:r>
-            <a:br/>
-            <a:r>
-              <a:t>• Nissan Safety Shield 360 with Automatic Emergency Braking</a:t>
-            </a:r>
-            <a:br/>
-            <a:r>
-              <a:t>• Lane Departure Warning &amp; Blind Spot Warning</a:t>
-            </a:r>
-            <a:br/>
-            <a:r>
-              <a:t>• Rear Cross-Traffic Alert &amp; Rear Automatic Braking</a:t>
+                <a:latin typeface="Calibri"/>
+              </a:defRPr>
+            </a:pPr>
+            <a:r>
+              <a:t>Why I Chose This Car:</a:t>
             </a:r>
           </a:p>
           <a:p>
             <a:pPr>
-              <a:defRPr b="1" sz="1300">
-                <a:solidFill>
-                  <a:srgbClr val="0F172A"/>
-                </a:solidFill>
-              </a:defRPr>
-            </a:pPr>
-            <a:r>
-              <a:t>Why I Chose This Car:</a:t>
-            </a:r>
-          </a:p>
-          <a:p>
-            <a:pPr>
-              <a:defRPr sz="1100" i="1">
-                <a:solidFill>
-                  <a:srgbClr val="475569"/>
-                </a:solidFill>
-              </a:defRPr>
-            </a:pPr>
-            <a:r>
-              <a:t>"Has no accident history, car looks immaculate with zero exterior damages, features modern safety tech and AWD for peace of mind, and the $11,376 price point provides exceptional value for a late-model compact SUV."</a:t>
+              <a:defRPr sz="1050" i="1">
+                <a:solidFill>
+                  <a:srgbClr val="64748B"/>
+                </a:solidFill>
+                <a:latin typeface="Calibri"/>
+              </a:defRPr>
+            </a:pPr>
+            <a:r>
+              <a:t>"Has clean history with no accidents, car is in immaculate condition with zero damage, offers modern AWD safety for teenage driving, and the $11,376 price provides tremendous value."</a:t>
             </a:r>
           </a:p>
         </p:txBody>
@@ -4359,7 +4390,7 @@
             <a:avLst/>
           </a:prstGeom>
           <a:solidFill>
-            <a:srgbClr val="F8FAFC"/>
+            <a:srgbClr val="F5F7FA"/>
           </a:solidFill>
           <a:ln>
             <a:noFill/>
@@ -4402,7 +4433,7 @@
             <a:avLst/>
           </a:prstGeom>
           <a:solidFill>
-            <a:srgbClr val="182646"/>
+            <a:srgbClr val="0F172A"/>
           </a:solidFill>
           <a:ln>
             <a:noFill/>
@@ -4438,14 +4469,14 @@
         </p:nvSpPr>
         <p:spPr>
           <a:xfrm>
-            <a:off x="731520" y="182880"/>
-            <a:ext cx="2103120" cy="320040"/>
+            <a:off x="731520" y="164592"/>
+            <a:ext cx="2194560" cy="292608"/>
           </a:xfrm>
           <a:prstGeom prst="roundRect">
             <a:avLst/>
           </a:prstGeom>
           <a:solidFill>
-            <a:srgbClr val="1D4ED8"/>
+            <a:srgbClr val="10B981"/>
           </a:solidFill>
           <a:ln>
             <a:noFill/>
@@ -4466,14 +4497,15 @@
           </a:fontRef>
         </p:style>
         <p:txBody>
-          <a:bodyPr rtlCol="0" anchor="ctr" wrap="square" tIns="18288" bIns="18288"/>
+          <a:bodyPr rtlCol="0" anchor="ctr" wrap="square" tIns="0"/>
           <a:lstStyle/>
           <a:p>
             <a:pPr algn="ctr">
-              <a:defRPr sz="1100" b="1">
+              <a:defRPr sz="1050" b="1">
                 <a:solidFill>
                   <a:srgbClr val="FFFFFF"/>
                 </a:solidFill>
+                <a:latin typeface="Calibri"/>
               </a:defRPr>
             </a:pPr>
             <a:r>
@@ -4490,8 +4522,8 @@
         </p:nvSpPr>
         <p:spPr>
           <a:xfrm>
-            <a:off x="731520" y="530352"/>
-            <a:ext cx="8686800" cy="457200"/>
+            <a:off x="731520" y="502920"/>
+            <a:ext cx="8229600" cy="502920"/>
           </a:xfrm>
           <a:prstGeom prst="rect">
             <a:avLst/>
@@ -4505,10 +4537,11 @@
           <a:lstStyle/>
           <a:p>
             <a:pPr>
-              <a:defRPr sz="2000" b="1">
+              <a:defRPr sz="2100" b="1">
                 <a:solidFill>
                   <a:srgbClr val="FFFFFF"/>
                 </a:solidFill>
+                <a:latin typeface="Calibri"/>
               </a:defRPr>
             </a:pPr>
             <a:r>
@@ -4525,7 +4558,7 @@
         </p:nvSpPr>
         <p:spPr>
           <a:xfrm>
-            <a:off x="7772400" y="228600"/>
+            <a:off x="7772400" y="182880"/>
             <a:ext cx="3657600" cy="685800"/>
           </a:xfrm>
           <a:prstGeom prst="rect">
@@ -4540,10 +4573,11 @@
           <a:lstStyle/>
           <a:p>
             <a:pPr algn="r">
-              <a:defRPr sz="1200">
+              <a:defRPr sz="1100">
                 <a:solidFill>
                   <a:srgbClr val="94A3B8"/>
                 </a:solidFill>
+                <a:latin typeface="Calibri"/>
               </a:defRPr>
             </a:pPr>
             <a:r>
@@ -4552,14 +4586,15 @@
           </a:p>
           <a:p>
             <a:pPr algn="r">
-              <a:defRPr sz="1100" b="1">
+              <a:defRPr sz="1200" b="1">
                 <a:solidFill>
                   <a:srgbClr val="E2E8F0"/>
                 </a:solidFill>
-              </a:defRPr>
-            </a:pPr>
-            <a:r>
-              <a:t>Student: Rehan Mangar  |  Slide 3 of 6</a:t>
+                <a:latin typeface="Calibri"/>
+              </a:defRPr>
+            </a:pPr>
+            <a:r>
+              <a:t>Student: Rehan Mangar  •  Slide 3 of 6</a:t>
             </a:r>
           </a:p>
         </p:txBody>
@@ -4572,8 +4607,8 @@
         </p:nvSpPr>
         <p:spPr>
           <a:xfrm>
-            <a:off x="731520" y="1280160"/>
-            <a:ext cx="5120640" cy="3931920"/>
+            <a:off x="731520" y="1234440"/>
+            <a:ext cx="4114800" cy="3840480"/>
           </a:xfrm>
           <a:prstGeom prst="roundRect">
             <a:avLst/>
@@ -4602,33 +4637,35 @@
           </a:fontRef>
         </p:style>
         <p:txBody>
-          <a:bodyPr rtlCol="0" anchor="ctr" lIns="274320" rIns="274320" tIns="228600"/>
+          <a:bodyPr rtlCol="0" anchor="ctr" lIns="256032" rIns="256032" tIns="201168"/>
           <a:lstStyle/>
           <a:p>
             <a:pPr algn="ctr">
-              <a:defRPr sz="1200" b="1">
+              <a:defRPr sz="1100" b="1">
                 <a:solidFill>
                   <a:srgbClr val="10B981"/>
                 </a:solidFill>
-              </a:defRPr>
-            </a:pPr>
-            <a:r>
-              <a:t>LOAN A: SIMPLE INTEREST (PARENTS)</a:t>
+                <a:latin typeface="Calibri"/>
+              </a:defRPr>
+            </a:pPr>
+            <a:r>
+              <a:t>LOAN A: PARENTS (SIMPLE INTEREST)</a:t>
             </a:r>
           </a:p>
           <a:p>
             <a:pPr>
               <a:spcAft>
-                <a:spcPts val="800"/>
+                <a:spcPts val="600"/>
               </a:spcAft>
-              <a:defRPr sz="2600" b="1">
+              <a:defRPr sz="2400" b="1">
                 <a:solidFill>
                   <a:srgbClr val="0F172A"/>
                 </a:solidFill>
-              </a:defRPr>
-            </a:pPr>
-            <a:r>
-              <a:t>$229.42 / month</a:t>
+                <a:latin typeface="Calibri"/>
+              </a:defRPr>
+            </a:pPr>
+            <a:r>
+              <a:t>$229.42 / mo</a:t>
             </a:r>
           </a:p>
           <a:p>
@@ -4636,22 +4673,24 @@
               <a:spcAft>
                 <a:spcPts val="400"/>
               </a:spcAft>
-              <a:defRPr b="1" sz="1150">
+              <a:defRPr b="1" sz="1100">
                 <a:solidFill>
                   <a:srgbClr val="0F172A"/>
                 </a:solidFill>
-              </a:defRPr>
-            </a:pPr>
-            <a:r>
-              <a:t>Loan Terms: </a:t>
+                <a:latin typeface="Calibri"/>
+              </a:defRPr>
+            </a:pPr>
+            <a:r>
+              <a:t>• Terms: </a:t>
             </a:r>
             <a:r>
               <a:rPr b="0">
                 <a:solidFill>
-                  <a:srgbClr val="0F172A"/>
-                </a:solidFill>
+                  <a:srgbClr val="334155"/>
+                </a:solidFill>
+                <a:latin typeface="Calibri"/>
               </a:rPr>
-              <a:t>4.2% Simple Interest / 5 Years (60 Months)</a:t>
+              <a:t>4.2% Simple Interest / 5 Yrs (60 Mos)</a:t>
             </a:r>
           </a:p>
           <a:p>
@@ -4659,22 +4698,24 @@
               <a:spcAft>
                 <a:spcPts val="400"/>
               </a:spcAft>
-              <a:defRPr b="1" sz="1150">
+              <a:defRPr b="1" sz="1100">
                 <a:solidFill>
                   <a:srgbClr val="0F172A"/>
                 </a:solidFill>
-              </a:defRPr>
-            </a:pPr>
-            <a:r>
-              <a:t>Interest Formula: </a:t>
-            </a:r>
-            <a:r>
-              <a:rPr b="0">
-                <a:solidFill>
-                  <a:srgbClr val="0F172A"/>
-                </a:solidFill>
+                <a:latin typeface="Calibri"/>
+              </a:defRPr>
+            </a:pPr>
+            <a:r>
+              <a:t>• Interest Paid: </a:t>
+            </a:r>
+            <a:r>
+              <a:rPr b="1">
+                <a:solidFill>
+                  <a:srgbClr val="10B981"/>
+                </a:solidFill>
+                <a:latin typeface="Calibri"/>
               </a:rPr>
-              <a:t>I = P × r × t = $11,376 × 0.042 × 5</a:t>
+              <a:t>$2,388.96  (Saves $1,683.12!)</a:t>
             </a:r>
           </a:p>
           <a:p>
@@ -4682,22 +4723,24 @@
               <a:spcAft>
                 <a:spcPts val="400"/>
               </a:spcAft>
-              <a:defRPr b="1" sz="1150">
+              <a:defRPr b="1" sz="1100">
                 <a:solidFill>
                   <a:srgbClr val="0F172A"/>
                 </a:solidFill>
-              </a:defRPr>
-            </a:pPr>
-            <a:r>
-              <a:t>Total Interest Paid: </a:t>
-            </a:r>
-            <a:r>
-              <a:rPr b="1">
-                <a:solidFill>
-                  <a:srgbClr val="10B981"/>
-                </a:solidFill>
+                <a:latin typeface="Calibri"/>
+              </a:defRPr>
+            </a:pPr>
+            <a:r>
+              <a:t>• Total Repayment: </a:t>
+            </a:r>
+            <a:r>
+              <a:rPr b="0">
+                <a:solidFill>
+                  <a:srgbClr val="334155"/>
+                </a:solidFill>
+                <a:latin typeface="Calibri"/>
               </a:rPr>
-              <a:t>$2,388.96  (Saves $1,683.12 vs Bank!)</a:t>
+              <a:t>$11,376 + $2,388.96 = $13,764.96</a:t>
             </a:r>
           </a:p>
           <a:p>
@@ -4705,45 +4748,24 @@
               <a:spcAft>
                 <a:spcPts val="400"/>
               </a:spcAft>
-              <a:defRPr b="1" sz="1150">
+              <a:defRPr b="1" sz="1100">
                 <a:solidFill>
                   <a:srgbClr val="0F172A"/>
                 </a:solidFill>
-              </a:defRPr>
-            </a:pPr>
-            <a:r>
-              <a:t>Total Cost with Interest: </a:t>
-            </a:r>
-            <a:r>
-              <a:rPr b="0">
-                <a:solidFill>
-                  <a:srgbClr val="0F172A"/>
-                </a:solidFill>
+                <a:latin typeface="Calibri"/>
+              </a:defRPr>
+            </a:pPr>
+            <a:r>
+              <a:t>• Monthly Payment: </a:t>
+            </a:r>
+            <a:r>
+              <a:rPr b="1">
+                <a:solidFill>
+                  <a:srgbClr val="334155"/>
+                </a:solidFill>
+                <a:latin typeface="Calibri"/>
               </a:rPr>
-              <a:t>$11,376 + $2,388.96 = $13,764.96</a:t>
-            </a:r>
-          </a:p>
-          <a:p>
-            <a:pPr>
-              <a:spcAft>
-                <a:spcPts val="400"/>
-              </a:spcAft>
-              <a:defRPr b="1" sz="1150">
-                <a:solidFill>
-                  <a:srgbClr val="0F172A"/>
-                </a:solidFill>
-              </a:defRPr>
-            </a:pPr>
-            <a:r>
-              <a:t>Monthly Payment Formula: </a:t>
-            </a:r>
-            <a:r>
-              <a:rPr b="1">
-                <a:solidFill>
-                  <a:srgbClr val="0F172A"/>
-                </a:solidFill>
-              </a:rPr>
-              <a:t>$13,764.96 ÷ 60 months = $229.42 / mo</a:t>
+              <a:t>$13,764.96 ÷ 60 = $229.42 / month</a:t>
             </a:r>
           </a:p>
         </p:txBody>
@@ -4756,8 +4778,8 @@
         </p:nvSpPr>
         <p:spPr>
           <a:xfrm>
-            <a:off x="6217920" y="1280160"/>
-            <a:ext cx="5212080" cy="3931920"/>
+            <a:off x="5029200" y="1234440"/>
+            <a:ext cx="4114800" cy="3840480"/>
           </a:xfrm>
           <a:prstGeom prst="roundRect">
             <a:avLst/>
@@ -4786,33 +4808,35 @@
           </a:fontRef>
         </p:style>
         <p:txBody>
-          <a:bodyPr rtlCol="0" anchor="ctr" lIns="274320" rIns="274320" tIns="228600"/>
+          <a:bodyPr rtlCol="0" anchor="ctr" lIns="256032" rIns="256032" tIns="201168"/>
           <a:lstStyle/>
           <a:p>
             <a:pPr algn="ctr">
-              <a:defRPr sz="1200" b="1">
+              <a:defRPr sz="1100" b="1">
                 <a:solidFill>
                   <a:srgbClr val="1D4ED8"/>
                 </a:solidFill>
-              </a:defRPr>
-            </a:pPr>
-            <a:r>
-              <a:t>LOAN B: COMPOUND INTEREST (BANK)</a:t>
+                <a:latin typeface="Calibri"/>
+              </a:defRPr>
+            </a:pPr>
+            <a:r>
+              <a:t>LOAN B: BANK (COMPOUND INTEREST)</a:t>
             </a:r>
           </a:p>
           <a:p>
             <a:pPr>
               <a:spcAft>
-                <a:spcPts val="800"/>
+                <a:spcPts val="600"/>
               </a:spcAft>
-              <a:defRPr sz="2600" b="1">
+              <a:defRPr sz="2400" b="1">
                 <a:solidFill>
                   <a:srgbClr val="0F172A"/>
                 </a:solidFill>
-              </a:defRPr>
-            </a:pPr>
-            <a:r>
-              <a:t>$214.56 / month</a:t>
+                <a:latin typeface="Calibri"/>
+              </a:defRPr>
+            </a:pPr>
+            <a:r>
+              <a:t>$214.56 / mo</a:t>
             </a:r>
           </a:p>
           <a:p>
@@ -4820,22 +4844,24 @@
               <a:spcAft>
                 <a:spcPts val="400"/>
               </a:spcAft>
-              <a:defRPr b="1" sz="1150">
+              <a:defRPr b="1" sz="1100">
                 <a:solidFill>
                   <a:srgbClr val="0F172A"/>
                 </a:solidFill>
-              </a:defRPr>
-            </a:pPr>
-            <a:r>
-              <a:t>Loan Terms: </a:t>
+                <a:latin typeface="Calibri"/>
+              </a:defRPr>
+            </a:pPr>
+            <a:r>
+              <a:t>• Terms: </a:t>
             </a:r>
             <a:r>
               <a:rPr>
                 <a:solidFill>
-                  <a:srgbClr val="0F172A"/>
-                </a:solidFill>
+                  <a:srgbClr val="334155"/>
+                </a:solidFill>
+                <a:latin typeface="Calibri"/>
               </a:rPr>
-              <a:t>5.1% Compounded Daily (365) / 6 Years (72 Mos)</a:t>
+              <a:t>5.1% Daily Compound (365) / 6 Yrs (72 Mos)</a:t>
             </a:r>
           </a:p>
           <a:p>
@@ -4843,22 +4869,24 @@
               <a:spcAft>
                 <a:spcPts val="400"/>
               </a:spcAft>
-              <a:defRPr b="1" sz="1150">
+              <a:defRPr b="1" sz="1100">
                 <a:solidFill>
                   <a:srgbClr val="0F172A"/>
                 </a:solidFill>
-              </a:defRPr>
-            </a:pPr>
-            <a:r>
-              <a:t>Compound Formula: </a:t>
+                <a:latin typeface="Calibri"/>
+              </a:defRPr>
+            </a:pPr>
+            <a:r>
+              <a:t>• Interest Paid: </a:t>
             </a:r>
             <a:r>
               <a:rPr>
                 <a:solidFill>
-                  <a:srgbClr val="0F172A"/>
-                </a:solidFill>
+                  <a:srgbClr val="DC2626"/>
+                </a:solidFill>
+                <a:latin typeface="Calibri"/>
               </a:rPr>
-              <a:t>A = P(1 + r/n)^(nt) = 11,376(1 + 0.051/365)^(2190)</a:t>
+              <a:t>$4,072.08  (+$1,683.12 more interest)</a:t>
             </a:r>
           </a:p>
           <a:p>
@@ -4866,22 +4894,24 @@
               <a:spcAft>
                 <a:spcPts val="400"/>
               </a:spcAft>
-              <a:defRPr b="1" sz="1150">
+              <a:defRPr b="1" sz="1100">
                 <a:solidFill>
                   <a:srgbClr val="0F172A"/>
                 </a:solidFill>
-              </a:defRPr>
-            </a:pPr>
-            <a:r>
-              <a:t>Total Amount Repaid: </a:t>
+                <a:latin typeface="Calibri"/>
+              </a:defRPr>
+            </a:pPr>
+            <a:r>
+              <a:t>• Total Repayment: </a:t>
             </a:r>
             <a:r>
               <a:rPr>
                 <a:solidFill>
-                  <a:srgbClr val="0F172A"/>
-                </a:solidFill>
+                  <a:srgbClr val="334155"/>
+                </a:solidFill>
+                <a:latin typeface="Calibri"/>
               </a:rPr>
-              <a:t>$15,448.08</a:t>
+              <a:t>$15,448.08 (11,376 × (1 + 0.051/365)^2190)</a:t>
             </a:r>
           </a:p>
           <a:p>
@@ -4889,45 +4919,24 @@
               <a:spcAft>
                 <a:spcPts val="400"/>
               </a:spcAft>
-              <a:defRPr b="1" sz="1150">
+              <a:defRPr b="1" sz="1100">
                 <a:solidFill>
                   <a:srgbClr val="0F172A"/>
                 </a:solidFill>
-              </a:defRPr>
-            </a:pPr>
-            <a:r>
-              <a:t>Total Interest Paid: </a:t>
+                <a:latin typeface="Calibri"/>
+              </a:defRPr>
+            </a:pPr>
+            <a:r>
+              <a:t>• Monthly Payment: </a:t>
             </a:r>
             <a:r>
               <a:rPr>
                 <a:solidFill>
-                  <a:srgbClr val="DC2626"/>
-                </a:solidFill>
+                  <a:srgbClr val="334155"/>
+                </a:solidFill>
+                <a:latin typeface="Calibri"/>
               </a:rPr>
-              <a:t>$15,448.08 - $11,376 = $4,072.08</a:t>
-            </a:r>
-          </a:p>
-          <a:p>
-            <a:pPr>
-              <a:spcAft>
-                <a:spcPts val="400"/>
-              </a:spcAft>
-              <a:defRPr b="1" sz="1150">
-                <a:solidFill>
-                  <a:srgbClr val="0F172A"/>
-                </a:solidFill>
-              </a:defRPr>
-            </a:pPr>
-            <a:r>
-              <a:t>Monthly Payment Formula: </a:t>
-            </a:r>
-            <a:r>
-              <a:rPr>
-                <a:solidFill>
-                  <a:srgbClr val="0F172A"/>
-                </a:solidFill>
-              </a:rPr>
-              <a:t>$15,448.08 ÷ 72 months = $214.56 / mo</a:t>
+              <a:t>$15,448.08 ÷ 72 = $214.56 / month</a:t>
             </a:r>
           </a:p>
         </p:txBody>
@@ -4940,8 +4949,100 @@
         </p:nvSpPr>
         <p:spPr>
           <a:xfrm>
-            <a:off x="731520" y="5394960"/>
-            <a:ext cx="10698480" cy="1188720"/>
+            <a:off x="9326880" y="1234440"/>
+            <a:ext cx="2148840" cy="3840480"/>
+          </a:xfrm>
+          <a:prstGeom prst="roundRect">
+            <a:avLst/>
+          </a:prstGeom>
+          <a:solidFill>
+            <a:srgbClr val="FFFFFF"/>
+          </a:solidFill>
+          <a:ln w="19050">
+            <a:solidFill>
+              <a:srgbClr val="E2E8F0"/>
+            </a:solidFill>
+          </a:ln>
+        </p:spPr>
+        <p:style>
+          <a:lnRef idx="1">
+            <a:schemeClr val="accent1"/>
+          </a:lnRef>
+          <a:fillRef idx="3">
+            <a:schemeClr val="accent1"/>
+          </a:fillRef>
+          <a:effectRef idx="2">
+            <a:schemeClr val="accent1"/>
+          </a:effectRef>
+          <a:fontRef idx="minor">
+            <a:schemeClr val="lt1"/>
+          </a:fontRef>
+        </p:style>
+        <p:txBody>
+          <a:bodyPr rtlCol="0" anchor="ctr" tIns="2651760" lIns="137160" rIns="137160"/>
+          <a:lstStyle/>
+          <a:p>
+            <a:pPr algn="ctr">
+              <a:defRPr b="1" sz="1050">
+                <a:solidFill>
+                  <a:srgbClr val="0F172A"/>
+                </a:solidFill>
+                <a:latin typeface="Calibri"/>
+              </a:defRPr>
+            </a:pPr>
+            <a:r>
+              <a:t>Financial Wisdom:</a:t>
+            </a:r>
+          </a:p>
+          <a:p>
+            <a:pPr>
+              <a:defRPr sz="950">
+                <a:solidFill>
+                  <a:srgbClr val="64748B"/>
+                </a:solidFill>
+                <a:latin typeface="Calibri"/>
+              </a:defRPr>
+            </a:pPr>
+            <a:r>
+              <a:t>Simple interest with shorter term saves significant money over long compounding.</a:t>
+            </a:r>
+          </a:p>
+        </p:txBody>
+      </p:sp>
+      <p:pic>
+        <p:nvPicPr>
+          <p:cNvPr id="10" name="Picture 9" descr="financing_calculator.jpg"/>
+          <p:cNvPicPr>
+            <a:picLocks noChangeAspect="1"/>
+          </p:cNvPicPr>
+          <p:nvPr/>
+        </p:nvPicPr>
+        <p:blipFill>
+          <a:blip r:embed="rId2"/>
+          <a:stretch>
+            <a:fillRect/>
+          </a:stretch>
+        </p:blipFill>
+        <p:spPr>
+          <a:xfrm>
+            <a:off x="9464040" y="1417320"/>
+            <a:ext cx="1874519" cy="2377440"/>
+          </a:xfrm>
+          <a:prstGeom prst="rect">
+            <a:avLst/>
+          </a:prstGeom>
+        </p:spPr>
+      </p:pic>
+      <p:sp>
+        <p:nvSpPr>
+          <p:cNvPr id="11" name="Rounded Rectangle 10"/>
+          <p:cNvSpPr/>
+          <p:nvPr/>
+        </p:nvSpPr>
+        <p:spPr>
+          <a:xfrm>
+            <a:off x="731520" y="5257800"/>
+            <a:ext cx="10744200" cy="1280160"/>
           </a:xfrm>
           <a:prstGeom prst="roundRect">
             <a:avLst/>
@@ -4970,38 +5071,40 @@
           </a:fontRef>
         </p:style>
         <p:txBody>
-          <a:bodyPr rtlCol="0" anchor="ctr" lIns="274320" rIns="274320" tIns="109728"/>
+          <a:bodyPr rtlCol="0" anchor="ctr" lIns="274320" rIns="274320" tIns="137160"/>
           <a:lstStyle/>
           <a:p>
             <a:pPr algn="ctr">
-              <a:defRPr sz="1300" b="1">
+              <a:defRPr sz="1250" b="1">
                 <a:solidFill>
                   <a:srgbClr val="065F46"/>
                 </a:solidFill>
-              </a:defRPr>
-            </a:pPr>
-            <a:r>
-              <a:t>WHICH LOAN WOULD YOU CHOOSE?  —  RECOMMENDATION: LOAN A (PARENTS)</a:t>
+                <a:latin typeface="Calibri"/>
+              </a:defRPr>
+            </a:pPr>
+            <a:r>
+              <a:t>WHICH LOAN WOULD YOU CHOOSE?  —  FINAL DECISION: LOAN A (PARENTS)</a:t>
             </a:r>
           </a:p>
           <a:p>
             <a:pPr>
               <a:defRPr sz="1100">
                 <a:solidFill>
-                  <a:srgbClr val="064E3B"/>
-                </a:solidFill>
-              </a:defRPr>
-            </a:pPr>
-            <a:r>
-              <a:t>• Lowest Monthly Payment: Loan B is lower by $14.86/month ($214.56 vs $229.42).</a:t>
+                  <a:srgbClr val="065F46"/>
+                </a:solidFill>
+                <a:latin typeface="Calibri"/>
+              </a:defRPr>
+            </a:pPr>
+            <a:r>
+              <a:t>• Lowest Monthly Payment: Loan B ($214.56/mo vs. $229.42/mo — lower by $14.86/mo).</a:t>
             </a:r>
             <a:br/>
             <a:r>
-              <a:t>• Lowest Total Interest Paid: Loan A saves $1,683.12 in interest ($2,388.96 vs $4,072.08).</a:t>
+              <a:t>• Lowest Total Interest: Loan A ($2,388.96 vs. $4,072.08 — saves $1,683.12 in interest).</a:t>
             </a:r>
             <a:br/>
             <a:r>
-              <a:t>• Conclusion: I choose Loan A. Paying an extra $14.86/month saves $1,683.12 and clears the debt 1 full year earlier.</a:t>
+              <a:t>• Reasoning: I choose Loan A. Paying $14.86 more per month saves $1,683.12 and clears the debt a full 12 months earlier.</a:t>
             </a:r>
           </a:p>
         </p:txBody>
@@ -5039,7 +5142,7 @@
             <a:avLst/>
           </a:prstGeom>
           <a:solidFill>
-            <a:srgbClr val="F8FAFC"/>
+            <a:srgbClr val="F5F7FA"/>
           </a:solidFill>
           <a:ln>
             <a:noFill/>
@@ -5082,7 +5185,7 @@
             <a:avLst/>
           </a:prstGeom>
           <a:solidFill>
-            <a:srgbClr val="182646"/>
+            <a:srgbClr val="0F172A"/>
           </a:solidFill>
           <a:ln>
             <a:noFill/>
@@ -5118,8 +5221,8 @@
         </p:nvSpPr>
         <p:spPr>
           <a:xfrm>
-            <a:off x="731520" y="182880"/>
-            <a:ext cx="2103120" cy="320040"/>
+            <a:off x="731520" y="164592"/>
+            <a:ext cx="2194560" cy="292608"/>
           </a:xfrm>
           <a:prstGeom prst="roundRect">
             <a:avLst/>
@@ -5146,14 +5249,15 @@
           </a:fontRef>
         </p:style>
         <p:txBody>
-          <a:bodyPr rtlCol="0" anchor="ctr" wrap="square" tIns="18288" bIns="18288"/>
+          <a:bodyPr rtlCol="0" anchor="ctr" wrap="square" tIns="0"/>
           <a:lstStyle/>
           <a:p>
             <a:pPr algn="ctr">
-              <a:defRPr sz="1100" b="1">
+              <a:defRPr sz="1050" b="1">
                 <a:solidFill>
                   <a:srgbClr val="FFFFFF"/>
                 </a:solidFill>
+                <a:latin typeface="Calibri"/>
               </a:defRPr>
             </a:pPr>
             <a:r>
@@ -5170,8 +5274,8 @@
         </p:nvSpPr>
         <p:spPr>
           <a:xfrm>
-            <a:off x="731520" y="530352"/>
-            <a:ext cx="8686800" cy="457200"/>
+            <a:off x="731520" y="502920"/>
+            <a:ext cx="8229600" cy="502920"/>
           </a:xfrm>
           <a:prstGeom prst="rect">
             <a:avLst/>
@@ -5185,10 +5289,11 @@
           <a:lstStyle/>
           <a:p>
             <a:pPr>
-              <a:defRPr sz="2000" b="1">
+              <a:defRPr sz="2100" b="1">
                 <a:solidFill>
                   <a:srgbClr val="FFFFFF"/>
                 </a:solidFill>
+                <a:latin typeface="Calibri"/>
               </a:defRPr>
             </a:pPr>
             <a:r>
@@ -5205,7 +5310,7 @@
         </p:nvSpPr>
         <p:spPr>
           <a:xfrm>
-            <a:off x="7772400" y="228600"/>
+            <a:off x="7772400" y="182880"/>
             <a:ext cx="3657600" cy="685800"/>
           </a:xfrm>
           <a:prstGeom prst="rect">
@@ -5220,10 +5325,11 @@
           <a:lstStyle/>
           <a:p>
             <a:pPr algn="r">
-              <a:defRPr sz="1200">
+              <a:defRPr sz="1100">
                 <a:solidFill>
                   <a:srgbClr val="94A3B8"/>
                 </a:solidFill>
+                <a:latin typeface="Calibri"/>
               </a:defRPr>
             </a:pPr>
             <a:r>
@@ -5232,14 +5338,15 @@
           </a:p>
           <a:p>
             <a:pPr algn="r">
-              <a:defRPr sz="1100" b="1">
+              <a:defRPr sz="1200" b="1">
                 <a:solidFill>
                   <a:srgbClr val="E2E8F0"/>
                 </a:solidFill>
-              </a:defRPr>
-            </a:pPr>
-            <a:r>
-              <a:t>Student: Rehan Mangar  |  Slide 4 of 6</a:t>
+                <a:latin typeface="Calibri"/>
+              </a:defRPr>
+            </a:pPr>
+            <a:r>
+              <a:t>Student: Rehan Mangar  •  Slide 4 of 6</a:t>
             </a:r>
           </a:p>
         </p:txBody>
@@ -5252,8 +5359,8 @@
         </p:nvSpPr>
         <p:spPr>
           <a:xfrm>
-            <a:off x="731520" y="1280160"/>
-            <a:ext cx="5029200" cy="5120640"/>
+            <a:off x="731520" y="1234440"/>
+            <a:ext cx="5029200" cy="5212080"/>
           </a:xfrm>
           <a:prstGeom prst="roundRect">
             <a:avLst/>
@@ -5261,7 +5368,7 @@
           <a:solidFill>
             <a:srgbClr val="FFFFFF"/>
           </a:solidFill>
-          <a:ln>
+          <a:ln w="19050">
             <a:solidFill>
               <a:srgbClr val="E2E8F0"/>
             </a:solidFill>
@@ -5305,8 +5412,8 @@
         </p:blipFill>
         <p:spPr>
           <a:xfrm>
-            <a:off x="914400" y="1463040"/>
-            <a:ext cx="4663440" cy="2926080"/>
+            <a:off x="960120" y="1463040"/>
+            <a:ext cx="4572000" cy="2880360"/>
           </a:xfrm>
           <a:prstGeom prst="rect">
             <a:avLst/>
@@ -5321,8 +5428,8 @@
         </p:nvSpPr>
         <p:spPr>
           <a:xfrm>
-            <a:off x="914400" y="4617720"/>
-            <a:ext cx="2240280" cy="1554480"/>
+            <a:off x="960120" y="4526280"/>
+            <a:ext cx="2194560" cy="1645920"/>
           </a:xfrm>
           <a:prstGeom prst="roundRect">
             <a:avLst/>
@@ -5351,7 +5458,7 @@
           </a:fontRef>
         </p:style>
         <p:txBody>
-          <a:bodyPr rtlCol="0" anchor="ctr" tIns="137160"/>
+          <a:bodyPr rtlCol="0" anchor="ctr" tIns="164592"/>
           <a:lstStyle/>
           <a:p>
             <a:pPr algn="ctr">
@@ -5359,6 +5466,7 @@
                 <a:solidFill>
                   <a:srgbClr val="1D4ED8"/>
                 </a:solidFill>
+                <a:latin typeface="Calibri"/>
               </a:defRPr>
             </a:pPr>
             <a:r>
@@ -5371,6 +5479,7 @@
                 <a:solidFill>
                   <a:srgbClr val="0F172A"/>
                 </a:solidFill>
+                <a:latin typeface="Calibri"/>
               </a:defRPr>
             </a:pPr>
             <a:r>
@@ -5383,10 +5492,11 @@
                 <a:solidFill>
                   <a:srgbClr val="64748B"/>
                 </a:solidFill>
-              </a:defRPr>
-            </a:pPr>
-            <a:r>
-              <a:t>Well under $20K budget</a:t>
+                <a:latin typeface="Calibri"/>
+              </a:defRPr>
+            </a:pPr>
+            <a:r>
+              <a:t>Under $20K budget limit</a:t>
             </a:r>
           </a:p>
         </p:txBody>
@@ -5399,8 +5509,8 @@
         </p:nvSpPr>
         <p:spPr>
           <a:xfrm>
-            <a:off x="3337560" y="4617720"/>
-            <a:ext cx="2240280" cy="1554480"/>
+            <a:off x="3337560" y="4526280"/>
+            <a:ext cx="2194560" cy="1645920"/>
           </a:xfrm>
           <a:prstGeom prst="roundRect">
             <a:avLst/>
@@ -5429,7 +5539,7 @@
           </a:fontRef>
         </p:style>
         <p:txBody>
-          <a:bodyPr rtlCol="0" anchor="ctr" tIns="137160"/>
+          <a:bodyPr rtlCol="0" anchor="ctr" tIns="164592"/>
           <a:lstStyle/>
           <a:p>
             <a:pPr algn="ctr">
@@ -5437,6 +5547,7 @@
                 <a:solidFill>
                   <a:srgbClr val="D97706"/>
                 </a:solidFill>
+                <a:latin typeface="Calibri"/>
               </a:defRPr>
             </a:pPr>
             <a:r>
@@ -5449,6 +5560,7 @@
                 <a:solidFill>
                   <a:srgbClr val="0F172A"/>
                 </a:solidFill>
+                <a:latin typeface="Calibri"/>
               </a:defRPr>
             </a:pPr>
             <a:r>
@@ -5461,10 +5573,11 @@
                 <a:solidFill>
                   <a:srgbClr val="64748B"/>
                 </a:solidFill>
-              </a:defRPr>
-            </a:pPr>
-            <a:r>
-              <a:t>13.2 Gal × $3.89/gal</a:t>
+                <a:latin typeface="Calibri"/>
+              </a:defRPr>
+            </a:pPr>
+            <a:r>
+              <a:t>13.2 Gallons × $3.89/gal</a:t>
             </a:r>
           </a:p>
         </p:txBody>
@@ -5477,8 +5590,8 @@
         </p:nvSpPr>
         <p:spPr>
           <a:xfrm>
-            <a:off x="6035040" y="1280160"/>
-            <a:ext cx="5394960" cy="5120640"/>
+            <a:off x="5989320" y="1234440"/>
+            <a:ext cx="5486400" cy="5212080"/>
           </a:xfrm>
           <a:prstGeom prst="roundRect">
             <a:avLst/>
@@ -5486,7 +5599,7 @@
           <a:solidFill>
             <a:srgbClr val="FFFFFF"/>
           </a:solidFill>
-          <a:ln>
+          <a:ln w="19050">
             <a:solidFill>
               <a:srgbClr val="E2E8F0"/>
             </a:solidFill>
@@ -5507,14 +5620,15 @@
           </a:fontRef>
         </p:style>
         <p:txBody>
-          <a:bodyPr rtlCol="0" anchor="ctr" lIns="320040" rIns="320040" tIns="274320"/>
+          <a:bodyPr rtlCol="0" anchor="ctr" lIns="320040" rIns="320040" tIns="256032"/>
           <a:lstStyle/>
           <a:p>
             <a:pPr algn="ctr">
-              <a:defRPr sz="1200" b="1">
+              <a:defRPr sz="1150" b="1">
                 <a:solidFill>
                   <a:srgbClr val="1D4ED8"/>
                 </a:solidFill>
+                <a:latin typeface="Calibri"/>
               </a:defRPr>
             </a:pPr>
             <a:r>
@@ -5524,12 +5638,13 @@
           <a:p>
             <a:pPr>
               <a:spcAft>
-                <a:spcPts val="1000"/>
+                <a:spcPts val="800"/>
               </a:spcAft>
               <a:defRPr sz="1800" b="1">
                 <a:solidFill>
                   <a:srgbClr val="0F172A"/>
                 </a:solidFill>
+                <a:latin typeface="Calibri"/>
               </a:defRPr>
             </a:pPr>
             <a:r>
@@ -5538,10 +5653,11 @@
           </a:p>
           <a:p>
             <a:pPr>
-              <a:defRPr b="1" sz="1300">
+              <a:defRPr b="1" sz="1250">
                 <a:solidFill>
                   <a:srgbClr val="0F172A"/>
                 </a:solidFill>
+                <a:latin typeface="Calibri"/>
               </a:defRPr>
             </a:pPr>
             <a:r>
@@ -5551,91 +5667,96 @@
           <a:p>
             <a:pPr>
               <a:spcAft>
-                <a:spcPts val="1000"/>
+                <a:spcPts val="800"/>
               </a:spcAft>
               <a:defRPr sz="1100">
                 <a:solidFill>
+                  <a:srgbClr val="334155"/>
+                </a:solidFill>
+                <a:latin typeface="Calibri"/>
+              </a:defRPr>
+            </a:pPr>
+            <a:r>
+              <a:t>• Apple CarPlay, Android Auto &amp; Amazon Alexa compatibility</a:t>
+            </a:r>
+            <a:br/>
+            <a:r>
+              <a:t>• 8-inch high-resolution touchscreen infotainment system</a:t>
+            </a:r>
+            <a:br/>
+            <a:r>
+              <a:t>• Integrated backup camera with path guidelines</a:t>
+            </a:r>
+            <a:br/>
+            <a:r>
+              <a:t>• Remote keyless entry &amp; Bluetooth hands-free connectivity</a:t>
+            </a:r>
+          </a:p>
+          <a:p>
+            <a:pPr>
+              <a:defRPr b="1" sz="1250">
+                <a:solidFill>
                   <a:srgbClr val="0F172A"/>
                 </a:solidFill>
-              </a:defRPr>
-            </a:pPr>
-            <a:r>
-              <a:t>• Apple CarPlay, Android Auto &amp; Amazon Alexa compatibility</a:t>
-            </a:r>
-            <a:br/>
-            <a:r>
-              <a:t>• 8-inch high-resolution touchscreen with 6-speaker audio</a:t>
-            </a:r>
-            <a:br/>
-            <a:r>
-              <a:t>• Integrated backup camera with projected path</a:t>
-            </a:r>
-            <a:br/>
-            <a:r>
-              <a:t>• Remote keyless entry with trunk release</a:t>
-            </a:r>
-          </a:p>
-          <a:p>
-            <a:pPr>
-              <a:defRPr b="1" sz="1300">
-                <a:solidFill>
-                  <a:srgbClr val="0F172A"/>
-                </a:solidFill>
-              </a:defRPr>
-            </a:pPr>
-            <a:r>
-              <a:t>Safety &amp; Driver Assist Features:</a:t>
+                <a:latin typeface="Calibri"/>
+              </a:defRPr>
+            </a:pPr>
+            <a:r>
+              <a:t>Safety &amp; Driver Assistance:</a:t>
             </a:r>
           </a:p>
           <a:p>
             <a:pPr>
               <a:spcAft>
-                <a:spcPts val="1000"/>
+                <a:spcPts val="800"/>
               </a:spcAft>
               <a:defRPr sz="1100">
                 <a:solidFill>
+                  <a:srgbClr val="334155"/>
+                </a:solidFill>
+                <a:latin typeface="Calibri"/>
+              </a:defRPr>
+            </a:pPr>
+            <a:r>
+              <a:t>• Toyota Safety Sense 2.0 with Pre-Collision System</a:t>
+            </a:r>
+            <a:br/>
+            <a:r>
+              <a:t>• Lane Departure Alert with Steering Assist &amp; Lane Tracing</a:t>
+            </a:r>
+            <a:br/>
+            <a:r>
+              <a:t>• Full-Speed Dynamic Radar Cruise Control &amp; Road Sign Assist</a:t>
+            </a:r>
+            <a:br/>
+            <a:r>
+              <a:t>• 10 advanced airbags &amp; Star Safety System</a:t>
+            </a:r>
+          </a:p>
+          <a:p>
+            <a:pPr>
+              <a:defRPr b="1" sz="1250">
+                <a:solidFill>
                   <a:srgbClr val="0F172A"/>
                 </a:solidFill>
-              </a:defRPr>
-            </a:pPr>
-            <a:r>
-              <a:t>• Toyota Safety Sense 2.0 with Pre-Collision System</a:t>
-            </a:r>
-            <a:br/>
-            <a:r>
-              <a:t>• Lane Departure Alert with Steering Assist &amp; Lane Tracing</a:t>
-            </a:r>
-            <a:br/>
-            <a:r>
-              <a:t>• Full-Speed Range Dynamic Radar Cruise Control</a:t>
-            </a:r>
-            <a:br/>
-            <a:r>
-              <a:t>• 10 advanced airbags &amp; Star Safety System</a:t>
+                <a:latin typeface="Calibri"/>
+              </a:defRPr>
+            </a:pPr>
+            <a:r>
+              <a:t>Why I Chose This Car:</a:t>
             </a:r>
           </a:p>
           <a:p>
             <a:pPr>
-              <a:defRPr b="1" sz="1300">
-                <a:solidFill>
-                  <a:srgbClr val="0F172A"/>
-                </a:solidFill>
-              </a:defRPr>
-            </a:pPr>
-            <a:r>
-              <a:t>Why I Chose This Car:</a:t>
-            </a:r>
-          </a:p>
-          <a:p>
-            <a:pPr>
-              <a:defRPr sz="1100" i="1">
-                <a:solidFill>
-                  <a:srgbClr val="475569"/>
-                </a:solidFill>
-              </a:defRPr>
-            </a:pPr>
-            <a:r>
-              <a:t>"Unmatched Toyota reliability, low maintenance costs, class-leading 38 MPG highway gas mileage that saves money at the pump, exceptional safety scores, and industry-leading resale retention."</a:t>
+              <a:defRPr sz="1050" i="1">
+                <a:solidFill>
+                  <a:srgbClr val="64748B"/>
+                </a:solidFill>
+                <a:latin typeface="Calibri"/>
+              </a:defRPr>
+            </a:pPr>
+            <a:r>
+              <a:t>"Unrivaled Toyota mechanical reliability, lower insurance premiums, class-leading 38 MPG highway fuel efficiency that saves money on daily commutes, and high resale value retention."</a:t>
             </a:r>
           </a:p>
         </p:txBody>
@@ -5673,7 +5794,7 @@
             <a:avLst/>
           </a:prstGeom>
           <a:solidFill>
-            <a:srgbClr val="F8FAFC"/>
+            <a:srgbClr val="F5F7FA"/>
           </a:solidFill>
           <a:ln>
             <a:noFill/>
@@ -5716,7 +5837,7 @@
             <a:avLst/>
           </a:prstGeom>
           <a:solidFill>
-            <a:srgbClr val="182646"/>
+            <a:srgbClr val="0F172A"/>
           </a:solidFill>
           <a:ln>
             <a:noFill/>
@@ -5752,14 +5873,14 @@
         </p:nvSpPr>
         <p:spPr>
           <a:xfrm>
-            <a:off x="731520" y="182880"/>
-            <a:ext cx="2103120" cy="320040"/>
+            <a:off x="731520" y="164592"/>
+            <a:ext cx="2194560" cy="292608"/>
           </a:xfrm>
           <a:prstGeom prst="roundRect">
             <a:avLst/>
           </a:prstGeom>
           <a:solidFill>
-            <a:srgbClr val="1D4ED8"/>
+            <a:srgbClr val="10B981"/>
           </a:solidFill>
           <a:ln>
             <a:noFill/>
@@ -5780,14 +5901,15 @@
           </a:fontRef>
         </p:style>
         <p:txBody>
-          <a:bodyPr rtlCol="0" anchor="ctr" wrap="square" tIns="18288" bIns="18288"/>
+          <a:bodyPr rtlCol="0" anchor="ctr" wrap="square" tIns="0"/>
           <a:lstStyle/>
           <a:p>
             <a:pPr algn="ctr">
-              <a:defRPr sz="1100" b="1">
+              <a:defRPr sz="1050" b="1">
                 <a:solidFill>
                   <a:srgbClr val="FFFFFF"/>
                 </a:solidFill>
+                <a:latin typeface="Calibri"/>
               </a:defRPr>
             </a:pPr>
             <a:r>
@@ -5804,8 +5926,8 @@
         </p:nvSpPr>
         <p:spPr>
           <a:xfrm>
-            <a:off x="731520" y="530352"/>
-            <a:ext cx="8686800" cy="457200"/>
+            <a:off x="731520" y="502920"/>
+            <a:ext cx="8229600" cy="502920"/>
           </a:xfrm>
           <a:prstGeom prst="rect">
             <a:avLst/>
@@ -5819,10 +5941,11 @@
           <a:lstStyle/>
           <a:p>
             <a:pPr>
-              <a:defRPr sz="2000" b="1">
+              <a:defRPr sz="2100" b="1">
                 <a:solidFill>
                   <a:srgbClr val="FFFFFF"/>
                 </a:solidFill>
+                <a:latin typeface="Calibri"/>
               </a:defRPr>
             </a:pPr>
             <a:r>
@@ -5839,7 +5962,7 @@
         </p:nvSpPr>
         <p:spPr>
           <a:xfrm>
-            <a:off x="7772400" y="228600"/>
+            <a:off x="7772400" y="182880"/>
             <a:ext cx="3657600" cy="685800"/>
           </a:xfrm>
           <a:prstGeom prst="rect">
@@ -5854,10 +5977,11 @@
           <a:lstStyle/>
           <a:p>
             <a:pPr algn="r">
-              <a:defRPr sz="1200">
+              <a:defRPr sz="1100">
                 <a:solidFill>
                   <a:srgbClr val="94A3B8"/>
                 </a:solidFill>
+                <a:latin typeface="Calibri"/>
               </a:defRPr>
             </a:pPr>
             <a:r>
@@ -5866,14 +5990,15 @@
           </a:p>
           <a:p>
             <a:pPr algn="r">
-              <a:defRPr sz="1100" b="1">
+              <a:defRPr sz="1200" b="1">
                 <a:solidFill>
                   <a:srgbClr val="E2E8F0"/>
                 </a:solidFill>
-              </a:defRPr>
-            </a:pPr>
-            <a:r>
-              <a:t>Student: Rehan Mangar  |  Slide 5 of 6</a:t>
+                <a:latin typeface="Calibri"/>
+              </a:defRPr>
+            </a:pPr>
+            <a:r>
+              <a:t>Student: Rehan Mangar  •  Slide 5 of 6</a:t>
             </a:r>
           </a:p>
         </p:txBody>
@@ -5886,8 +6011,8 @@
         </p:nvSpPr>
         <p:spPr>
           <a:xfrm>
-            <a:off x="731520" y="1280160"/>
-            <a:ext cx="5120640" cy="3931920"/>
+            <a:off x="731520" y="1234440"/>
+            <a:ext cx="4114800" cy="3840480"/>
           </a:xfrm>
           <a:prstGeom prst="roundRect">
             <a:avLst/>
@@ -5916,33 +6041,35 @@
           </a:fontRef>
         </p:style>
         <p:txBody>
-          <a:bodyPr rtlCol="0" anchor="ctr" lIns="274320" rIns="274320" tIns="228600"/>
+          <a:bodyPr rtlCol="0" anchor="ctr" lIns="256032" rIns="256032" tIns="201168"/>
           <a:lstStyle/>
           <a:p>
             <a:pPr algn="ctr">
-              <a:defRPr sz="1200" b="1">
+              <a:defRPr sz="1100" b="1">
                 <a:solidFill>
                   <a:srgbClr val="10B981"/>
                 </a:solidFill>
-              </a:defRPr>
-            </a:pPr>
-            <a:r>
-              <a:t>LOAN C: SIMPLE INTEREST (PARENTS)</a:t>
+                <a:latin typeface="Calibri"/>
+              </a:defRPr>
+            </a:pPr>
+            <a:r>
+              <a:t>LOAN C: PARENTS (SIMPLE INTEREST)</a:t>
             </a:r>
           </a:p>
           <a:p>
             <a:pPr>
               <a:spcAft>
-                <a:spcPts val="800"/>
+                <a:spcPts val="600"/>
               </a:spcAft>
-              <a:defRPr sz="2600" b="1">
+              <a:defRPr sz="2400" b="1">
                 <a:solidFill>
                   <a:srgbClr val="0F172A"/>
                 </a:solidFill>
-              </a:defRPr>
-            </a:pPr>
-            <a:r>
-              <a:t>$292.42 / month</a:t>
+                <a:latin typeface="Calibri"/>
+              </a:defRPr>
+            </a:pPr>
+            <a:r>
+              <a:t>$292.42 / mo</a:t>
             </a:r>
           </a:p>
           <a:p>
@@ -5950,22 +6077,24 @@
               <a:spcAft>
                 <a:spcPts val="400"/>
               </a:spcAft>
-              <a:defRPr b="1" sz="1150">
+              <a:defRPr b="1" sz="1100">
                 <a:solidFill>
                   <a:srgbClr val="0F172A"/>
                 </a:solidFill>
-              </a:defRPr>
-            </a:pPr>
-            <a:r>
-              <a:t>Loan Terms: </a:t>
+                <a:latin typeface="Calibri"/>
+              </a:defRPr>
+            </a:pPr>
+            <a:r>
+              <a:t>• Terms: </a:t>
             </a:r>
             <a:r>
               <a:rPr b="0">
                 <a:solidFill>
-                  <a:srgbClr val="0F172A"/>
-                </a:solidFill>
+                  <a:srgbClr val="334155"/>
+                </a:solidFill>
+                <a:latin typeface="Calibri"/>
               </a:rPr>
-              <a:t>4.2% Simple Interest / 5 Years (60 Months)</a:t>
+              <a:t>4.2% Simple Interest / 5 Yrs (60 Mos)</a:t>
             </a:r>
           </a:p>
           <a:p>
@@ -5973,22 +6102,24 @@
               <a:spcAft>
                 <a:spcPts val="400"/>
               </a:spcAft>
-              <a:defRPr b="1" sz="1150">
+              <a:defRPr b="1" sz="1100">
                 <a:solidFill>
                   <a:srgbClr val="0F172A"/>
                 </a:solidFill>
-              </a:defRPr>
-            </a:pPr>
-            <a:r>
-              <a:t>Interest Formula: </a:t>
-            </a:r>
-            <a:r>
-              <a:rPr b="0">
-                <a:solidFill>
-                  <a:srgbClr val="0F172A"/>
-                </a:solidFill>
+                <a:latin typeface="Calibri"/>
+              </a:defRPr>
+            </a:pPr>
+            <a:r>
+              <a:t>• Interest Paid: </a:t>
+            </a:r>
+            <a:r>
+              <a:rPr b="1">
+                <a:solidFill>
+                  <a:srgbClr val="10B981"/>
+                </a:solidFill>
+                <a:latin typeface="Calibri"/>
               </a:rPr>
-              <a:t>I = P × r × t = $14,500 × 0.042 × 5</a:t>
+              <a:t>$3,045.00  (Saves $2,142.23!)</a:t>
             </a:r>
           </a:p>
           <a:p>
@@ -5996,22 +6127,24 @@
               <a:spcAft>
                 <a:spcPts val="400"/>
               </a:spcAft>
-              <a:defRPr b="1" sz="1150">
+              <a:defRPr b="1" sz="1100">
                 <a:solidFill>
                   <a:srgbClr val="0F172A"/>
                 </a:solidFill>
-              </a:defRPr>
-            </a:pPr>
-            <a:r>
-              <a:t>Total Interest Paid: </a:t>
-            </a:r>
-            <a:r>
-              <a:rPr b="1">
-                <a:solidFill>
-                  <a:srgbClr val="10B981"/>
-                </a:solidFill>
+                <a:latin typeface="Calibri"/>
+              </a:defRPr>
+            </a:pPr>
+            <a:r>
+              <a:t>• Total Repayment: </a:t>
+            </a:r>
+            <a:r>
+              <a:rPr b="0">
+                <a:solidFill>
+                  <a:srgbClr val="334155"/>
+                </a:solidFill>
+                <a:latin typeface="Calibri"/>
               </a:rPr>
-              <a:t>$3,045.00  (Saves $2,142.23 vs Bank!)</a:t>
+              <a:t>$14,500 + $3,045.00 = $17,545.00</a:t>
             </a:r>
           </a:p>
           <a:p>
@@ -6019,45 +6152,24 @@
               <a:spcAft>
                 <a:spcPts val="400"/>
               </a:spcAft>
-              <a:defRPr b="1" sz="1150">
+              <a:defRPr b="1" sz="1100">
                 <a:solidFill>
                   <a:srgbClr val="0F172A"/>
                 </a:solidFill>
-              </a:defRPr>
-            </a:pPr>
-            <a:r>
-              <a:t>Total Cost with Interest: </a:t>
-            </a:r>
-            <a:r>
-              <a:rPr b="0">
-                <a:solidFill>
-                  <a:srgbClr val="0F172A"/>
-                </a:solidFill>
+                <a:latin typeface="Calibri"/>
+              </a:defRPr>
+            </a:pPr>
+            <a:r>
+              <a:t>• Monthly Payment: </a:t>
+            </a:r>
+            <a:r>
+              <a:rPr b="1">
+                <a:solidFill>
+                  <a:srgbClr val="334155"/>
+                </a:solidFill>
+                <a:latin typeface="Calibri"/>
               </a:rPr>
-              <a:t>$14,500 + $3,045.00 = $17,545.00</a:t>
-            </a:r>
-          </a:p>
-          <a:p>
-            <a:pPr>
-              <a:spcAft>
-                <a:spcPts val="400"/>
-              </a:spcAft>
-              <a:defRPr b="1" sz="1150">
-                <a:solidFill>
-                  <a:srgbClr val="0F172A"/>
-                </a:solidFill>
-              </a:defRPr>
-            </a:pPr>
-            <a:r>
-              <a:t>Monthly Payment Formula: </a:t>
-            </a:r>
-            <a:r>
-              <a:rPr b="1">
-                <a:solidFill>
-                  <a:srgbClr val="0F172A"/>
-                </a:solidFill>
-              </a:rPr>
-              <a:t>$17,545.00 ÷ 60 months = $292.42 / mo</a:t>
+              <a:t>$17,545.00 ÷ 60 = $292.42 / month</a:t>
             </a:r>
           </a:p>
         </p:txBody>
@@ -6070,8 +6182,8 @@
         </p:nvSpPr>
         <p:spPr>
           <a:xfrm>
-            <a:off x="6217920" y="1280160"/>
-            <a:ext cx="5212080" cy="3931920"/>
+            <a:off x="5029200" y="1234440"/>
+            <a:ext cx="4114800" cy="3840480"/>
           </a:xfrm>
           <a:prstGeom prst="roundRect">
             <a:avLst/>
@@ -6100,33 +6212,35 @@
           </a:fontRef>
         </p:style>
         <p:txBody>
-          <a:bodyPr rtlCol="0" anchor="ctr" lIns="274320" rIns="274320" tIns="228600"/>
+          <a:bodyPr rtlCol="0" anchor="ctr" lIns="256032" rIns="256032" tIns="201168"/>
           <a:lstStyle/>
           <a:p>
             <a:pPr algn="ctr">
-              <a:defRPr sz="1200" b="1">
+              <a:defRPr sz="1100" b="1">
                 <a:solidFill>
                   <a:srgbClr val="1D4ED8"/>
                 </a:solidFill>
-              </a:defRPr>
-            </a:pPr>
-            <a:r>
-              <a:t>LOAN D: COMPOUND INTEREST (BANK)</a:t>
+                <a:latin typeface="Calibri"/>
+              </a:defRPr>
+            </a:pPr>
+            <a:r>
+              <a:t>LOAN D: BANK (COMPOUND INTEREST)</a:t>
             </a:r>
           </a:p>
           <a:p>
             <a:pPr>
               <a:spcAft>
-                <a:spcPts val="800"/>
+                <a:spcPts val="600"/>
               </a:spcAft>
-              <a:defRPr sz="2600" b="1">
+              <a:defRPr sz="2400" b="1">
                 <a:solidFill>
                   <a:srgbClr val="0F172A"/>
                 </a:solidFill>
-              </a:defRPr>
-            </a:pPr>
-            <a:r>
-              <a:t>$273.43 / month</a:t>
+                <a:latin typeface="Calibri"/>
+              </a:defRPr>
+            </a:pPr>
+            <a:r>
+              <a:t>$273.43 / mo</a:t>
             </a:r>
           </a:p>
           <a:p>
@@ -6134,22 +6248,24 @@
               <a:spcAft>
                 <a:spcPts val="400"/>
               </a:spcAft>
-              <a:defRPr b="1" sz="1150">
+              <a:defRPr b="1" sz="1100">
                 <a:solidFill>
                   <a:srgbClr val="0F172A"/>
                 </a:solidFill>
-              </a:defRPr>
-            </a:pPr>
-            <a:r>
-              <a:t>Loan Terms: </a:t>
+                <a:latin typeface="Calibri"/>
+              </a:defRPr>
+            </a:pPr>
+            <a:r>
+              <a:t>• Terms: </a:t>
             </a:r>
             <a:r>
               <a:rPr>
                 <a:solidFill>
-                  <a:srgbClr val="0F172A"/>
-                </a:solidFill>
+                  <a:srgbClr val="334155"/>
+                </a:solidFill>
+                <a:latin typeface="Calibri"/>
               </a:rPr>
-              <a:t>5.1% Compounded Daily (365) / 6 Years (72 Mos)</a:t>
+              <a:t>5.1% Daily Compound (365) / 6 Yrs (72 Mos)</a:t>
             </a:r>
           </a:p>
           <a:p>
@@ -6157,22 +6273,24 @@
               <a:spcAft>
                 <a:spcPts val="400"/>
               </a:spcAft>
-              <a:defRPr b="1" sz="1150">
+              <a:defRPr b="1" sz="1100">
                 <a:solidFill>
                   <a:srgbClr val="0F172A"/>
                 </a:solidFill>
-              </a:defRPr>
-            </a:pPr>
-            <a:r>
-              <a:t>Compound Formula: </a:t>
+                <a:latin typeface="Calibri"/>
+              </a:defRPr>
+            </a:pPr>
+            <a:r>
+              <a:t>• Interest Paid: </a:t>
             </a:r>
             <a:r>
               <a:rPr>
                 <a:solidFill>
-                  <a:srgbClr val="0F172A"/>
-                </a:solidFill>
+                  <a:srgbClr val="DC2626"/>
+                </a:solidFill>
+                <a:latin typeface="Calibri"/>
               </a:rPr>
-              <a:t>A = P(1 + r/n)^(nt) = 14,500(1 + 0.051/365)^(2190)</a:t>
+              <a:t>$5,187.23  (+$2,142.23 more interest)</a:t>
             </a:r>
           </a:p>
           <a:p>
@@ -6180,22 +6298,24 @@
               <a:spcAft>
                 <a:spcPts val="400"/>
               </a:spcAft>
-              <a:defRPr b="1" sz="1150">
+              <a:defRPr b="1" sz="1100">
                 <a:solidFill>
                   <a:srgbClr val="0F172A"/>
                 </a:solidFill>
-              </a:defRPr>
-            </a:pPr>
-            <a:r>
-              <a:t>Total Amount Repaid: </a:t>
+                <a:latin typeface="Calibri"/>
+              </a:defRPr>
+            </a:pPr>
+            <a:r>
+              <a:t>• Total Repayment: </a:t>
             </a:r>
             <a:r>
               <a:rPr>
                 <a:solidFill>
-                  <a:srgbClr val="0F172A"/>
-                </a:solidFill>
+                  <a:srgbClr val="334155"/>
+                </a:solidFill>
+                <a:latin typeface="Calibri"/>
               </a:rPr>
-              <a:t>$19,687.23</a:t>
+              <a:t>$19,687.23 (14,500 × (1 + 0.051/365)^2190)</a:t>
             </a:r>
           </a:p>
           <a:p>
@@ -6203,45 +6323,24 @@
               <a:spcAft>
                 <a:spcPts val="400"/>
               </a:spcAft>
-              <a:defRPr b="1" sz="1150">
+              <a:defRPr b="1" sz="1100">
                 <a:solidFill>
                   <a:srgbClr val="0F172A"/>
                 </a:solidFill>
-              </a:defRPr>
-            </a:pPr>
-            <a:r>
-              <a:t>Total Interest Paid: </a:t>
+                <a:latin typeface="Calibri"/>
+              </a:defRPr>
+            </a:pPr>
+            <a:r>
+              <a:t>• Monthly Payment: </a:t>
             </a:r>
             <a:r>
               <a:rPr>
                 <a:solidFill>
-                  <a:srgbClr val="DC2626"/>
-                </a:solidFill>
+                  <a:srgbClr val="334155"/>
+                </a:solidFill>
+                <a:latin typeface="Calibri"/>
               </a:rPr>
-              <a:t>$19,687.23 - $14,500 = $5,187.23</a:t>
-            </a:r>
-          </a:p>
-          <a:p>
-            <a:pPr>
-              <a:spcAft>
-                <a:spcPts val="400"/>
-              </a:spcAft>
-              <a:defRPr b="1" sz="1150">
-                <a:solidFill>
-                  <a:srgbClr val="0F172A"/>
-                </a:solidFill>
-              </a:defRPr>
-            </a:pPr>
-            <a:r>
-              <a:t>Monthly Payment Formula: </a:t>
-            </a:r>
-            <a:r>
-              <a:rPr>
-                <a:solidFill>
-                  <a:srgbClr val="0F172A"/>
-                </a:solidFill>
-              </a:rPr>
-              <a:t>$19,687.23 ÷ 72 months = $273.43 / mo</a:t>
+              <a:t>$19,687.23 ÷ 72 = $273.43 / month</a:t>
             </a:r>
           </a:p>
         </p:txBody>
@@ -6254,8 +6353,100 @@
         </p:nvSpPr>
         <p:spPr>
           <a:xfrm>
-            <a:off x="731520" y="5394960"/>
-            <a:ext cx="10698480" cy="1188720"/>
+            <a:off x="9326880" y="1234440"/>
+            <a:ext cx="2148840" cy="3840480"/>
+          </a:xfrm>
+          <a:prstGeom prst="roundRect">
+            <a:avLst/>
+          </a:prstGeom>
+          <a:solidFill>
+            <a:srgbClr val="FFFFFF"/>
+          </a:solidFill>
+          <a:ln w="19050">
+            <a:solidFill>
+              <a:srgbClr val="E2E8F0"/>
+            </a:solidFill>
+          </a:ln>
+        </p:spPr>
+        <p:style>
+          <a:lnRef idx="1">
+            <a:schemeClr val="accent1"/>
+          </a:lnRef>
+          <a:fillRef idx="3">
+            <a:schemeClr val="accent1"/>
+          </a:fillRef>
+          <a:effectRef idx="2">
+            <a:schemeClr val="accent1"/>
+          </a:effectRef>
+          <a:fontRef idx="minor">
+            <a:schemeClr val="lt1"/>
+          </a:fontRef>
+        </p:style>
+        <p:txBody>
+          <a:bodyPr rtlCol="0" anchor="ctr" tIns="2651760" lIns="137160" rIns="137160"/>
+          <a:lstStyle/>
+          <a:p>
+            <a:pPr algn="ctr">
+              <a:defRPr b="1" sz="1050">
+                <a:solidFill>
+                  <a:srgbClr val="0F172A"/>
+                </a:solidFill>
+                <a:latin typeface="Calibri"/>
+              </a:defRPr>
+            </a:pPr>
+            <a:r>
+              <a:t>Compounding Impact:</a:t>
+            </a:r>
+          </a:p>
+          <a:p>
+            <a:pPr>
+              <a:defRPr sz="950">
+                <a:solidFill>
+                  <a:srgbClr val="64748B"/>
+                </a:solidFill>
+                <a:latin typeface="Calibri"/>
+              </a:defRPr>
+            </a:pPr>
+            <a:r>
+              <a:t>Daily compounding adds over $5,100 in interest on a 6-year bank loan.</a:t>
+            </a:r>
+          </a:p>
+        </p:txBody>
+      </p:sp>
+      <p:pic>
+        <p:nvPicPr>
+          <p:cNvPr id="10" name="Picture 9" descr="bank_savings.jpg"/>
+          <p:cNvPicPr>
+            <a:picLocks noChangeAspect="1"/>
+          </p:cNvPicPr>
+          <p:nvPr/>
+        </p:nvPicPr>
+        <p:blipFill>
+          <a:blip r:embed="rId2"/>
+          <a:stretch>
+            <a:fillRect/>
+          </a:stretch>
+        </p:blipFill>
+        <p:spPr>
+          <a:xfrm>
+            <a:off x="9464040" y="1417320"/>
+            <a:ext cx="1874519" cy="2377440"/>
+          </a:xfrm>
+          <a:prstGeom prst="rect">
+            <a:avLst/>
+          </a:prstGeom>
+        </p:spPr>
+      </p:pic>
+      <p:sp>
+        <p:nvSpPr>
+          <p:cNvPr id="11" name="Rounded Rectangle 10"/>
+          <p:cNvSpPr/>
+          <p:nvPr/>
+        </p:nvSpPr>
+        <p:spPr>
+          <a:xfrm>
+            <a:off x="731520" y="5257800"/>
+            <a:ext cx="10744200" cy="1280160"/>
           </a:xfrm>
           <a:prstGeom prst="roundRect">
             <a:avLst/>
@@ -6284,38 +6475,40 @@
           </a:fontRef>
         </p:style>
         <p:txBody>
-          <a:bodyPr rtlCol="0" anchor="ctr" lIns="274320" rIns="274320" tIns="109728"/>
+          <a:bodyPr rtlCol="0" anchor="ctr" lIns="274320" rIns="274320" tIns="137160"/>
           <a:lstStyle/>
           <a:p>
             <a:pPr algn="ctr">
-              <a:defRPr sz="1300" b="1">
+              <a:defRPr sz="1250" b="1">
                 <a:solidFill>
                   <a:srgbClr val="065F46"/>
                 </a:solidFill>
-              </a:defRPr>
-            </a:pPr>
-            <a:r>
-              <a:t>WHICH LOAN WOULD YOU CHOOSE?  —  RECOMMENDATION: LOAN C (PARENTS)</a:t>
+                <a:latin typeface="Calibri"/>
+              </a:defRPr>
+            </a:pPr>
+            <a:r>
+              <a:t>WHICH LOAN WOULD YOU CHOOSE?  —  FINAL DECISION: LOAN C (PARENTS)</a:t>
             </a:r>
           </a:p>
           <a:p>
             <a:pPr>
               <a:defRPr sz="1100">
                 <a:solidFill>
-                  <a:srgbClr val="064E3B"/>
-                </a:solidFill>
-              </a:defRPr>
-            </a:pPr>
-            <a:r>
-              <a:t>• Lowest Monthly Payment: Loan D is lower by $18.99/month ($273.43 vs $292.42).</a:t>
+                  <a:srgbClr val="065F46"/>
+                </a:solidFill>
+                <a:latin typeface="Calibri"/>
+              </a:defRPr>
+            </a:pPr>
+            <a:r>
+              <a:t>• Lowest Monthly Payment: Loan D ($273.43/mo vs. $292.42/mo — lower by $18.99/mo).</a:t>
             </a:r>
             <a:br/>
             <a:r>
-              <a:t>• Lowest Total Interest Paid: Loan C saves $2,142.23 in interest ($3,045.00 vs $5,187.23).</a:t>
+              <a:t>• Lowest Total Interest: Loan C ($3,045.00 vs. $5,187.23 — saves $2,142.23 in interest).</a:t>
             </a:r>
             <a:br/>
             <a:r>
-              <a:t>• Conclusion: I choose Loan C. Paying slightly more each month eliminates over $2,100 of interest and debt 1 year faster.</a:t>
+              <a:t>• Reasoning: I choose Loan C. Paying $18.99 more per month saves over $2,142 in interest and eliminates debt 1 year faster.</a:t>
             </a:r>
           </a:p>
         </p:txBody>
@@ -6353,7 +6546,7 @@
             <a:avLst/>
           </a:prstGeom>
           <a:solidFill>
-            <a:srgbClr val="F8FAFC"/>
+            <a:srgbClr val="F5F7FA"/>
           </a:solidFill>
           <a:ln>
             <a:noFill/>
@@ -6396,7 +6589,7 @@
             <a:avLst/>
           </a:prstGeom>
           <a:solidFill>
-            <a:srgbClr val="182646"/>
+            <a:srgbClr val="0F172A"/>
           </a:solidFill>
           <a:ln>
             <a:noFill/>
@@ -6432,8 +6625,8 @@
         </p:nvSpPr>
         <p:spPr>
           <a:xfrm>
-            <a:off x="731520" y="182880"/>
-            <a:ext cx="2103120" cy="320040"/>
+            <a:off x="731520" y="164592"/>
+            <a:ext cx="2194560" cy="292608"/>
           </a:xfrm>
           <a:prstGeom prst="roundRect">
             <a:avLst/>
@@ -6460,14 +6653,15 @@
           </a:fontRef>
         </p:style>
         <p:txBody>
-          <a:bodyPr rtlCol="0" anchor="ctr" wrap="square" tIns="18288" bIns="18288"/>
+          <a:bodyPr rtlCol="0" anchor="ctr" wrap="square" tIns="0"/>
           <a:lstStyle/>
           <a:p>
             <a:pPr algn="ctr">
-              <a:defRPr sz="1100" b="1">
+              <a:defRPr sz="1050" b="1">
                 <a:solidFill>
                   <a:srgbClr val="FFFFFF"/>
                 </a:solidFill>
+                <a:latin typeface="Calibri"/>
               </a:defRPr>
             </a:pPr>
             <a:r>
@@ -6484,8 +6678,8 @@
         </p:nvSpPr>
         <p:spPr>
           <a:xfrm>
-            <a:off x="731520" y="530352"/>
-            <a:ext cx="8686800" cy="457200"/>
+            <a:off x="731520" y="502920"/>
+            <a:ext cx="8229600" cy="502920"/>
           </a:xfrm>
           <a:prstGeom prst="rect">
             <a:avLst/>
@@ -6499,10 +6693,11 @@
           <a:lstStyle/>
           <a:p>
             <a:pPr>
-              <a:defRPr sz="2000" b="1">
+              <a:defRPr sz="2100" b="1">
                 <a:solidFill>
                   <a:srgbClr val="FFFFFF"/>
                 </a:solidFill>
+                <a:latin typeface="Calibri"/>
               </a:defRPr>
             </a:pPr>
             <a:r>
@@ -6519,7 +6714,7 @@
         </p:nvSpPr>
         <p:spPr>
           <a:xfrm>
-            <a:off x="7772400" y="228600"/>
+            <a:off x="7772400" y="182880"/>
             <a:ext cx="3657600" cy="685800"/>
           </a:xfrm>
           <a:prstGeom prst="rect">
@@ -6534,10 +6729,11 @@
           <a:lstStyle/>
           <a:p>
             <a:pPr algn="r">
-              <a:defRPr sz="1200">
+              <a:defRPr sz="1100">
                 <a:solidFill>
                   <a:srgbClr val="94A3B8"/>
                 </a:solidFill>
+                <a:latin typeface="Calibri"/>
               </a:defRPr>
             </a:pPr>
             <a:r>
@@ -6546,14 +6742,15 @@
           </a:p>
           <a:p>
             <a:pPr algn="r">
-              <a:defRPr sz="1100" b="1">
+              <a:defRPr sz="1200" b="1">
                 <a:solidFill>
                   <a:srgbClr val="E2E8F0"/>
                 </a:solidFill>
-              </a:defRPr>
-            </a:pPr>
-            <a:r>
-              <a:t>Student: Rehan Mangar  |  Slide 6 of 6</a:t>
+                <a:latin typeface="Calibri"/>
+              </a:defRPr>
+            </a:pPr>
+            <a:r>
+              <a:t>Student: Rehan Mangar  •  Slide 6 of 6</a:t>
             </a:r>
           </a:p>
         </p:txBody>
@@ -6566,8 +6763,8 @@
         </p:nvSpPr>
         <p:spPr>
           <a:xfrm>
-            <a:off x="731520" y="1280160"/>
-            <a:ext cx="5486400" cy="5120640"/>
+            <a:off x="731520" y="1234440"/>
+            <a:ext cx="4754880" cy="5212080"/>
           </a:xfrm>
           <a:prstGeom prst="roundRect">
             <a:avLst/>
@@ -6601,12 +6798,13 @@
           <a:p>
             <a:pPr algn="ctr">
               <a:spcAft>
-                <a:spcPts val="600"/>
+                <a:spcPts val="400"/>
               </a:spcAft>
-              <a:defRPr sz="1200" b="1">
+              <a:defRPr sz="1150" b="1">
                 <a:solidFill>
                   <a:srgbClr val="1D4ED8"/>
                 </a:solidFill>
+                <a:latin typeface="Calibri"/>
               </a:defRPr>
             </a:pPr>
             <a:r>
@@ -6615,25 +6813,27 @@
           </a:p>
           <a:p>
             <a:pPr>
-              <a:defRPr b="1" sz="1150">
+              <a:defRPr b="1" sz="1100">
                 <a:solidFill>
                   <a:srgbClr val="0F172A"/>
                 </a:solidFill>
-              </a:defRPr>
-            </a:pPr>
-            <a:r>
-              <a:t>1. Chosen Car &amp; Monthly Payment:</a:t>
+                <a:latin typeface="Calibri"/>
+              </a:defRPr>
+            </a:pPr>
+            <a:r>
+              <a:t>1. Which car and monthly payment did you pick?</a:t>
             </a:r>
           </a:p>
           <a:p>
             <a:pPr>
               <a:spcAft>
-                <a:spcPts val="600"/>
+                <a:spcPts val="400"/>
               </a:spcAft>
-              <a:defRPr sz="1100">
+              <a:defRPr sz="1050">
                 <a:solidFill>
                   <a:srgbClr val="1D4ED8"/>
                 </a:solidFill>
+                <a:latin typeface="Calibri"/>
               </a:defRPr>
             </a:pPr>
             <a:r>
@@ -6642,110 +6842,118 @@
           </a:p>
           <a:p>
             <a:pPr>
-              <a:defRPr b="1" sz="1150">
+              <a:defRPr b="1" sz="1100">
                 <a:solidFill>
                   <a:srgbClr val="0F172A"/>
                 </a:solidFill>
-              </a:defRPr>
-            </a:pPr>
-            <a:r>
-              <a:t>2. Transportation Budget (11%):</a:t>
+                <a:latin typeface="Calibri"/>
+              </a:defRPr>
+            </a:pPr>
+            <a:r>
+              <a:t>2. What is your transportation budget?</a:t>
             </a:r>
           </a:p>
           <a:p>
             <a:pPr>
               <a:spcAft>
-                <a:spcPts val="600"/>
+                <a:spcPts val="400"/>
               </a:spcAft>
-              <a:defRPr sz="1100">
+              <a:defRPr sz="1050">
+                <a:solidFill>
+                  <a:srgbClr val="334155"/>
+                </a:solidFill>
+                <a:latin typeface="Calibri"/>
+              </a:defRPr>
+            </a:pPr>
+            <a:r>
+              <a:t>→ $150.48 / month (11% of $1,368.00 gross monthly income).</a:t>
+            </a:r>
+          </a:p>
+          <a:p>
+            <a:pPr>
+              <a:defRPr b="1" sz="1100">
                 <a:solidFill>
                   <a:srgbClr val="0F172A"/>
                 </a:solidFill>
-              </a:defRPr>
-            </a:pPr>
-            <a:r>
-              <a:t>→ $150.48 / month (11% of $1,368.00 gross monthly pay).</a:t>
-            </a:r>
-          </a:p>
-          <a:p>
-            <a:pPr>
-              <a:defRPr b="1" sz="1150">
-                <a:solidFill>
-                  <a:srgbClr val="0F172A"/>
-                </a:solidFill>
-              </a:defRPr>
-            </a:pPr>
-            <a:r>
-              <a:t>3. Does it fit your current budget?</a:t>
+                <a:latin typeface="Calibri"/>
+              </a:defRPr>
+            </a:pPr>
+            <a:r>
+              <a:t>3. Does the monthly payment fit into your budget?</a:t>
             </a:r>
           </a:p>
           <a:p>
             <a:pPr>
               <a:spcAft>
-                <a:spcPts val="600"/>
+                <a:spcPts val="400"/>
               </a:spcAft>
-              <a:defRPr sz="1100">
+              <a:defRPr sz="1050">
+                <a:solidFill>
+                  <a:srgbClr val="334155"/>
+                </a:solidFill>
+                <a:latin typeface="Calibri"/>
+              </a:defRPr>
+            </a:pPr>
+            <a:r>
+              <a:t>→ No. Payment exceeds the initial $150.48 budget by $64.08 (Loan B) or $78.94 (Loan A).</a:t>
+            </a:r>
+          </a:p>
+          <a:p>
+            <a:pPr>
+              <a:defRPr b="1" sz="1100">
                 <a:solidFill>
                   <a:srgbClr val="0F172A"/>
                 </a:solidFill>
-              </a:defRPr>
-            </a:pPr>
-            <a:r>
-              <a:t>→ No — payment exceeds initial $150.48 budget by $64.08 to $78.94/mo (before insurance).</a:t>
-            </a:r>
-          </a:p>
-          <a:p>
-            <a:pPr>
-              <a:defRPr b="1" sz="1150">
-                <a:solidFill>
-                  <a:srgbClr val="0F172A"/>
-                </a:solidFill>
-              </a:defRPr>
-            </a:pPr>
-            <a:r>
-              <a:t>4. Researched Car Insurance:</a:t>
+                <a:latin typeface="Calibri"/>
+              </a:defRPr>
+            </a:pPr>
+            <a:r>
+              <a:t>4. What do you expect to pay for car insurance?</a:t>
             </a:r>
           </a:p>
           <a:p>
             <a:pPr>
               <a:spcAft>
-                <a:spcPts val="600"/>
+                <a:spcPts val="400"/>
               </a:spcAft>
-              <a:defRPr sz="1100">
+              <a:defRPr sz="1050">
+                <a:solidFill>
+                  <a:srgbClr val="334155"/>
+                </a:solidFill>
+                <a:latin typeface="Calibri"/>
+              </a:defRPr>
+            </a:pPr>
+            <a:r>
+              <a:t>→ $245.00 / month (researched average for 17-18 yr old driver on family policy).</a:t>
+            </a:r>
+          </a:p>
+          <a:p>
+            <a:pPr>
+              <a:defRPr b="1" sz="1100">
                 <a:solidFill>
                   <a:srgbClr val="0F172A"/>
                 </a:solidFill>
-              </a:defRPr>
-            </a:pPr>
-            <a:r>
-              <a:t>→ $245.00 / month (average for 17-18 yr old added to family policy).</a:t>
-            </a:r>
-          </a:p>
-          <a:p>
-            <a:pPr>
-              <a:defRPr b="1" sz="1150">
-                <a:solidFill>
-                  <a:srgbClr val="0F172A"/>
-                </a:solidFill>
-              </a:defRPr>
-            </a:pPr>
-            <a:r>
-              <a:t>5. Total Monthly Payment:</a:t>
+                <a:latin typeface="Calibri"/>
+              </a:defRPr>
+            </a:pPr>
+            <a:r>
+              <a:t>5. What is your total monthly payment?</a:t>
             </a:r>
           </a:p>
           <a:p>
             <a:pPr>
               <a:spcAft>
-                <a:spcPts val="600"/>
+                <a:spcPts val="400"/>
               </a:spcAft>
-              <a:defRPr sz="1100">
-                <a:solidFill>
-                  <a:srgbClr val="1D4ED8"/>
-                </a:solidFill>
-              </a:defRPr>
-            </a:pPr>
-            <a:r>
-              <a:t>→ $474.42 / month ($229.42 car loan + $245.00 insurance; or $459.56 with Loan B).</a:t>
+              <a:defRPr sz="1050">
+                <a:solidFill>
+                  <a:srgbClr val="334155"/>
+                </a:solidFill>
+                <a:latin typeface="Calibri"/>
+              </a:defRPr>
+            </a:pPr>
+            <a:r>
+              <a:t>→ $474.42 / month ($229.42 loan + $245.00 insurance; or $459.56 with Loan B).</a:t>
             </a:r>
           </a:p>
         </p:txBody>
@@ -6758,8 +6966,8 @@
         </p:nvSpPr>
         <p:spPr>
           <a:xfrm>
-            <a:off x="6492240" y="1280160"/>
-            <a:ext cx="4937760" cy="5120640"/>
+            <a:off x="5715000" y="1234440"/>
+            <a:ext cx="5760720" cy="5212080"/>
           </a:xfrm>
           <a:prstGeom prst="roundRect">
             <a:avLst/>
@@ -6788,133 +6996,125 @@
           </a:fontRef>
         </p:style>
         <p:txBody>
-          <a:bodyPr rtlCol="0" anchor="ctr" lIns="274320" rIns="274320" tIns="228600"/>
+          <a:bodyPr rtlCol="0" anchor="ctr" lIns="274320" rIns="274320" tIns="2423160"/>
           <a:lstStyle/>
           <a:p>
             <a:pPr algn="ctr">
               <a:spcAft>
-                <a:spcPts val="600"/>
+                <a:spcPts val="200"/>
               </a:spcAft>
-              <a:defRPr sz="1200" b="1">
-                <a:solidFill>
-                  <a:srgbClr val="10B981"/>
-                </a:solidFill>
-              </a:defRPr>
-            </a:pPr>
-            <a:r>
-              <a:t>HOW I WILL AFFORD IT (MY COMMITMENT)</a:t>
-            </a:r>
-          </a:p>
-          <a:p>
-            <a:pPr>
-              <a:defRPr b="1" sz="1150">
-                <a:solidFill>
-                  <a:srgbClr val="0F172A"/>
-                </a:solidFill>
-              </a:defRPr>
-            </a:pPr>
-            <a:r>
-              <a:t>Step 1: Increase Work Hours at Target</a:t>
+              <a:defRPr sz="1150" b="1">
+                <a:solidFill>
+                  <a:srgbClr val="065F46"/>
+                </a:solidFill>
+                <a:latin typeface="Calibri"/>
+              </a:defRPr>
+            </a:pPr>
+            <a:r>
+              <a:t>HOW I WILL AFFORD IT (MY COMMITMENT TO YOU)</a:t>
             </a:r>
           </a:p>
           <a:p>
             <a:pPr>
               <a:spcAft>
-                <a:spcPts val="600"/>
+                <a:spcPts val="300"/>
               </a:spcAft>
-              <a:defRPr sz="1050">
-                <a:solidFill>
-                  <a:srgbClr val="64748B"/>
-                </a:solidFill>
-              </a:defRPr>
-            </a:pPr>
-            <a:r>
-              <a:t>Pick up one extra 8-hour shift per week to move from 24 to 32 hrs/wk. Gross income rises from $1,368 to $1,824.00/mo (+ $456.00/mo net cash flow).</a:t>
-            </a:r>
-          </a:p>
-          <a:p>
-            <a:pPr>
-              <a:defRPr b="1" sz="1150">
+              <a:defRPr b="1" sz="1050">
                 <a:solidFill>
                   <a:srgbClr val="0F172A"/>
                 </a:solidFill>
-              </a:defRPr>
-            </a:pPr>
-            <a:r>
-              <a:t>Step 2: Reallocate Personal Budget</a:t>
+                <a:latin typeface="Calibri"/>
+              </a:defRPr>
+            </a:pPr>
+            <a:r>
+              <a:t>• 1. Increase Work Hours at Target: </a:t>
+            </a:r>
+            <a:r>
+              <a:rPr sz="1000">
+                <a:solidFill>
+                  <a:srgbClr val="334155"/>
+                </a:solidFill>
+                <a:latin typeface="Calibri"/>
+              </a:rPr>
+              <a:t>Pick up one extra 8-hr shift/week (24 to 32 hrs/wk). Gross income jumps from $1,368 to $1,824.00/mo (+ $456.00/mo cash flow), easily covering the entire car payment and insurance.</a:t>
             </a:r>
           </a:p>
           <a:p>
             <a:pPr>
               <a:spcAft>
-                <a:spcPts val="600"/>
+                <a:spcPts val="300"/>
               </a:spcAft>
-              <a:defRPr sz="1050">
-                <a:solidFill>
-                  <a:srgbClr val="64748B"/>
-                </a:solidFill>
-              </a:defRPr>
-            </a:pPr>
-            <a:r>
-              <a:t>Cut discretionary spending on dining out, snacks, subscriptions, and clothes, redirecting $150+/mo directly to insurance and fuel.</a:t>
-            </a:r>
-          </a:p>
-          <a:p>
-            <a:pPr>
-              <a:defRPr b="1" sz="1150">
+              <a:defRPr b="1" sz="1050">
                 <a:solidFill>
                   <a:srgbClr val="0F172A"/>
                 </a:solidFill>
-              </a:defRPr>
-            </a:pPr>
-            <a:r>
-              <a:t>Step 3: Save Upfront Down Payment</a:t>
+                <a:latin typeface="Calibri"/>
+              </a:defRPr>
+            </a:pPr>
+            <a:r>
+              <a:t>• 2. Cut Discretionary Spending: </a:t>
+            </a:r>
+            <a:r>
+              <a:rPr sz="1000">
+                <a:solidFill>
+                  <a:srgbClr val="334155"/>
+                </a:solidFill>
+                <a:latin typeface="Calibri"/>
+              </a:rPr>
+              <a:t>Reduce dining out, streaming, and entertainment expenses, reallocating $150+/month directly toward gasoline and maintenance reserves.</a:t>
             </a:r>
           </a:p>
           <a:p>
             <a:pPr>
               <a:spcAft>
-                <a:spcPts val="600"/>
+                <a:spcPts val="300"/>
               </a:spcAft>
-              <a:defRPr sz="1050">
-                <a:solidFill>
-                  <a:srgbClr val="64748B"/>
-                </a:solidFill>
-              </a:defRPr>
-            </a:pPr>
-            <a:r>
-              <a:t>Work over summer/break to save a $1,500 to $2,000 cash down payment before buying, reducing the financed balance to under $9,500.</a:t>
-            </a:r>
-          </a:p>
-          <a:p>
-            <a:pPr>
-              <a:defRPr b="1" sz="1150">
+              <a:defRPr b="1" sz="1050">
                 <a:solidFill>
                   <a:srgbClr val="0F172A"/>
                 </a:solidFill>
-              </a:defRPr>
-            </a:pPr>
-            <a:r>
-              <a:t>Why This is a Responsible Investment</a:t>
-            </a:r>
-          </a:p>
-          <a:p>
-            <a:pPr>
-              <a:spcAft>
-                <a:spcPts val="600"/>
-              </a:spcAft>
-              <a:defRPr sz="1050">
-                <a:solidFill>
-                  <a:srgbClr val="64748B"/>
-                </a:solidFill>
-              </a:defRPr>
-            </a:pPr>
-            <a:r>
-              <a:t>The Nissan Rogue provides AWD winter safety, modern crash prevention, and reliable transit to work and school, building real financial discipline.</a:t>
-            </a:r>
-          </a:p>
-        </p:txBody>
-      </p:sp>
+                <a:latin typeface="Calibri"/>
+              </a:defRPr>
+            </a:pPr>
+            <a:r>
+              <a:t>• 3. Save Upfront Down Payment: </a:t>
+            </a:r>
+            <a:r>
+              <a:rPr sz="1000">
+                <a:solidFill>
+                  <a:srgbClr val="334155"/>
+                </a:solidFill>
+                <a:latin typeface="Calibri"/>
+              </a:rPr>
+              <a:t>Save $1,500 - $2,000 cash before purchase to reduce loan principal under $9,500, lowering monthly payments even further.</a:t>
+            </a:r>
+          </a:p>
+        </p:txBody>
+      </p:sp>
+      <p:pic>
+        <p:nvPicPr>
+          <p:cNvPr id="9" name="Picture 8" descr="car_dealership.jpg"/>
+          <p:cNvPicPr>
+            <a:picLocks noChangeAspect="1"/>
+          </p:cNvPicPr>
+          <p:nvPr/>
+        </p:nvPicPr>
+        <p:blipFill>
+          <a:blip r:embed="rId2"/>
+          <a:stretch>
+            <a:fillRect/>
+          </a:stretch>
+        </p:blipFill>
+        <p:spPr>
+          <a:xfrm>
+            <a:off x="5943600" y="1417320"/>
+            <a:ext cx="5303520" cy="2103120"/>
+          </a:xfrm>
+          <a:prstGeom prst="rect">
+            <a:avLst/>
+          </a:prstGeom>
+        </p:spPr>
+      </p:pic>
     </p:spTree>
   </p:cSld>
   <p:clrMapOvr>

</xml_diff>

<commit_message>
feat: update Car #2 to 2012 Jeep Wrangler Unlimited Sport 4WD with verified loan calculations, updated worksheets, and revised presentation deck
</commit_message>
<xml_diff>
--- a/Car_Buying_Project/Buying_Your_First_Car_Presentation.pptx
+++ b/Car_Buying_Project/Buying_Your_First_Car_Presentation.pptx
@@ -5512,7 +5512,7 @@
               </a:defRPr>
             </a:pPr>
             <a:r>
-              <a:t>Car #2 Overview: 2021 Toyota Corolla LE</a:t>
+              <a:t>Car #2 Overview: 2012 Jeep Wrangler Unlimited Sport</a:t>
             </a:r>
           </a:p>
         </p:txBody>
@@ -5662,7 +5662,7 @@
       </p:sp>
       <p:pic>
         <p:nvPicPr>
-          <p:cNvPr id="8" name="Picture 7" descr="toyota_corolla.jpg"/>
+          <p:cNvPr id="8" name="Picture 7" descr="jeep_wrangler.jpg"/>
           <p:cNvPicPr>
             <a:picLocks noChangeAspect="1"/>
           </p:cNvPicPr>
@@ -5747,7 +5747,7 @@
               </a:defRPr>
             </a:pPr>
             <a:r>
-              <a:t>$14,500</a:t>
+              <a:t>$8,995</a:t>
             </a:r>
           </a:p>
           <a:p>
@@ -5760,7 +5760,7 @@
               </a:defRPr>
             </a:pPr>
             <a:r>
-              <a:t>Well under $20K budget</a:t>
+              <a:t>Highly affordable deal</a:t>
             </a:r>
           </a:p>
         </p:txBody>
@@ -5828,7 +5828,7 @@
               </a:defRPr>
             </a:pPr>
             <a:r>
-              <a:t>$51.35</a:t>
+              <a:t>$87.53</a:t>
             </a:r>
           </a:p>
           <a:p>
@@ -5841,7 +5841,7 @@
               </a:defRPr>
             </a:pPr>
             <a:r>
-              <a:t>13.2 Gal × $3.89/gal</a:t>
+              <a:t>22.5 Gal × $3.89/gal</a:t>
             </a:r>
           </a:p>
         </p:txBody>
@@ -5896,7 +5896,7 @@
               </a:defRPr>
             </a:pPr>
             <a:r>
-              <a:t>TECHNOLOGY &amp; INFOTAINMENT</a:t>
+              <a:t>UTILITY &amp; CONVENIENCE FEATURES</a:t>
             </a:r>
           </a:p>
           <a:p>
@@ -5909,19 +5909,19 @@
               </a:defRPr>
             </a:pPr>
             <a:r>
-              <a:t>• Apple CarPlay, Android Auto &amp; Amazon Alexa compatibility</a:t>
+              <a:t>• Durable wash-out interior with removable floor drain plugs</a:t>
             </a:r>
             <a:br/>
             <a:r>
-              <a:t>• 8-inch high-resolution touchscreen infotainment display</a:t>
+              <a:t>• Command-Trac shift-on-the-fly 4WD system for extreme terrain</a:t>
             </a:r>
             <a:br/>
             <a:r>
-              <a:t>• Integrated backup camera with projected guidelines</a:t>
+              <a:t>• Removable doors &amp; fold-down soft top convertible versatility</a:t>
             </a:r>
             <a:br/>
             <a:r>
-              <a:t>• Remote keyless entry &amp; Bluetooth hands-free phone system</a:t>
+              <a:t>• Heavy-duty roll bar audio sound system &amp; auxiliary input</a:t>
             </a:r>
           </a:p>
         </p:txBody>
@@ -5976,7 +5976,7 @@
               </a:defRPr>
             </a:pPr>
             <a:r>
-              <a:t>ACTIVE SAFETY (TOYOTA SAFETY SENSE 2.0)</a:t>
+              <a:t>ACTIVE SAFETY &amp; RUGGED TRACTION</a:t>
             </a:r>
           </a:p>
           <a:p>
@@ -5989,19 +5989,19 @@
               </a:defRPr>
             </a:pPr>
             <a:r>
-              <a:t>• Pre-Collision System with Daytime/Low-Light Pedestrian Detection</a:t>
+              <a:t>• ESC (Electronic Stability Control) &amp; ERM (Electronic Roll Mitigation)</a:t>
             </a:r>
             <a:br/>
             <a:r>
-              <a:t>• Lane Departure Alert with Steering Assist &amp; Lane Tracing</a:t>
+              <a:t>• HSA (Hill Start Assist) for smooth inclines without roll-back</a:t>
             </a:r>
             <a:br/>
             <a:r>
-              <a:t>• Full-Speed Dynamic Radar Cruise Control &amp; Road Sign Assist</a:t>
+              <a:t>• 4-Wheel Anti-lock Braking System (ABS) &amp; all-terrain traction control</a:t>
             </a:r>
             <a:br/>
             <a:r>
-              <a:t>• 10 advanced airbags &amp; Star Safety System</a:t>
+              <a:t>• Advanced multistage front airbag system &amp; high-strength steel frame</a:t>
             </a:r>
           </a:p>
         </p:txBody>
@@ -6069,7 +6069,7 @@
               </a:defRPr>
             </a:pPr>
             <a:r>
-              <a:t>"Industry-leading mechanical dependability, class-leading 38 MPG highway fuel efficiency reducing weekly gas costs, lower teenage insurance premiums, and outstanding resale value."</a:t>
+              <a:t>"It is a great deal at its price ($8,995). It provides authentic 4WD all-weather capability, legendary durability, and the lowest acquisition cost under the $20,000 project limit."</a:t>
             </a:r>
           </a:p>
         </p:txBody>
@@ -6221,7 +6221,7 @@
               </a:defRPr>
             </a:pPr>
             <a:r>
-              <a:t>Car #2 Financing Breakdown: Toyota Corolla</a:t>
+              <a:t>Car #2 Financing Breakdown: Jeep Wrangler</a:t>
             </a:r>
           </a:p>
         </p:txBody>
@@ -6377,7 +6377,7 @@
               </a:defRPr>
             </a:pPr>
             <a:r>
-              <a:t>$292.42 / month</a:t>
+              <a:t>$181.40 / month</a:t>
             </a:r>
           </a:p>
           <a:p>
@@ -6427,7 +6427,7 @@
                 </a:solidFill>
                 <a:latin typeface="Segoe UI"/>
               </a:rPr>
-              <a:t>I = $14,500 × 0.042 × 5 = $3,045.00</a:t>
+              <a:t>I = $8,995 × 0.042 × 5 = $1,888.95</a:t>
             </a:r>
           </a:p>
           <a:p>
@@ -6452,7 +6452,7 @@
                 </a:solidFill>
                 <a:latin typeface="Segoe UI"/>
               </a:rPr>
-              <a:t>$14,500 + $3,045.00 = $17,545.00</a:t>
+              <a:t>$8,995 + $1,888.95 = $10,883.95</a:t>
             </a:r>
           </a:p>
           <a:p>
@@ -6477,7 +6477,7 @@
                 </a:solidFill>
                 <a:latin typeface="Segoe UI"/>
               </a:rPr>
-              <a:t>$17,545.00 ÷ 60 months = $292.42 / mo</a:t>
+              <a:t>$10,883.95 ÷ 60 months = $181.40 / mo</a:t>
             </a:r>
           </a:p>
           <a:p>
@@ -6502,7 +6502,7 @@
                 </a:solidFill>
                 <a:latin typeface="Segoe UI"/>
               </a:rPr>
-              <a:t>Saves $2,142.23 in total interest vs. Bank!</a:t>
+              <a:t>Saves $1,330.84 in total interest vs. Bank!</a:t>
             </a:r>
           </a:p>
         </p:txBody>
@@ -6615,7 +6615,7 @@
               </a:defRPr>
             </a:pPr>
             <a:r>
-              <a:t>$273.43 / month</a:t>
+              <a:t>$169.65 / month</a:t>
             </a:r>
           </a:p>
           <a:p>
@@ -6665,7 +6665,7 @@
                 </a:solidFill>
                 <a:latin typeface="Segoe UI"/>
               </a:rPr>
-              <a:t>$14,500 × (1 + 0.051/365)^2190</a:t>
+              <a:t>$8,995 × (1 + 0.051/365)^2190</a:t>
             </a:r>
           </a:p>
           <a:p>
@@ -6690,7 +6690,7 @@
                 </a:solidFill>
                 <a:latin typeface="Segoe UI"/>
               </a:rPr>
-              <a:t>$19,687.23 principal + interest</a:t>
+              <a:t>$12,214.79 principal + interest</a:t>
             </a:r>
           </a:p>
           <a:p>
@@ -6715,7 +6715,7 @@
                 </a:solidFill>
                 <a:latin typeface="Segoe UI"/>
               </a:rPr>
-              <a:t>$19,687.23 - $14,500 = $5,187.23</a:t>
+              <a:t>$12,214.79 - $8,995 = $3,219.79</a:t>
             </a:r>
           </a:p>
           <a:p>
@@ -6740,7 +6740,7 @@
                 </a:solidFill>
                 <a:latin typeface="Segoe UI"/>
               </a:rPr>
-              <a:t>$19,687.23 ÷ 72 months = $273.43 / mo</a:t>
+              <a:t>$12,214.79 ÷ 72 months = $169.65 / mo</a:t>
             </a:r>
           </a:p>
         </p:txBody>
@@ -6863,7 +6863,7 @@
               </a:defRPr>
             </a:pPr>
             <a:r>
-              <a:t>Commercial daily compounding causes over $5,187 to be lost strictly to interest.</a:t>
+              <a:t>Commercial daily compounding causes over $3,219 to be lost strictly to interest.</a:t>
             </a:r>
           </a:p>
         </p:txBody>
@@ -6955,15 +6955,15 @@
               </a:defRPr>
             </a:pPr>
             <a:r>
-              <a:t>• Lowest Monthly Payment: Loan D has the lower monthly payment ($273.43/mo vs. $292.42/mo — $18.99 cheaper per month).</a:t>
+              <a:t>• Lowest Monthly Payment: Loan D has the lower monthly payment ($169.65/mo vs. $181.40/mo — $11.75 cheaper per month).</a:t>
             </a:r>
             <a:br/>
             <a:r>
-              <a:t>• Lowest Total Interest Paid: Loan C saves $2,142.23 in total interest ($3,045.00 vs. $5,187.23).</a:t>
+              <a:t>• Lowest Total Interest Paid: Loan C saves $1,330.84 in total interest ($1,888.95 vs. $3,219.79).</a:t>
             </a:r>
             <a:br/>
             <a:r>
-              <a:t>• Recommendation: I choose Loan C. Paying $18.99 more per month saves over $2,142 in interest and finishes 12 months sooner.</a:t>
+              <a:t>• Recommendation: I choose Loan C. Paying $11.75 more per month saves over $1,330 in interest and finishes 12 months sooner.</a:t>
             </a:r>
           </a:p>
         </p:txBody>
@@ -7284,15 +7284,19 @@
               </a:defRPr>
             </a:pPr>
             <a:r>
-              <a:t>• Chosen Vehicle &amp; Loan: 2023 Nissan Rogue S AWD with Loan A ($229.42 / mo) or Loan B ($214.56 / mo).</a:t>
+              <a:t>• Primary Vehicle Option: 2023 Nissan Rogue S AWD with Loan A ($229.42 / mo) or Loan B ($214.56 / mo).</a:t>
             </a:r>
             <a:br/>
             <a:r>
+              <a:t>• Budget Alternative Option: 2012 Jeep Wrangler Unlimited with Loan C ($181.40 / mo) or Loan D ($169.65 / mo).</a:t>
+            </a:r>
+            <a:br/>
+            <a:r>
               <a:t>• Baseline Transportation Budget (11%): $150.48 / month ($1,368.00 gross income × 0.11).</a:t>
             </a:r>
             <a:br/>
             <a:r>
-              <a:t>• Does it fit into your initial budget? No. The vehicle payment alone exceeds the initial $150.48 budget by $64.08 to $78.94 per month before factoring in insurance.</a:t>
+              <a:t>• Does it fit into your initial budget? No. Neither car fits unassisted, but the Jeep is remarkably close (exceeding by only $19.17/mo on Loan D vs. $78.94/mo for the Rogue).</a:t>
             </a:r>
           </a:p>
         </p:txBody>

</xml_diff>

<commit_message>
fix: resolve layout clipping, rotate store photo, and rewrite copy using no-ai-slop
</commit_message>
<xml_diff>
--- a/Car_Buying_Project/Buying_Your_First_Car_Presentation.pptx
+++ b/Car_Buying_Project/Buying_Your_First_Car_Presentation.pptx
@@ -3145,17 +3145,17 @@
         <p:spPr>
           <a:xfrm>
             <a:off x="731520" y="365760"/>
-            <a:ext cx="2377440" cy="292608"/>
+            <a:ext cx="2103120" cy="292608"/>
           </a:xfrm>
           <a:prstGeom prst="roundRect">
             <a:avLst/>
           </a:prstGeom>
           <a:solidFill>
-            <a:srgbClr val="FEF2F2"/>
+            <a:srgbClr val="EFF6FF"/>
           </a:solidFill>
           <a:ln w="12700">
             <a:solidFill>
-              <a:srgbClr val="FECACA"/>
+              <a:srgbClr val="BFDBFE"/>
             </a:solidFill>
           </a:ln>
         </p:spPr>
@@ -3174,19 +3174,19 @@
           </a:fontRef>
         </p:style>
         <p:txBody>
-          <a:bodyPr rtlCol="0" anchor="ctr" wrap="square" tIns="0"/>
+          <a:bodyPr rtlCol="0" anchor="ctr" tIns="0"/>
           <a:lstStyle/>
           <a:p>
             <a:pPr algn="ctr">
               <a:defRPr sz="950" b="1">
                 <a:solidFill>
-                  <a:srgbClr val="DC2626"/>
-                </a:solidFill>
-                <a:latin typeface="Segoe UI"/>
-              </a:defRPr>
-            </a:pPr>
-            <a:r>
-              <a:t>ASSIGNED JOB PROFILE</a:t>
+                  <a:srgbClr val="2563EB"/>
+                </a:solidFill>
+                <a:latin typeface="Segoe UI"/>
+              </a:defRPr>
+            </a:pPr>
+            <a:r>
+              <a:t>JOB PROFILE</a:t>
             </a:r>
           </a:p>
         </p:txBody>
@@ -3208,7 +3208,7 @@
           <a:noFill/>
         </p:spPr>
         <p:txBody>
-          <a:bodyPr wrap="square" tIns="0">
+          <a:bodyPr wrap="none" tIns="0">
             <a:spAutoFit/>
           </a:bodyPr>
           <a:lstStyle/>
@@ -3222,7 +3222,7 @@
               </a:defRPr>
             </a:pPr>
             <a:r>
-              <a:t>Employment Profile &amp; Transportation Budget Baseline</a:t>
+              <a:t>Employment Profile &amp; Transportation Budget</a:t>
             </a:r>
           </a:p>
         </p:txBody>
@@ -3334,7 +3334,7 @@
         <p:spPr>
           <a:xfrm>
             <a:off x="731520" y="1371600"/>
-            <a:ext cx="6217920" cy="4937760"/>
+            <a:ext cx="5852160" cy="4937760"/>
           </a:xfrm>
           <a:prstGeom prst="roundRect">
             <a:avLst/>
@@ -3367,23 +3367,26 @@
           <a:lstStyle/>
           <a:p>
             <a:pPr algn="ctr">
-              <a:defRPr sz="1050" b="1">
-                <a:solidFill>
-                  <a:srgbClr val="2563EB"/>
-                </a:solidFill>
-                <a:latin typeface="Segoe UI"/>
-              </a:defRPr>
-            </a:pPr>
-            <a:r>
-              <a:t>PERSONAL FINANCE FOUNDATION</a:t>
+              <a:spcAft>
+                <a:spcPts val="1400"/>
+              </a:spcAft>
+              <a:defRPr sz="2200" b="1">
+                <a:solidFill>
+                  <a:srgbClr val="0F172A"/>
+                </a:solidFill>
+                <a:latin typeface="Segoe UI"/>
+              </a:defRPr>
+            </a:pPr>
+            <a:r>
+              <a:t>Target Team Member</a:t>
             </a:r>
           </a:p>
           <a:p>
             <a:pPr>
               <a:spcAft>
-                <a:spcPts val="1200"/>
+                <a:spcPts val="800"/>
               </a:spcAft>
-              <a:defRPr sz="2200" b="1">
+              <a:defRPr b="1" sz="1200">
                 <a:solidFill>
                   <a:srgbClr val="0F172A"/>
                 </a:solidFill>
@@ -3391,25 +3394,12 @@
               </a:defRPr>
             </a:pPr>
             <a:r>
-              <a:t>Target Team Member</a:t>
-            </a:r>
-          </a:p>
-          <a:p>
-            <a:pPr>
-              <a:defRPr b="1" sz="1250">
-                <a:solidFill>
-                  <a:srgbClr val="0F172A"/>
-                </a:solidFill>
-                <a:latin typeface="Segoe UI"/>
-              </a:defRPr>
-            </a:pPr>
-            <a:r>
-              <a:t>Hourly Pay Rate: </a:t>
-            </a:r>
-            <a:r>
-              <a:rPr b="1" sz="1350">
-                <a:solidFill>
-                  <a:srgbClr val="2563EB"/>
+              <a:t>• Hourly Pay Rate: </a:t>
+            </a:r>
+            <a:r>
+              <a:rPr b="0">
+                <a:solidFill>
+                  <a:srgbClr val="1E293B"/>
                 </a:solidFill>
               </a:rPr>
               <a:t>$14.25 / hr</a:t>
@@ -3418,22 +3408,9 @@
           <a:p>
             <a:pPr>
               <a:spcAft>
-                <a:spcPts val="400"/>
+                <a:spcPts val="800"/>
               </a:spcAft>
-              <a:defRPr sz="1000">
-                <a:solidFill>
-                  <a:srgbClr val="475569"/>
-                </a:solidFill>
-                <a:latin typeface="Segoe UI"/>
-              </a:defRPr>
-            </a:pPr>
-            <a:r>
-              <a:t>   ↳ Assigned entry-level starting wage</a:t>
-            </a:r>
-          </a:p>
-          <a:p>
-            <a:pPr>
-              <a:defRPr b="1" sz="1250">
+              <a:defRPr b="1" sz="1200">
                 <a:solidFill>
                   <a:srgbClr val="0F172A"/>
                 </a:solidFill>
@@ -3441,36 +3418,23 @@
               </a:defRPr>
             </a:pPr>
             <a:r>
-              <a:t>Work Schedule: </a:t>
-            </a:r>
-            <a:r>
-              <a:rPr b="1" sz="1350">
-                <a:solidFill>
-                  <a:srgbClr val="2563EB"/>
+              <a:t>• Work Schedule: </a:t>
+            </a:r>
+            <a:r>
+              <a:rPr b="0">
+                <a:solidFill>
+                  <a:srgbClr val="1E293B"/>
                 </a:solidFill>
               </a:rPr>
-              <a:t>24 hrs / week</a:t>
+              <a:t>24 hours / week</a:t>
             </a:r>
           </a:p>
           <a:p>
             <a:pPr>
               <a:spcAft>
-                <a:spcPts val="400"/>
+                <a:spcPts val="800"/>
               </a:spcAft>
-              <a:defRPr sz="1000">
-                <a:solidFill>
-                  <a:srgbClr val="475569"/>
-                </a:solidFill>
-                <a:latin typeface="Segoe UI"/>
-              </a:defRPr>
-            </a:pPr>
-            <a:r>
-              <a:t>   ↳ Part-time school-year schedule</a:t>
-            </a:r>
-          </a:p>
-          <a:p>
-            <a:pPr>
-              <a:defRPr b="1" sz="1250">
+              <a:defRPr b="1" sz="1200">
                 <a:solidFill>
                   <a:srgbClr val="0F172A"/>
                 </a:solidFill>
@@ -3478,36 +3442,23 @@
               </a:defRPr>
             </a:pPr>
             <a:r>
-              <a:t>Gross Weekly Income: </a:t>
-            </a:r>
-            <a:r>
-              <a:rPr b="1" sz="1350">
-                <a:solidFill>
-                  <a:srgbClr val="2563EB"/>
+              <a:t>• Gross Weekly Pay: </a:t>
+            </a:r>
+            <a:r>
+              <a:rPr b="0">
+                <a:solidFill>
+                  <a:srgbClr val="1E293B"/>
                 </a:solidFill>
               </a:rPr>
-              <a:t>$342.00 / week</a:t>
+              <a:t>$342.00 / week ($14.25 × 24 hrs)</a:t>
             </a:r>
           </a:p>
           <a:p>
             <a:pPr>
               <a:spcAft>
-                <a:spcPts val="400"/>
+                <a:spcPts val="800"/>
               </a:spcAft>
-              <a:defRPr sz="1000">
-                <a:solidFill>
-                  <a:srgbClr val="475569"/>
-                </a:solidFill>
-                <a:latin typeface="Segoe UI"/>
-              </a:defRPr>
-            </a:pPr>
-            <a:r>
-              <a:t>   ↳ 24 hours × $14.25 / hr</a:t>
-            </a:r>
-          </a:p>
-          <a:p>
-            <a:pPr>
-              <a:defRPr b="1" sz="1250">
+              <a:defRPr b="1" sz="1200">
                 <a:solidFill>
                   <a:srgbClr val="0F172A"/>
                 </a:solidFill>
@@ -3515,31 +3466,15 @@
               </a:defRPr>
             </a:pPr>
             <a:r>
-              <a:t>Gross Monthly Income: </a:t>
-            </a:r>
-            <a:r>
-              <a:rPr b="1" sz="1350">
-                <a:solidFill>
-                  <a:srgbClr val="2563EB"/>
+              <a:t>• Gross Monthly Pay: </a:t>
+            </a:r>
+            <a:r>
+              <a:rPr b="0">
+                <a:solidFill>
+                  <a:srgbClr val="1E293B"/>
                 </a:solidFill>
               </a:rPr>
-              <a:t>$1,368.00 / mo</a:t>
-            </a:r>
-          </a:p>
-          <a:p>
-            <a:pPr>
-              <a:spcAft>
-                <a:spcPts val="400"/>
-              </a:spcAft>
-              <a:defRPr sz="1000">
-                <a:solidFill>
-                  <a:srgbClr val="475569"/>
-                </a:solidFill>
-                <a:latin typeface="Segoe UI"/>
-              </a:defRPr>
-            </a:pPr>
-            <a:r>
-              <a:t>   ↳ $342.00 / week × 4 weeks</a:t>
+              <a:t>$1,368.00 / month ($342 × 4 weeks)</a:t>
             </a:r>
           </a:p>
         </p:txBody>
@@ -3552,8 +3487,8 @@
         </p:nvSpPr>
         <p:spPr>
           <a:xfrm>
-            <a:off x="1051560" y="4663440"/>
-            <a:ext cx="5577840" cy="1371600"/>
+            <a:off x="1051560" y="4480560"/>
+            <a:ext cx="5212080" cy="1554480"/>
           </a:xfrm>
           <a:prstGeom prst="roundRect">
             <a:avLst/>
@@ -3582,11 +3517,11 @@
           </a:fontRef>
         </p:style>
         <p:txBody>
-          <a:bodyPr rtlCol="0" anchor="ctr" lIns="274320" rIns="274320" tIns="164592"/>
+          <a:bodyPr rtlCol="0" anchor="ctr" lIns="274320" rIns="274320" tIns="182880"/>
           <a:lstStyle/>
           <a:p>
             <a:pPr algn="ctr">
-              <a:defRPr sz="1000" b="1">
+              <a:defRPr sz="1100" b="1">
                 <a:solidFill>
                   <a:srgbClr val="D97706"/>
                 </a:solidFill>
@@ -3594,12 +3529,12 @@
               </a:defRPr>
             </a:pPr>
             <a:r>
-              <a:t>11% TRANSPORTATION BUDGET GUIDELINE</a:t>
+              <a:t>11% TRANSPORTATION BUDGET</a:t>
             </a:r>
           </a:p>
           <a:p>
             <a:pPr>
-              <a:defRPr sz="2000" b="1">
+              <a:defRPr sz="2200" b="1">
                 <a:solidFill>
                   <a:srgbClr val="0F172A"/>
                 </a:solidFill>
@@ -3612,7 +3547,7 @@
           </a:p>
           <a:p>
             <a:pPr>
-              <a:defRPr sz="950">
+              <a:defRPr sz="1000">
                 <a:solidFill>
                   <a:srgbClr val="475569"/>
                 </a:solidFill>
@@ -3620,7 +3555,7 @@
               </a:defRPr>
             </a:pPr>
             <a:r>
-              <a:t>Calculation: $1,368.00 gross monthly income × 0.11 baseline budget allocation.</a:t>
+              <a:t>Calculation: $1,368.00 gross monthly pay × 0.11 budget allocation.</a:t>
             </a:r>
           </a:p>
         </p:txBody>
@@ -3633,8 +3568,8 @@
         </p:nvSpPr>
         <p:spPr>
           <a:xfrm>
-            <a:off x="7132320" y="1371600"/>
-            <a:ext cx="4327855" cy="4937760"/>
+            <a:off x="6858000" y="1371600"/>
+            <a:ext cx="4602175" cy="4937760"/>
           </a:xfrm>
           <a:prstGeom prst="roundRect">
             <a:avLst/>
@@ -3686,8 +3621,8 @@
         </p:blipFill>
         <p:spPr>
           <a:xfrm>
-            <a:off x="7360920" y="1600200"/>
-            <a:ext cx="3870655" cy="2834640"/>
+            <a:off x="7086600" y="1600200"/>
+            <a:ext cx="4144975" cy="3017520"/>
           </a:xfrm>
           <a:prstGeom prst="rect">
             <a:avLst/>
@@ -3702,8 +3637,8 @@
         </p:nvSpPr>
         <p:spPr>
           <a:xfrm>
-            <a:off x="7360920" y="4617720"/>
-            <a:ext cx="3870655" cy="1417320"/>
+            <a:off x="7086600" y="4800600"/>
+            <a:ext cx="4144975" cy="1234440"/>
           </a:xfrm>
           <a:prstGeom prst="roundRect">
             <a:avLst/>
@@ -3732,11 +3667,11 @@
           </a:fontRef>
         </p:style>
         <p:txBody>
-          <a:bodyPr rtlCol="0" anchor="ctr" lIns="228600" rIns="228600" tIns="164592"/>
+          <a:bodyPr rtlCol="0" anchor="ctr" lIns="228600" rIns="228600" tIns="182880"/>
           <a:lstStyle/>
           <a:p>
             <a:pPr algn="ctr">
-              <a:defRPr sz="1000" b="1">
+              <a:defRPr sz="1100" b="1">
                 <a:solidFill>
                   <a:srgbClr val="2563EB"/>
                 </a:solidFill>
@@ -3744,12 +3679,12 @@
               </a:defRPr>
             </a:pPr>
             <a:r>
-              <a:t>RELIABLE CASH FLOW FOUNDATION</a:t>
+              <a:t>Target Employment</a:t>
             </a:r>
           </a:p>
           <a:p>
             <a:pPr>
-              <a:defRPr sz="1000">
+              <a:defRPr sz="1050">
                 <a:solidFill>
                   <a:srgbClr val="1E293B"/>
                 </a:solidFill>
@@ -3757,7 +3692,7 @@
               </a:defRPr>
             </a:pPr>
             <a:r>
-              <a:t>Consistent hourly employment provides the income stream necessary to finance and operate a vehicle responsibly during high school while building personal savings.</a:t>
+              <a:t>Working 24 hours per week at Target earns $1,368/month to pay for a car and build savings.</a:t>
             </a:r>
           </a:p>
         </p:txBody>
@@ -3832,7 +3767,7 @@
         <p:spPr>
           <a:xfrm>
             <a:off x="731520" y="365760"/>
-            <a:ext cx="2377440" cy="292608"/>
+            <a:ext cx="2103120" cy="292608"/>
           </a:xfrm>
           <a:prstGeom prst="roundRect">
             <a:avLst/>
@@ -3861,7 +3796,7 @@
           </a:fontRef>
         </p:style>
         <p:txBody>
-          <a:bodyPr rtlCol="0" anchor="ctr" wrap="square" tIns="0"/>
+          <a:bodyPr rtlCol="0" anchor="ctr" tIns="0"/>
           <a:lstStyle/>
           <a:p>
             <a:pPr algn="ctr">
@@ -3873,7 +3808,7 @@
               </a:defRPr>
             </a:pPr>
             <a:r>
-              <a:t>PRIMARY VEHICLE CHOICE</a:t>
+              <a:t>CAR #1</a:t>
             </a:r>
           </a:p>
         </p:txBody>
@@ -3895,7 +3830,7 @@
           <a:noFill/>
         </p:spPr>
         <p:txBody>
-          <a:bodyPr wrap="square" tIns="0">
+          <a:bodyPr wrap="none" tIns="0">
             <a:spAutoFit/>
           </a:bodyPr>
           <a:lstStyle/>
@@ -4119,11 +4054,11 @@
           </a:fontRef>
         </p:style>
         <p:txBody>
-          <a:bodyPr rtlCol="0" anchor="ctr" tIns="137160"/>
+          <a:bodyPr rtlCol="0" anchor="ctr" tIns="164592"/>
           <a:lstStyle/>
           <a:p>
             <a:pPr algn="ctr">
-              <a:defRPr sz="950" b="1">
+              <a:defRPr sz="1000" b="1">
                 <a:solidFill>
                   <a:srgbClr val="2563EB"/>
                 </a:solidFill>
@@ -4145,19 +4080,6 @@
             </a:pPr>
             <a:r>
               <a:t>$11,376</a:t>
-            </a:r>
-          </a:p>
-          <a:p>
-            <a:pPr algn="ctr">
-              <a:defRPr sz="950">
-                <a:solidFill>
-                  <a:srgbClr val="475569"/>
-                </a:solidFill>
-                <a:latin typeface="Segoe UI"/>
-              </a:defRPr>
-            </a:pPr>
-            <a:r>
-              <a:t>Under $20K project limit</a:t>
             </a:r>
           </a:p>
         </p:txBody>
@@ -4200,11 +4122,11 @@
           </a:fontRef>
         </p:style>
         <p:txBody>
-          <a:bodyPr rtlCol="0" anchor="ctr" tIns="137160"/>
+          <a:bodyPr rtlCol="0" anchor="ctr" tIns="164592"/>
           <a:lstStyle/>
           <a:p>
             <a:pPr algn="ctr">
-              <a:defRPr sz="950" b="1">
+              <a:defRPr sz="1000" b="1">
                 <a:solidFill>
                   <a:srgbClr val="D97706"/>
                 </a:solidFill>
@@ -4252,7 +4174,7 @@
         <p:spPr>
           <a:xfrm>
             <a:off x="6080760" y="1371600"/>
-            <a:ext cx="5379415" cy="1508760"/>
+            <a:ext cx="5379415" cy="2834640"/>
           </a:xfrm>
           <a:prstGeom prst="roundRect">
             <a:avLst/>
@@ -4281,11 +4203,14 @@
           </a:fontRef>
         </p:style>
         <p:txBody>
-          <a:bodyPr rtlCol="0" anchor="ctr" lIns="274320" rIns="274320" tIns="164592"/>
+          <a:bodyPr rtlCol="0" anchor="ctr" lIns="320040" rIns="320040" tIns="228600"/>
           <a:lstStyle/>
           <a:p>
             <a:pPr algn="ctr">
-              <a:defRPr sz="1000" b="1">
+              <a:spcAft>
+                <a:spcPts val="800"/>
+              </a:spcAft>
+              <a:defRPr sz="1300" b="1">
                 <a:solidFill>
                   <a:srgbClr val="2563EB"/>
                 </a:solidFill>
@@ -4293,12 +4218,15 @@
               </a:defRPr>
             </a:pPr>
             <a:r>
-              <a:t>TECHNOLOGY &amp; CONVENIENCE</a:t>
+              <a:t>Features &amp; Safety Options</a:t>
             </a:r>
           </a:p>
           <a:p>
             <a:pPr>
-              <a:defRPr sz="1050">
+              <a:spcAft>
+                <a:spcPts val="400"/>
+              </a:spcAft>
+              <a:defRPr sz="1100">
                 <a:solidFill>
                   <a:srgbClr val="1E293B"/>
                 </a:solidFill>
@@ -4306,19 +4234,71 @@
               </a:defRPr>
             </a:pPr>
             <a:r>
-              <a:t>• Apple CarPlay &amp; Android Auto seamless smartphone connectivity</a:t>
-            </a:r>
-            <a:br/>
-            <a:r>
-              <a:t>• Keyless start &amp; remote entry with push-button ignition</a:t>
-            </a:r>
-            <a:br/>
-            <a:r>
-              <a:t>• Rearview backup camera &amp; automatic parking assistance</a:t>
-            </a:r>
-            <a:br/>
-            <a:r>
-              <a:t>• 8-inch digital touchscreen display with Bluetooth audio</a:t>
+              <a:t>• Apple CarPlay and Android Auto smartphone connection</a:t>
+            </a:r>
+          </a:p>
+          <a:p>
+            <a:pPr>
+              <a:spcAft>
+                <a:spcPts val="400"/>
+              </a:spcAft>
+              <a:defRPr sz="1100">
+                <a:solidFill>
+                  <a:srgbClr val="1E293B"/>
+                </a:solidFill>
+                <a:latin typeface="Segoe UI"/>
+              </a:defRPr>
+            </a:pPr>
+            <a:r>
+              <a:t>• Backup camera and automatic emergency braking</a:t>
+            </a:r>
+          </a:p>
+          <a:p>
+            <a:pPr>
+              <a:spcAft>
+                <a:spcPts val="400"/>
+              </a:spcAft>
+              <a:defRPr sz="1100">
+                <a:solidFill>
+                  <a:srgbClr val="1E293B"/>
+                </a:solidFill>
+                <a:latin typeface="Segoe UI"/>
+              </a:defRPr>
+            </a:pPr>
+            <a:r>
+              <a:t>• Keyless entry with push-button start</a:t>
+            </a:r>
+          </a:p>
+          <a:p>
+            <a:pPr>
+              <a:spcAft>
+                <a:spcPts val="400"/>
+              </a:spcAft>
+              <a:defRPr sz="1100">
+                <a:solidFill>
+                  <a:srgbClr val="1E293B"/>
+                </a:solidFill>
+                <a:latin typeface="Segoe UI"/>
+              </a:defRPr>
+            </a:pPr>
+            <a:r>
+              <a:t>• Blind spot warning and lane departure alerts</a:t>
+            </a:r>
+          </a:p>
+          <a:p>
+            <a:pPr>
+              <a:spcAft>
+                <a:spcPts val="400"/>
+              </a:spcAft>
+              <a:defRPr sz="1100">
+                <a:solidFill>
+                  <a:srgbClr val="1E293B"/>
+                </a:solidFill>
+                <a:latin typeface="Segoe UI"/>
+              </a:defRPr>
+            </a:pPr>
+            <a:r>
+              <a:t>• Intelligent all-wheel drive (AWD) for rain and snow</a:t>
             </a:r>
           </a:p>
         </p:txBody>
@@ -4331,8 +4311,8 @@
         </p:nvSpPr>
         <p:spPr>
           <a:xfrm>
-            <a:off x="6080760" y="3017520"/>
-            <a:ext cx="5379415" cy="1600200"/>
+            <a:off x="6080760" y="4389120"/>
+            <a:ext cx="5379415" cy="1920240"/>
           </a:xfrm>
           <a:prstGeom prst="roundRect">
             <a:avLst/>
@@ -4361,24 +4341,27 @@
           </a:fontRef>
         </p:style>
         <p:txBody>
-          <a:bodyPr rtlCol="0" anchor="ctr" lIns="274320" rIns="274320" tIns="164592"/>
+          <a:bodyPr rtlCol="0" anchor="ctr" lIns="320040" rIns="320040" tIns="228600"/>
           <a:lstStyle/>
           <a:p>
             <a:pPr algn="ctr">
-              <a:defRPr sz="1000" b="1">
-                <a:solidFill>
-                  <a:srgbClr val="059669"/>
-                </a:solidFill>
-                <a:latin typeface="Segoe UI"/>
-              </a:defRPr>
-            </a:pPr>
-            <a:r>
-              <a:t>ACTIVE SAFETY &amp; TRACTION</a:t>
+              <a:spcAft>
+                <a:spcPts val="600"/>
+              </a:spcAft>
+              <a:defRPr sz="1300" b="1">
+                <a:solidFill>
+                  <a:srgbClr val="0F172A"/>
+                </a:solidFill>
+                <a:latin typeface="Segoe UI"/>
+              </a:defRPr>
+            </a:pPr>
+            <a:r>
+              <a:t>Why I Chose This Car</a:t>
             </a:r>
           </a:p>
           <a:p>
             <a:pPr>
-              <a:defRPr sz="1050">
+              <a:defRPr sz="1100">
                 <a:solidFill>
                   <a:srgbClr val="1E293B"/>
                 </a:solidFill>
@@ -4386,87 +4369,7 @@
               </a:defRPr>
             </a:pPr>
             <a:r>
-              <a:t>• Intelligent All-Wheel Drive (AWD / 4WD) for safe snow and rain control</a:t>
-            </a:r>
-            <a:br/>
-            <a:r>
-              <a:t>• Automatic Emergency Braking with Pedestrian Detection</a:t>
-            </a:r>
-            <a:br/>
-            <a:r>
-              <a:t>• Lane Departure Warning &amp; Blind Spot Warning system</a:t>
-            </a:r>
-            <a:br/>
-            <a:r>
-              <a:t>• Rear Cross-Traffic Alert and comprehensive airbag canopy</a:t>
-            </a:r>
-          </a:p>
-        </p:txBody>
-      </p:sp>
-      <p:sp>
-        <p:nvSpPr>
-          <p:cNvPr id="13" name="Rounded Rectangle 12"/>
-          <p:cNvSpPr/>
-          <p:nvPr/>
-        </p:nvSpPr>
-        <p:spPr>
-          <a:xfrm>
-            <a:off x="6080760" y="4754880"/>
-            <a:ext cx="5379415" cy="1554480"/>
-          </a:xfrm>
-          <a:prstGeom prst="roundRect">
-            <a:avLst/>
-          </a:prstGeom>
-          <a:solidFill>
-            <a:srgbClr val="FFFFFF"/>
-          </a:solidFill>
-          <a:ln w="12700">
-            <a:solidFill>
-              <a:srgbClr val="E2E8F0"/>
-            </a:solidFill>
-          </a:ln>
-        </p:spPr>
-        <p:style>
-          <a:lnRef idx="1">
-            <a:schemeClr val="accent1"/>
-          </a:lnRef>
-          <a:fillRef idx="3">
-            <a:schemeClr val="accent1"/>
-          </a:fillRef>
-          <a:effectRef idx="2">
-            <a:schemeClr val="accent1"/>
-          </a:effectRef>
-          <a:fontRef idx="minor">
-            <a:schemeClr val="lt1"/>
-          </a:fontRef>
-        </p:style>
-        <p:txBody>
-          <a:bodyPr rtlCol="0" anchor="ctr" lIns="274320" rIns="274320" tIns="164592"/>
-          <a:lstStyle/>
-          <a:p>
-            <a:pPr algn="ctr">
-              <a:defRPr sz="1000" b="1">
-                <a:solidFill>
-                  <a:srgbClr val="0F172A"/>
-                </a:solidFill>
-                <a:latin typeface="Segoe UI"/>
-              </a:defRPr>
-            </a:pPr>
-            <a:r>
-              <a:t>WHY THIS VEHICLE WAS CHOSEN</a:t>
-            </a:r>
-          </a:p>
-          <a:p>
-            <a:pPr>
-              <a:defRPr i="1" sz="1050">
-                <a:solidFill>
-                  <a:srgbClr val="475569"/>
-                </a:solidFill>
-                <a:latin typeface="Segoe UI"/>
-              </a:defRPr>
-            </a:pPr>
-            <a:r>
-              <a:t>"Verified clean history with zero accident reports, no exterior or structural damage, all-weather AWD capability crucial for winter commuting, and exceptional overall value at $11,376."</a:t>
+              <a:t>Clean Carfax with no accident reports, no exterior damage, reliable all-wheel drive for winter weather, and well under the $20,000 budget.</a:t>
             </a:r>
           </a:p>
         </p:txBody>
@@ -4541,7 +4444,7 @@
         <p:spPr>
           <a:xfrm>
             <a:off x="731520" y="365760"/>
-            <a:ext cx="2377440" cy="292608"/>
+            <a:ext cx="2103120" cy="292608"/>
           </a:xfrm>
           <a:prstGeom prst="roundRect">
             <a:avLst/>
@@ -4570,7 +4473,7 @@
           </a:fontRef>
         </p:style>
         <p:txBody>
-          <a:bodyPr rtlCol="0" anchor="ctr" wrap="square" tIns="0"/>
+          <a:bodyPr rtlCol="0" anchor="ctr" tIns="0"/>
           <a:lstStyle/>
           <a:p>
             <a:pPr algn="ctr">
@@ -4582,7 +4485,7 @@
               </a:defRPr>
             </a:pPr>
             <a:r>
-              <a:t>COMPARATIVE LOAN ANALYSIS</a:t>
+              <a:t>FINANCING</a:t>
             </a:r>
           </a:p>
         </p:txBody>
@@ -4604,7 +4507,7 @@
           <a:noFill/>
         </p:spPr>
         <p:txBody>
-          <a:bodyPr wrap="square" tIns="0">
+          <a:bodyPr wrap="none" tIns="0">
             <a:spAutoFit/>
           </a:bodyPr>
           <a:lstStyle/>
@@ -4618,7 +4521,7 @@
               </a:defRPr>
             </a:pPr>
             <a:r>
-              <a:t>Car #1 Financing Breakdown: Nissan Rogue</a:t>
+              <a:t>Car #1 Financing: Nissan Rogue Loans</a:t>
             </a:r>
           </a:p>
         </p:txBody>
@@ -4730,7 +4633,7 @@
         <p:spPr>
           <a:xfrm>
             <a:off x="731520" y="1371600"/>
-            <a:ext cx="4114800" cy="3474720"/>
+            <a:ext cx="5212080" cy="3383280"/>
           </a:xfrm>
           <a:prstGeom prst="roundRect">
             <a:avLst/>
@@ -4759,10 +4662,23 @@
           </a:fontRef>
         </p:style>
         <p:txBody>
-          <a:bodyPr rtlCol="0" anchor="ctr" tIns="502920" lIns="274320" rIns="274320"/>
+          <a:bodyPr rtlCol="0" anchor="ctr" lIns="365760" rIns="365760" tIns="228600"/>
           <a:lstStyle/>
           <a:p>
             <a:pPr algn="ctr">
+              <a:defRPr sz="1100" b="1">
+                <a:solidFill>
+                  <a:srgbClr val="059669"/>
+                </a:solidFill>
+                <a:latin typeface="Segoe UI"/>
+              </a:defRPr>
+            </a:pPr>
+            <a:r>
+              <a:t>LOAN A (PARENTS) — RECOMMENDED</a:t>
+            </a:r>
+          </a:p>
+          <a:p>
+            <a:pPr>
               <a:spcAft>
                 <a:spcPts val="800"/>
               </a:spcAft>
@@ -4782,24 +4698,15 @@
               <a:spcAft>
                 <a:spcPts val="300"/>
               </a:spcAft>
-              <a:defRPr b="1" sz="1050">
-                <a:solidFill>
-                  <a:srgbClr val="0F172A"/>
-                </a:solidFill>
-                <a:latin typeface="Segoe UI"/>
-              </a:defRPr>
-            </a:pPr>
-            <a:r>
-              <a:t>• Terms: </a:t>
-            </a:r>
-            <a:r>
-              <a:rPr b="0">
+              <a:defRPr sz="1100" b="0">
                 <a:solidFill>
                   <a:srgbClr val="1E293B"/>
                 </a:solidFill>
                 <a:latin typeface="Segoe UI"/>
-              </a:rPr>
-              <a:t>4.2% Simple APR / 5 Years (60 Months)</a:t>
+              </a:defRPr>
+            </a:pPr>
+            <a:r>
+              <a:t>• 4.2% Simple Interest / 5 Years (60 months)</a:t>
             </a:r>
           </a:p>
           <a:p>
@@ -4807,24 +4714,15 @@
               <a:spcAft>
                 <a:spcPts val="300"/>
               </a:spcAft>
-              <a:defRPr b="1" sz="1050">
-                <a:solidFill>
-                  <a:srgbClr val="0F172A"/>
-                </a:solidFill>
-                <a:latin typeface="Segoe UI"/>
-              </a:defRPr>
-            </a:pPr>
-            <a:r>
-              <a:t>• Interest Formula: </a:t>
-            </a:r>
-            <a:r>
-              <a:rPr b="0">
+              <a:defRPr sz="1100" b="0">
                 <a:solidFill>
                   <a:srgbClr val="1E293B"/>
                 </a:solidFill>
                 <a:latin typeface="Segoe UI"/>
-              </a:rPr>
-              <a:t>I = $11,376 × 0.042 × 5 = $2,388.96</a:t>
+              </a:defRPr>
+            </a:pPr>
+            <a:r>
+              <a:t>• Interest: $11,376 × 0.042 × 5 = $2,388.96</a:t>
             </a:r>
           </a:p>
           <a:p>
@@ -4832,24 +4730,15 @@
               <a:spcAft>
                 <a:spcPts val="300"/>
               </a:spcAft>
-              <a:defRPr b="1" sz="1050">
-                <a:solidFill>
-                  <a:srgbClr val="0F172A"/>
-                </a:solidFill>
-                <a:latin typeface="Segoe UI"/>
-              </a:defRPr>
-            </a:pPr>
-            <a:r>
-              <a:t>• Total Repayment: </a:t>
-            </a:r>
-            <a:r>
-              <a:rPr b="0">
+              <a:defRPr sz="1100" b="0">
                 <a:solidFill>
                   <a:srgbClr val="1E293B"/>
                 </a:solidFill>
                 <a:latin typeface="Segoe UI"/>
-              </a:rPr>
-              <a:t>$11,376 + $2,388.96 = $13,764.96</a:t>
+              </a:defRPr>
+            </a:pPr>
+            <a:r>
+              <a:t>• Total Cost: $11,376 + $2,388.96 = $13,764.96</a:t>
             </a:r>
           </a:p>
           <a:p>
@@ -4857,24 +4746,15 @@
               <a:spcAft>
                 <a:spcPts val="300"/>
               </a:spcAft>
-              <a:defRPr b="1" sz="1050">
-                <a:solidFill>
-                  <a:srgbClr val="0F172A"/>
-                </a:solidFill>
-                <a:latin typeface="Segoe UI"/>
-              </a:defRPr>
-            </a:pPr>
-            <a:r>
-              <a:t>• Monthly Payment: </a:t>
-            </a:r>
-            <a:r>
-              <a:rPr b="0">
+              <a:defRPr sz="1100" b="0">
                 <a:solidFill>
                   <a:srgbClr val="1E293B"/>
                 </a:solidFill>
                 <a:latin typeface="Segoe UI"/>
-              </a:rPr>
-              <a:t>$13,764.96 ÷ 60 months = $229.42 / mo</a:t>
+              </a:defRPr>
+            </a:pPr>
+            <a:r>
+              <a:t>• Monthly Payment: $13,764.96 ÷ 60 = $229.42 / mo</a:t>
             </a:r>
           </a:p>
           <a:p>
@@ -4882,24 +4762,15 @@
               <a:spcAft>
                 <a:spcPts val="300"/>
               </a:spcAft>
-              <a:defRPr b="1" sz="1050">
-                <a:solidFill>
-                  <a:srgbClr val="0F172A"/>
-                </a:solidFill>
-                <a:latin typeface="Segoe UI"/>
-              </a:defRPr>
-            </a:pPr>
-            <a:r>
-              <a:t>• Interest Benefit: </a:t>
-            </a:r>
-            <a:r>
-              <a:rPr b="1">
+              <a:defRPr sz="1100" b="1">
                 <a:solidFill>
                   <a:srgbClr val="059669"/>
                 </a:solidFill>
                 <a:latin typeface="Segoe UI"/>
-              </a:rPr>
-              <a:t>Saves $1,683.12 in total interest vs. Bank!</a:t>
+              </a:defRPr>
+            </a:pPr>
+            <a:r>
+              <a:t>• Saves $1,683.12 in interest compared to the bank loan.</a:t>
             </a:r>
           </a:p>
         </p:txBody>
@@ -4912,8 +4783,159 @@
         </p:nvSpPr>
         <p:spPr>
           <a:xfrm>
-            <a:off x="731520" y="1371600"/>
-            <a:ext cx="4114800" cy="365760"/>
+            <a:off x="6248095" y="1371600"/>
+            <a:ext cx="5212080" cy="3383280"/>
+          </a:xfrm>
+          <a:prstGeom prst="roundRect">
+            <a:avLst/>
+          </a:prstGeom>
+          <a:solidFill>
+            <a:srgbClr val="FFFFFF"/>
+          </a:solidFill>
+          <a:ln w="12700">
+            <a:solidFill>
+              <a:srgbClr val="E2E8F0"/>
+            </a:solidFill>
+          </a:ln>
+        </p:spPr>
+        <p:style>
+          <a:lnRef idx="1">
+            <a:schemeClr val="accent1"/>
+          </a:lnRef>
+          <a:fillRef idx="3">
+            <a:schemeClr val="accent1"/>
+          </a:fillRef>
+          <a:effectRef idx="2">
+            <a:schemeClr val="accent1"/>
+          </a:effectRef>
+          <a:fontRef idx="minor">
+            <a:schemeClr val="lt1"/>
+          </a:fontRef>
+        </p:style>
+        <p:txBody>
+          <a:bodyPr rtlCol="0" anchor="ctr" lIns="365760" rIns="365760" tIns="228600"/>
+          <a:lstStyle/>
+          <a:p>
+            <a:pPr algn="ctr">
+              <a:defRPr sz="1100" b="1">
+                <a:solidFill>
+                  <a:srgbClr val="2563EB"/>
+                </a:solidFill>
+                <a:latin typeface="Segoe UI"/>
+              </a:defRPr>
+            </a:pPr>
+            <a:r>
+              <a:t>LOAN B (COMMERCIAL BANK)</a:t>
+            </a:r>
+          </a:p>
+          <a:p>
+            <a:pPr>
+              <a:spcAft>
+                <a:spcPts val="800"/>
+              </a:spcAft>
+              <a:defRPr sz="2400" b="1">
+                <a:solidFill>
+                  <a:srgbClr val="0F172A"/>
+                </a:solidFill>
+                <a:latin typeface="Segoe UI"/>
+              </a:defRPr>
+            </a:pPr>
+            <a:r>
+              <a:t>$214.56 / month</a:t>
+            </a:r>
+          </a:p>
+          <a:p>
+            <a:pPr>
+              <a:spcAft>
+                <a:spcPts val="300"/>
+              </a:spcAft>
+              <a:defRPr sz="1100">
+                <a:solidFill>
+                  <a:srgbClr val="1E293B"/>
+                </a:solidFill>
+                <a:latin typeface="Segoe UI"/>
+              </a:defRPr>
+            </a:pPr>
+            <a:r>
+              <a:t>• 5.1% Compound Interest (Daily) / 6 Years (72 months)</a:t>
+            </a:r>
+          </a:p>
+          <a:p>
+            <a:pPr>
+              <a:spcAft>
+                <a:spcPts val="300"/>
+              </a:spcAft>
+              <a:defRPr sz="1100">
+                <a:solidFill>
+                  <a:srgbClr val="1E293B"/>
+                </a:solidFill>
+                <a:latin typeface="Segoe UI"/>
+              </a:defRPr>
+            </a:pPr>
+            <a:r>
+              <a:t>• Formula: $11,376 × (1 + 0.051/365)^2190 = $15,448.08</a:t>
+            </a:r>
+          </a:p>
+          <a:p>
+            <a:pPr>
+              <a:spcAft>
+                <a:spcPts val="300"/>
+              </a:spcAft>
+              <a:defRPr sz="1100">
+                <a:solidFill>
+                  <a:srgbClr val="1E293B"/>
+                </a:solidFill>
+                <a:latin typeface="Segoe UI"/>
+              </a:defRPr>
+            </a:pPr>
+            <a:r>
+              <a:t>• Total Interest Paid: $15,448.08 - $11,376 = $4,072.08</a:t>
+            </a:r>
+          </a:p>
+          <a:p>
+            <a:pPr>
+              <a:spcAft>
+                <a:spcPts val="300"/>
+              </a:spcAft>
+              <a:defRPr sz="1100">
+                <a:solidFill>
+                  <a:srgbClr val="1E293B"/>
+                </a:solidFill>
+                <a:latin typeface="Segoe UI"/>
+              </a:defRPr>
+            </a:pPr>
+            <a:r>
+              <a:t>• Monthly Payment: $15,448.08 ÷ 72 = $214.56 / mo</a:t>
+            </a:r>
+          </a:p>
+          <a:p>
+            <a:pPr>
+              <a:spcAft>
+                <a:spcPts val="300"/>
+              </a:spcAft>
+              <a:defRPr sz="1100">
+                <a:solidFill>
+                  <a:srgbClr val="1E293B"/>
+                </a:solidFill>
+                <a:latin typeface="Segoe UI"/>
+              </a:defRPr>
+            </a:pPr>
+            <a:r>
+              <a:t>• Daily compounding adds $1,683 in extra interest.</a:t>
+            </a:r>
+          </a:p>
+        </p:txBody>
+      </p:sp>
+      <p:sp>
+        <p:nvSpPr>
+          <p:cNvPr id="9" name="Rounded Rectangle 8"/>
+          <p:cNvSpPr/>
+          <p:nvPr/>
+        </p:nvSpPr>
+        <p:spPr>
+          <a:xfrm>
+            <a:off x="731520" y="4983480"/>
+            <a:ext cx="10728655" cy="1325880"/>
           </a:xfrm>
           <a:prstGeom prst="roundRect">
             <a:avLst/>
@@ -4942,391 +4964,6 @@
           </a:fontRef>
         </p:style>
         <p:txBody>
-          <a:bodyPr rtlCol="0" anchor="ctr"/>
-          <a:lstStyle/>
-          <a:p>
-            <a:pPr algn="ctr">
-              <a:defRPr sz="950" b="1">
-                <a:solidFill>
-                  <a:srgbClr val="059669"/>
-                </a:solidFill>
-                <a:latin typeface="Segoe UI"/>
-              </a:defRPr>
-            </a:pPr>
-            <a:r>
-              <a:t>★ RECOMMENDED: LOAN A (PARENTS SIMPLE INTEREST)</a:t>
-            </a:r>
-          </a:p>
-        </p:txBody>
-      </p:sp>
-      <p:sp>
-        <p:nvSpPr>
-          <p:cNvPr id="9" name="Rounded Rectangle 8"/>
-          <p:cNvSpPr/>
-          <p:nvPr/>
-        </p:nvSpPr>
-        <p:spPr>
-          <a:xfrm>
-            <a:off x="5029200" y="1371600"/>
-            <a:ext cx="4114800" cy="3474720"/>
-          </a:xfrm>
-          <a:prstGeom prst="roundRect">
-            <a:avLst/>
-          </a:prstGeom>
-          <a:solidFill>
-            <a:srgbClr val="FFFFFF"/>
-          </a:solidFill>
-          <a:ln w="12700">
-            <a:solidFill>
-              <a:srgbClr val="E2E8F0"/>
-            </a:solidFill>
-          </a:ln>
-        </p:spPr>
-        <p:style>
-          <a:lnRef idx="1">
-            <a:schemeClr val="accent1"/>
-          </a:lnRef>
-          <a:fillRef idx="3">
-            <a:schemeClr val="accent1"/>
-          </a:fillRef>
-          <a:effectRef idx="2">
-            <a:schemeClr val="accent1"/>
-          </a:effectRef>
-          <a:fontRef idx="minor">
-            <a:schemeClr val="lt1"/>
-          </a:fontRef>
-        </p:style>
-        <p:txBody>
-          <a:bodyPr rtlCol="0" anchor="ctr" tIns="502920" lIns="274320" rIns="274320"/>
-          <a:lstStyle/>
-          <a:p>
-            <a:pPr algn="ctr">
-              <a:spcAft>
-                <a:spcPts val="800"/>
-              </a:spcAft>
-              <a:defRPr sz="2400" b="1">
-                <a:solidFill>
-                  <a:srgbClr val="0F172A"/>
-                </a:solidFill>
-                <a:latin typeface="Segoe UI"/>
-              </a:defRPr>
-            </a:pPr>
-            <a:r>
-              <a:t>$214.56 / month</a:t>
-            </a:r>
-          </a:p>
-          <a:p>
-            <a:pPr>
-              <a:spcAft>
-                <a:spcPts val="300"/>
-              </a:spcAft>
-              <a:defRPr b="1" sz="1050">
-                <a:solidFill>
-                  <a:srgbClr val="0F172A"/>
-                </a:solidFill>
-                <a:latin typeface="Segoe UI"/>
-              </a:defRPr>
-            </a:pPr>
-            <a:r>
-              <a:t>• Terms: </a:t>
-            </a:r>
-            <a:r>
-              <a:rPr>
-                <a:solidFill>
-                  <a:srgbClr val="1E293B"/>
-                </a:solidFill>
-                <a:latin typeface="Segoe UI"/>
-              </a:rPr>
-              <a:t>5.1% Compounded Daily (365) / 6 Years (72 Mos)</a:t>
-            </a:r>
-          </a:p>
-          <a:p>
-            <a:pPr>
-              <a:spcAft>
-                <a:spcPts val="300"/>
-              </a:spcAft>
-              <a:defRPr b="1" sz="1050">
-                <a:solidFill>
-                  <a:srgbClr val="0F172A"/>
-                </a:solidFill>
-                <a:latin typeface="Segoe UI"/>
-              </a:defRPr>
-            </a:pPr>
-            <a:r>
-              <a:t>• Compound Formula: </a:t>
-            </a:r>
-            <a:r>
-              <a:rPr>
-                <a:solidFill>
-                  <a:srgbClr val="1E293B"/>
-                </a:solidFill>
-                <a:latin typeface="Segoe UI"/>
-              </a:rPr>
-              <a:t>$11,376 × (1 + 0.051/365)^2190</a:t>
-            </a:r>
-          </a:p>
-          <a:p>
-            <a:pPr>
-              <a:spcAft>
-                <a:spcPts val="300"/>
-              </a:spcAft>
-              <a:defRPr b="1" sz="1050">
-                <a:solidFill>
-                  <a:srgbClr val="0F172A"/>
-                </a:solidFill>
-                <a:latin typeface="Segoe UI"/>
-              </a:defRPr>
-            </a:pPr>
-            <a:r>
-              <a:t>• Total Repayment: </a:t>
-            </a:r>
-            <a:r>
-              <a:rPr>
-                <a:solidFill>
-                  <a:srgbClr val="1E293B"/>
-                </a:solidFill>
-                <a:latin typeface="Segoe UI"/>
-              </a:rPr>
-              <a:t>$15,448.08 principal + interest</a:t>
-            </a:r>
-          </a:p>
-          <a:p>
-            <a:pPr>
-              <a:spcAft>
-                <a:spcPts val="300"/>
-              </a:spcAft>
-              <a:defRPr b="1" sz="1050">
-                <a:solidFill>
-                  <a:srgbClr val="0F172A"/>
-                </a:solidFill>
-                <a:latin typeface="Segoe UI"/>
-              </a:defRPr>
-            </a:pPr>
-            <a:r>
-              <a:t>• Total Interest Paid: </a:t>
-            </a:r>
-            <a:r>
-              <a:rPr>
-                <a:solidFill>
-                  <a:srgbClr val="1E293B"/>
-                </a:solidFill>
-                <a:latin typeface="Segoe UI"/>
-              </a:rPr>
-              <a:t>$15,448.08 - $11,376 = $4,072.08</a:t>
-            </a:r>
-          </a:p>
-          <a:p>
-            <a:pPr>
-              <a:spcAft>
-                <a:spcPts val="300"/>
-              </a:spcAft>
-              <a:defRPr b="1" sz="1050">
-                <a:solidFill>
-                  <a:srgbClr val="0F172A"/>
-                </a:solidFill>
-                <a:latin typeface="Segoe UI"/>
-              </a:defRPr>
-            </a:pPr>
-            <a:r>
-              <a:t>• Monthly Payment: </a:t>
-            </a:r>
-            <a:r>
-              <a:rPr>
-                <a:solidFill>
-                  <a:srgbClr val="1E293B"/>
-                </a:solidFill>
-                <a:latin typeface="Segoe UI"/>
-              </a:rPr>
-              <a:t>$15,448.08 ÷ 72 months = $214.56 / mo</a:t>
-            </a:r>
-          </a:p>
-        </p:txBody>
-      </p:sp>
-      <p:sp>
-        <p:nvSpPr>
-          <p:cNvPr id="10" name="Rounded Rectangle 9"/>
-          <p:cNvSpPr/>
-          <p:nvPr/>
-        </p:nvSpPr>
-        <p:spPr>
-          <a:xfrm>
-            <a:off x="5029200" y="1371600"/>
-            <a:ext cx="4114800" cy="365760"/>
-          </a:xfrm>
-          <a:prstGeom prst="roundRect">
-            <a:avLst/>
-          </a:prstGeom>
-          <a:solidFill>
-            <a:srgbClr val="EFF6FF"/>
-          </a:solidFill>
-          <a:ln w="12700">
-            <a:solidFill>
-              <a:srgbClr val="BFDBFE"/>
-            </a:solidFill>
-          </a:ln>
-        </p:spPr>
-        <p:style>
-          <a:lnRef idx="1">
-            <a:schemeClr val="accent1"/>
-          </a:lnRef>
-          <a:fillRef idx="3">
-            <a:schemeClr val="accent1"/>
-          </a:fillRef>
-          <a:effectRef idx="2">
-            <a:schemeClr val="accent1"/>
-          </a:effectRef>
-          <a:fontRef idx="minor">
-            <a:schemeClr val="lt1"/>
-          </a:fontRef>
-        </p:style>
-        <p:txBody>
-          <a:bodyPr rtlCol="0" anchor="ctr"/>
-          <a:lstStyle/>
-          <a:p>
-            <a:pPr algn="ctr">
-              <a:defRPr sz="950" b="1">
-                <a:solidFill>
-                  <a:srgbClr val="2563EB"/>
-                </a:solidFill>
-                <a:latin typeface="Segoe UI"/>
-              </a:defRPr>
-            </a:pPr>
-            <a:r>
-              <a:t>LOAN B: COMMERCIAL BANK (COMPOUND INTEREST)</a:t>
-            </a:r>
-          </a:p>
-        </p:txBody>
-      </p:sp>
-      <p:sp>
-        <p:nvSpPr>
-          <p:cNvPr id="11" name="Rounded Rectangle 10"/>
-          <p:cNvSpPr/>
-          <p:nvPr/>
-        </p:nvSpPr>
-        <p:spPr>
-          <a:xfrm>
-            <a:off x="9326880" y="1371600"/>
-            <a:ext cx="2133295" cy="3474720"/>
-          </a:xfrm>
-          <a:prstGeom prst="roundRect">
-            <a:avLst/>
-          </a:prstGeom>
-          <a:solidFill>
-            <a:srgbClr val="FFFFFF"/>
-          </a:solidFill>
-          <a:ln w="12700">
-            <a:solidFill>
-              <a:srgbClr val="E2E8F0"/>
-            </a:solidFill>
-          </a:ln>
-        </p:spPr>
-        <p:style>
-          <a:lnRef idx="1">
-            <a:schemeClr val="accent1"/>
-          </a:lnRef>
-          <a:fillRef idx="3">
-            <a:schemeClr val="accent1"/>
-          </a:fillRef>
-          <a:effectRef idx="2">
-            <a:schemeClr val="accent1"/>
-          </a:effectRef>
-          <a:fontRef idx="minor">
-            <a:schemeClr val="lt1"/>
-          </a:fontRef>
-        </p:style>
-        <p:txBody>
-          <a:bodyPr rtlCol="0" anchor="ctr" tIns="2468880" lIns="182880" rIns="182880"/>
-          <a:lstStyle/>
-          <a:p>
-            <a:pPr algn="ctr">
-              <a:defRPr sz="1000" b="1">
-                <a:solidFill>
-                  <a:srgbClr val="0F172A"/>
-                </a:solidFill>
-                <a:latin typeface="Segoe UI"/>
-              </a:defRPr>
-            </a:pPr>
-            <a:r>
-              <a:t>COMPOUND TRAP:</a:t>
-            </a:r>
-          </a:p>
-          <a:p>
-            <a:pPr>
-              <a:defRPr sz="950">
-                <a:solidFill>
-                  <a:srgbClr val="475569"/>
-                </a:solidFill>
-                <a:latin typeface="Segoe UI"/>
-              </a:defRPr>
-            </a:pPr>
-            <a:r>
-              <a:t>A longer 6-year bank term lowers monthly payments by $14.86, but adds $1,683 in extra interest.</a:t>
-            </a:r>
-          </a:p>
-        </p:txBody>
-      </p:sp>
-      <p:pic>
-        <p:nvPicPr>
-          <p:cNvPr id="12" name="Picture 11" descr="financing_calculator.jpg"/>
-          <p:cNvPicPr>
-            <a:picLocks noChangeAspect="1"/>
-          </p:cNvPicPr>
-          <p:nvPr/>
-        </p:nvPicPr>
-        <p:blipFill>
-          <a:blip r:embed="rId2"/>
-          <a:stretch>
-            <a:fillRect/>
-          </a:stretch>
-        </p:blipFill>
-        <p:spPr>
-          <a:xfrm>
-            <a:off x="9464040" y="1508760"/>
-            <a:ext cx="1858975" cy="2194560"/>
-          </a:xfrm>
-          <a:prstGeom prst="rect">
-            <a:avLst/>
-          </a:prstGeom>
-        </p:spPr>
-      </p:pic>
-      <p:sp>
-        <p:nvSpPr>
-          <p:cNvPr id="13" name="Rounded Rectangle 12"/>
-          <p:cNvSpPr/>
-          <p:nvPr/>
-        </p:nvSpPr>
-        <p:spPr>
-          <a:xfrm>
-            <a:off x="731520" y="5029200"/>
-            <a:ext cx="10728655" cy="1280160"/>
-          </a:xfrm>
-          <a:prstGeom prst="roundRect">
-            <a:avLst/>
-          </a:prstGeom>
-          <a:solidFill>
-            <a:srgbClr val="ECFDF5"/>
-          </a:solidFill>
-          <a:ln w="12700">
-            <a:solidFill>
-              <a:srgbClr val="A7F3D0"/>
-            </a:solidFill>
-          </a:ln>
-        </p:spPr>
-        <p:style>
-          <a:lnRef idx="1">
-            <a:schemeClr val="accent1"/>
-          </a:lnRef>
-          <a:fillRef idx="3">
-            <a:schemeClr val="accent1"/>
-          </a:fillRef>
-          <a:effectRef idx="2">
-            <a:schemeClr val="accent1"/>
-          </a:effectRef>
-          <a:fontRef idx="minor">
-            <a:schemeClr val="lt1"/>
-          </a:fontRef>
-        </p:style>
-        <p:txBody>
           <a:bodyPr rtlCol="0" anchor="ctr" lIns="320040" rIns="320040" tIns="164592"/>
           <a:lstStyle/>
           <a:p>
@@ -5339,7 +4976,7 @@
               </a:defRPr>
             </a:pPr>
             <a:r>
-              <a:t>WHICH LOAN WOULD YOU CHOOSE?  —  FINAL DECISION: LOAN A (PARENTS)</a:t>
+              <a:t>WHICH LOAN WOULD YOU CHOOSE?</a:t>
             </a:r>
           </a:p>
           <a:p>
@@ -5352,15 +4989,15 @@
               </a:defRPr>
             </a:pPr>
             <a:r>
-              <a:t>• Lowest Monthly Payment: Loan B has the lower monthly payment ($214.56/mo vs. $229.42/mo — $14.86 cheaper per month).</a:t>
+              <a:t>• Lowest Monthly Payment: Loan B ($214.56/mo vs. $229.42/mo — $14.86 cheaper per month).</a:t>
             </a:r>
             <a:br/>
             <a:r>
-              <a:t>• Lowest Total Interest Paid: Loan A saves $1,683.12 in total interest ($2,388.96 vs. $4,072.08).</a:t>
+              <a:t>• Lowest Total Interest: Loan A ($2,388.96 vs. $4,072.08 — saves $1,683.12).</a:t>
             </a:r>
             <a:br/>
             <a:r>
-              <a:t>• Recommendation: I choose Loan A. Paying $14.86 more per month eliminates over $1,683 in interest and clears debt a full 12 months earlier.</a:t>
+              <a:t>• My Choice: Loan A. Paying $14.86 more per month saves over $1,683 in interest and finishes 12 months sooner.</a:t>
             </a:r>
           </a:p>
         </p:txBody>
@@ -5435,7 +5072,7 @@
         <p:spPr>
           <a:xfrm>
             <a:off x="731520" y="365760"/>
-            <a:ext cx="2377440" cy="292608"/>
+            <a:ext cx="2103120" cy="292608"/>
           </a:xfrm>
           <a:prstGeom prst="roundRect">
             <a:avLst/>
@@ -5464,7 +5101,7 @@
           </a:fontRef>
         </p:style>
         <p:txBody>
-          <a:bodyPr rtlCol="0" anchor="ctr" wrap="square" tIns="0"/>
+          <a:bodyPr rtlCol="0" anchor="ctr" tIns="0"/>
           <a:lstStyle/>
           <a:p>
             <a:pPr algn="ctr">
@@ -5476,7 +5113,7 @@
               </a:defRPr>
             </a:pPr>
             <a:r>
-              <a:t>ALTERNATIVE VEHICLE CHOICE</a:t>
+              <a:t>CAR #2</a:t>
             </a:r>
           </a:p>
         </p:txBody>
@@ -5498,7 +5135,7 @@
           <a:noFill/>
         </p:spPr>
         <p:txBody>
-          <a:bodyPr wrap="square" tIns="0">
+          <a:bodyPr wrap="none" tIns="0">
             <a:spAutoFit/>
           </a:bodyPr>
           <a:lstStyle/>
@@ -5512,7 +5149,7 @@
               </a:defRPr>
             </a:pPr>
             <a:r>
-              <a:t>Car #2 Overview: 2012 Jeep Wrangler Unlimited Sport</a:t>
+              <a:t>Car #2 Overview: 2012 Jeep Wrangler Unlimited</a:t>
             </a:r>
           </a:p>
         </p:txBody>
@@ -5722,11 +5359,11 @@
           </a:fontRef>
         </p:style>
         <p:txBody>
-          <a:bodyPr rtlCol="0" anchor="ctr" tIns="137160"/>
+          <a:bodyPr rtlCol="0" anchor="ctr" tIns="164592"/>
           <a:lstStyle/>
           <a:p>
             <a:pPr algn="ctr">
-              <a:defRPr sz="950" b="1">
+              <a:defRPr sz="1000" b="1">
                 <a:solidFill>
                   <a:srgbClr val="2563EB"/>
                 </a:solidFill>
@@ -5748,19 +5385,6 @@
             </a:pPr>
             <a:r>
               <a:t>$8,995</a:t>
-            </a:r>
-          </a:p>
-          <a:p>
-            <a:pPr algn="ctr">
-              <a:defRPr sz="950">
-                <a:solidFill>
-                  <a:srgbClr val="475569"/>
-                </a:solidFill>
-                <a:latin typeface="Segoe UI"/>
-              </a:defRPr>
-            </a:pPr>
-            <a:r>
-              <a:t>Highly affordable deal</a:t>
             </a:r>
           </a:p>
         </p:txBody>
@@ -5803,11 +5427,11 @@
           </a:fontRef>
         </p:style>
         <p:txBody>
-          <a:bodyPr rtlCol="0" anchor="ctr" tIns="137160"/>
+          <a:bodyPr rtlCol="0" anchor="ctr" tIns="164592"/>
           <a:lstStyle/>
           <a:p>
             <a:pPr algn="ctr">
-              <a:defRPr sz="950" b="1">
+              <a:defRPr sz="1000" b="1">
                 <a:solidFill>
                   <a:srgbClr val="D97706"/>
                 </a:solidFill>
@@ -5855,7 +5479,7 @@
         <p:spPr>
           <a:xfrm>
             <a:off x="6080760" y="1371600"/>
-            <a:ext cx="5379415" cy="1508760"/>
+            <a:ext cx="5379415" cy="2834640"/>
           </a:xfrm>
           <a:prstGeom prst="roundRect">
             <a:avLst/>
@@ -5884,11 +5508,14 @@
           </a:fontRef>
         </p:style>
         <p:txBody>
-          <a:bodyPr rtlCol="0" anchor="ctr" lIns="274320" rIns="274320" tIns="164592"/>
+          <a:bodyPr rtlCol="0" anchor="ctr" lIns="320040" rIns="320040" tIns="228600"/>
           <a:lstStyle/>
           <a:p>
             <a:pPr algn="ctr">
-              <a:defRPr sz="1000" b="1">
+              <a:spcAft>
+                <a:spcPts val="800"/>
+              </a:spcAft>
+              <a:defRPr sz="1300" b="1">
                 <a:solidFill>
                   <a:srgbClr val="2563EB"/>
                 </a:solidFill>
@@ -5896,12 +5523,15 @@
               </a:defRPr>
             </a:pPr>
             <a:r>
-              <a:t>UTILITY &amp; CONVENIENCE FEATURES</a:t>
+              <a:t>Features &amp; Safety Options</a:t>
             </a:r>
           </a:p>
           <a:p>
             <a:pPr>
-              <a:defRPr sz="1050">
+              <a:spcAft>
+                <a:spcPts val="400"/>
+              </a:spcAft>
+              <a:defRPr sz="1100">
                 <a:solidFill>
                   <a:srgbClr val="1E293B"/>
                 </a:solidFill>
@@ -5909,19 +5539,71 @@
               </a:defRPr>
             </a:pPr>
             <a:r>
-              <a:t>• Durable wash-out interior with removable floor drain plugs</a:t>
-            </a:r>
-            <a:br/>
-            <a:r>
-              <a:t>• Command-Trac shift-on-the-fly 4WD system for extreme terrain</a:t>
-            </a:r>
-            <a:br/>
-            <a:r>
-              <a:t>• Removable doors &amp; fold-down soft top convertible versatility</a:t>
-            </a:r>
-            <a:br/>
-            <a:r>
-              <a:t>• Heavy-duty roll bar audio sound system &amp; auxiliary input</a:t>
+              <a:t>• Command-Trac shift-on-the-fly 4-wheel drive (4WD)</a:t>
+            </a:r>
+          </a:p>
+          <a:p>
+            <a:pPr>
+              <a:spcAft>
+                <a:spcPts val="400"/>
+              </a:spcAft>
+              <a:defRPr sz="1100">
+                <a:solidFill>
+                  <a:srgbClr val="1E293B"/>
+                </a:solidFill>
+                <a:latin typeface="Segoe UI"/>
+              </a:defRPr>
+            </a:pPr>
+            <a:r>
+              <a:t>• Durable wash-out interior with floor drain plugs</a:t>
+            </a:r>
+          </a:p>
+          <a:p>
+            <a:pPr>
+              <a:spcAft>
+                <a:spcPts val="400"/>
+              </a:spcAft>
+              <a:defRPr sz="1100">
+                <a:solidFill>
+                  <a:srgbClr val="1E293B"/>
+                </a:solidFill>
+                <a:latin typeface="Segoe UI"/>
+              </a:defRPr>
+            </a:pPr>
+            <a:r>
+              <a:t>• Removable soft top and full steel doors</a:t>
+            </a:r>
+          </a:p>
+          <a:p>
+            <a:pPr>
+              <a:spcAft>
+                <a:spcPts val="400"/>
+              </a:spcAft>
+              <a:defRPr sz="1100">
+                <a:solidFill>
+                  <a:srgbClr val="1E293B"/>
+                </a:solidFill>
+                <a:latin typeface="Segoe UI"/>
+              </a:defRPr>
+            </a:pPr>
+            <a:r>
+              <a:t>• Electronic stability control (ESC) &amp; roll mitigation (ERM)</a:t>
+            </a:r>
+          </a:p>
+          <a:p>
+            <a:pPr>
+              <a:spcAft>
+                <a:spcPts val="400"/>
+              </a:spcAft>
+              <a:defRPr sz="1100">
+                <a:solidFill>
+                  <a:srgbClr val="1E293B"/>
+                </a:solidFill>
+                <a:latin typeface="Segoe UI"/>
+              </a:defRPr>
+            </a:pPr>
+            <a:r>
+              <a:t>• Hill start assist (HSA) and 4-wheel anti-lock brakes (ABS)</a:t>
             </a:r>
           </a:p>
         </p:txBody>
@@ -5934,8 +5616,8 @@
         </p:nvSpPr>
         <p:spPr>
           <a:xfrm>
-            <a:off x="6080760" y="3017520"/>
-            <a:ext cx="5379415" cy="1600200"/>
+            <a:off x="6080760" y="4389120"/>
+            <a:ext cx="5379415" cy="1920240"/>
           </a:xfrm>
           <a:prstGeom prst="roundRect">
             <a:avLst/>
@@ -5964,24 +5646,27 @@
           </a:fontRef>
         </p:style>
         <p:txBody>
-          <a:bodyPr rtlCol="0" anchor="ctr" lIns="274320" rIns="274320" tIns="164592"/>
+          <a:bodyPr rtlCol="0" anchor="ctr" lIns="320040" rIns="320040" tIns="228600"/>
           <a:lstStyle/>
           <a:p>
             <a:pPr algn="ctr">
-              <a:defRPr sz="1000" b="1">
-                <a:solidFill>
-                  <a:srgbClr val="059669"/>
-                </a:solidFill>
-                <a:latin typeface="Segoe UI"/>
-              </a:defRPr>
-            </a:pPr>
-            <a:r>
-              <a:t>ACTIVE SAFETY &amp; RUGGED TRACTION</a:t>
+              <a:spcAft>
+                <a:spcPts val="600"/>
+              </a:spcAft>
+              <a:defRPr sz="1300" b="1">
+                <a:solidFill>
+                  <a:srgbClr val="0F172A"/>
+                </a:solidFill>
+                <a:latin typeface="Segoe UI"/>
+              </a:defRPr>
+            </a:pPr>
+            <a:r>
+              <a:t>Why I Chose This Car</a:t>
             </a:r>
           </a:p>
           <a:p>
             <a:pPr>
-              <a:defRPr sz="1050">
+              <a:defRPr sz="1100">
                 <a:solidFill>
                   <a:srgbClr val="1E293B"/>
                 </a:solidFill>
@@ -5989,87 +5674,7 @@
               </a:defRPr>
             </a:pPr>
             <a:r>
-              <a:t>• ESC (Electronic Stability Control) &amp; ERM (Electronic Roll Mitigation)</a:t>
-            </a:r>
-            <a:br/>
-            <a:r>
-              <a:t>• HSA (Hill Start Assist) for smooth inclines without roll-back</a:t>
-            </a:r>
-            <a:br/>
-            <a:r>
-              <a:t>• 4-Wheel Anti-lock Braking System (ABS) &amp; all-terrain traction control</a:t>
-            </a:r>
-            <a:br/>
-            <a:r>
-              <a:t>• Advanced multistage front airbag system &amp; high-strength steel frame</a:t>
-            </a:r>
-          </a:p>
-        </p:txBody>
-      </p:sp>
-      <p:sp>
-        <p:nvSpPr>
-          <p:cNvPr id="13" name="Rounded Rectangle 12"/>
-          <p:cNvSpPr/>
-          <p:nvPr/>
-        </p:nvSpPr>
-        <p:spPr>
-          <a:xfrm>
-            <a:off x="6080760" y="4754880"/>
-            <a:ext cx="5379415" cy="1554480"/>
-          </a:xfrm>
-          <a:prstGeom prst="roundRect">
-            <a:avLst/>
-          </a:prstGeom>
-          <a:solidFill>
-            <a:srgbClr val="FFFFFF"/>
-          </a:solidFill>
-          <a:ln w="12700">
-            <a:solidFill>
-              <a:srgbClr val="E2E8F0"/>
-            </a:solidFill>
-          </a:ln>
-        </p:spPr>
-        <p:style>
-          <a:lnRef idx="1">
-            <a:schemeClr val="accent1"/>
-          </a:lnRef>
-          <a:fillRef idx="3">
-            <a:schemeClr val="accent1"/>
-          </a:fillRef>
-          <a:effectRef idx="2">
-            <a:schemeClr val="accent1"/>
-          </a:effectRef>
-          <a:fontRef idx="minor">
-            <a:schemeClr val="lt1"/>
-          </a:fontRef>
-        </p:style>
-        <p:txBody>
-          <a:bodyPr rtlCol="0" anchor="ctr" lIns="274320" rIns="274320" tIns="164592"/>
-          <a:lstStyle/>
-          <a:p>
-            <a:pPr algn="ctr">
-              <a:defRPr sz="1000" b="1">
-                <a:solidFill>
-                  <a:srgbClr val="0F172A"/>
-                </a:solidFill>
-                <a:latin typeface="Segoe UI"/>
-              </a:defRPr>
-            </a:pPr>
-            <a:r>
-              <a:t>WHY THIS VEHICLE WAS CHOSEN</a:t>
-            </a:r>
-          </a:p>
-          <a:p>
-            <a:pPr>
-              <a:defRPr i="1" sz="1050">
-                <a:solidFill>
-                  <a:srgbClr val="475569"/>
-                </a:solidFill>
-                <a:latin typeface="Segoe UI"/>
-              </a:defRPr>
-            </a:pPr>
-            <a:r>
-              <a:t>"It is a great deal at its price ($8,995). It provides authentic 4WD all-weather capability, legendary durability, and the lowest acquisition cost under the $20,000 project limit."</a:t>
+              <a:t>It is a great deal at $8,995, offering true 4WD capability, simple durable maintenance, and huge budget savings.</a:t>
             </a:r>
           </a:p>
         </p:txBody>
@@ -6144,7 +5749,7 @@
         <p:spPr>
           <a:xfrm>
             <a:off x="731520" y="365760"/>
-            <a:ext cx="2377440" cy="292608"/>
+            <a:ext cx="2103120" cy="292608"/>
           </a:xfrm>
           <a:prstGeom prst="roundRect">
             <a:avLst/>
@@ -6173,7 +5778,7 @@
           </a:fontRef>
         </p:style>
         <p:txBody>
-          <a:bodyPr rtlCol="0" anchor="ctr" wrap="square" tIns="0"/>
+          <a:bodyPr rtlCol="0" anchor="ctr" tIns="0"/>
           <a:lstStyle/>
           <a:p>
             <a:pPr algn="ctr">
@@ -6185,7 +5790,7 @@
               </a:defRPr>
             </a:pPr>
             <a:r>
-              <a:t>COMPARATIVE LOAN ANALYSIS</a:t>
+              <a:t>FINANCING</a:t>
             </a:r>
           </a:p>
         </p:txBody>
@@ -6207,7 +5812,7 @@
           <a:noFill/>
         </p:spPr>
         <p:txBody>
-          <a:bodyPr wrap="square" tIns="0">
+          <a:bodyPr wrap="none" tIns="0">
             <a:spAutoFit/>
           </a:bodyPr>
           <a:lstStyle/>
@@ -6221,7 +5826,7 @@
               </a:defRPr>
             </a:pPr>
             <a:r>
-              <a:t>Car #2 Financing Breakdown: Jeep Wrangler</a:t>
+              <a:t>Car #2 Financing: Jeep Wrangler Loans</a:t>
             </a:r>
           </a:p>
         </p:txBody>
@@ -6333,7 +5938,7 @@
         <p:spPr>
           <a:xfrm>
             <a:off x="731520" y="1371600"/>
-            <a:ext cx="4114800" cy="3474720"/>
+            <a:ext cx="5212080" cy="3383280"/>
           </a:xfrm>
           <a:prstGeom prst="roundRect">
             <a:avLst/>
@@ -6362,10 +5967,23 @@
           </a:fontRef>
         </p:style>
         <p:txBody>
-          <a:bodyPr rtlCol="0" anchor="ctr" tIns="502920" lIns="274320" rIns="274320"/>
+          <a:bodyPr rtlCol="0" anchor="ctr" lIns="365760" rIns="365760" tIns="228600"/>
           <a:lstStyle/>
           <a:p>
             <a:pPr algn="ctr">
+              <a:defRPr sz="1100" b="1">
+                <a:solidFill>
+                  <a:srgbClr val="059669"/>
+                </a:solidFill>
+                <a:latin typeface="Segoe UI"/>
+              </a:defRPr>
+            </a:pPr>
+            <a:r>
+              <a:t>LOAN C (PARENTS) — RECOMMENDED</a:t>
+            </a:r>
+          </a:p>
+          <a:p>
+            <a:pPr>
               <a:spcAft>
                 <a:spcPts val="800"/>
               </a:spcAft>
@@ -6385,24 +6003,15 @@
               <a:spcAft>
                 <a:spcPts val="300"/>
               </a:spcAft>
-              <a:defRPr b="1" sz="1050">
-                <a:solidFill>
-                  <a:srgbClr val="0F172A"/>
-                </a:solidFill>
-                <a:latin typeface="Segoe UI"/>
-              </a:defRPr>
-            </a:pPr>
-            <a:r>
-              <a:t>• Terms: </a:t>
-            </a:r>
-            <a:r>
-              <a:rPr b="0">
+              <a:defRPr sz="1100" b="0">
                 <a:solidFill>
                   <a:srgbClr val="1E293B"/>
                 </a:solidFill>
                 <a:latin typeface="Segoe UI"/>
-              </a:rPr>
-              <a:t>4.2% Simple APR / 5 Years (60 Months)</a:t>
+              </a:defRPr>
+            </a:pPr>
+            <a:r>
+              <a:t>• 4.2% Simple Interest / 5 Years (60 months)</a:t>
             </a:r>
           </a:p>
           <a:p>
@@ -6410,24 +6019,15 @@
               <a:spcAft>
                 <a:spcPts val="300"/>
               </a:spcAft>
-              <a:defRPr b="1" sz="1050">
-                <a:solidFill>
-                  <a:srgbClr val="0F172A"/>
-                </a:solidFill>
-                <a:latin typeface="Segoe UI"/>
-              </a:defRPr>
-            </a:pPr>
-            <a:r>
-              <a:t>• Interest Formula: </a:t>
-            </a:r>
-            <a:r>
-              <a:rPr b="0">
+              <a:defRPr sz="1100" b="0">
                 <a:solidFill>
                   <a:srgbClr val="1E293B"/>
                 </a:solidFill>
                 <a:latin typeface="Segoe UI"/>
-              </a:rPr>
-              <a:t>I = $8,995 × 0.042 × 5 = $1,888.95</a:t>
+              </a:defRPr>
+            </a:pPr>
+            <a:r>
+              <a:t>• Interest: $8,995 × 0.042 × 5 = $1,888.95</a:t>
             </a:r>
           </a:p>
           <a:p>
@@ -6435,24 +6035,15 @@
               <a:spcAft>
                 <a:spcPts val="300"/>
               </a:spcAft>
-              <a:defRPr b="1" sz="1050">
-                <a:solidFill>
-                  <a:srgbClr val="0F172A"/>
-                </a:solidFill>
-                <a:latin typeface="Segoe UI"/>
-              </a:defRPr>
-            </a:pPr>
-            <a:r>
-              <a:t>• Total Repayment: </a:t>
-            </a:r>
-            <a:r>
-              <a:rPr b="0">
+              <a:defRPr sz="1100" b="0">
                 <a:solidFill>
                   <a:srgbClr val="1E293B"/>
                 </a:solidFill>
                 <a:latin typeface="Segoe UI"/>
-              </a:rPr>
-              <a:t>$8,995 + $1,888.95 = $10,883.95</a:t>
+              </a:defRPr>
+            </a:pPr>
+            <a:r>
+              <a:t>• Total Cost: $8,995 + $1,888.95 = $10,883.95</a:t>
             </a:r>
           </a:p>
           <a:p>
@@ -6460,24 +6051,15 @@
               <a:spcAft>
                 <a:spcPts val="300"/>
               </a:spcAft>
-              <a:defRPr b="1" sz="1050">
-                <a:solidFill>
-                  <a:srgbClr val="0F172A"/>
-                </a:solidFill>
-                <a:latin typeface="Segoe UI"/>
-              </a:defRPr>
-            </a:pPr>
-            <a:r>
-              <a:t>• Monthly Payment: </a:t>
-            </a:r>
-            <a:r>
-              <a:rPr b="0">
+              <a:defRPr sz="1100" b="0">
                 <a:solidFill>
                   <a:srgbClr val="1E293B"/>
                 </a:solidFill>
                 <a:latin typeface="Segoe UI"/>
-              </a:rPr>
-              <a:t>$10,883.95 ÷ 60 months = $181.40 / mo</a:t>
+              </a:defRPr>
+            </a:pPr>
+            <a:r>
+              <a:t>• Monthly Payment: $10,883.95 ÷ 60 = $181.40 / mo</a:t>
             </a:r>
           </a:p>
           <a:p>
@@ -6485,24 +6067,15 @@
               <a:spcAft>
                 <a:spcPts val="300"/>
               </a:spcAft>
-              <a:defRPr b="1" sz="1050">
-                <a:solidFill>
-                  <a:srgbClr val="0F172A"/>
-                </a:solidFill>
-                <a:latin typeface="Segoe UI"/>
-              </a:defRPr>
-            </a:pPr>
-            <a:r>
-              <a:t>• Interest Benefit: </a:t>
-            </a:r>
-            <a:r>
-              <a:rPr b="1">
+              <a:defRPr sz="1100" b="1">
                 <a:solidFill>
                   <a:srgbClr val="059669"/>
                 </a:solidFill>
                 <a:latin typeface="Segoe UI"/>
-              </a:rPr>
-              <a:t>Saves $1,330.84 in total interest vs. Bank!</a:t>
+              </a:defRPr>
+            </a:pPr>
+            <a:r>
+              <a:t>• Saves $1,330.84 in interest compared to the bank loan.</a:t>
             </a:r>
           </a:p>
         </p:txBody>
@@ -6515,8 +6088,159 @@
         </p:nvSpPr>
         <p:spPr>
           <a:xfrm>
-            <a:off x="731520" y="1371600"/>
-            <a:ext cx="4114800" cy="365760"/>
+            <a:off x="6248095" y="1371600"/>
+            <a:ext cx="5212080" cy="3383280"/>
+          </a:xfrm>
+          <a:prstGeom prst="roundRect">
+            <a:avLst/>
+          </a:prstGeom>
+          <a:solidFill>
+            <a:srgbClr val="FFFFFF"/>
+          </a:solidFill>
+          <a:ln w="12700">
+            <a:solidFill>
+              <a:srgbClr val="E2E8F0"/>
+            </a:solidFill>
+          </a:ln>
+        </p:spPr>
+        <p:style>
+          <a:lnRef idx="1">
+            <a:schemeClr val="accent1"/>
+          </a:lnRef>
+          <a:fillRef idx="3">
+            <a:schemeClr val="accent1"/>
+          </a:fillRef>
+          <a:effectRef idx="2">
+            <a:schemeClr val="accent1"/>
+          </a:effectRef>
+          <a:fontRef idx="minor">
+            <a:schemeClr val="lt1"/>
+          </a:fontRef>
+        </p:style>
+        <p:txBody>
+          <a:bodyPr rtlCol="0" anchor="ctr" lIns="365760" rIns="365760" tIns="228600"/>
+          <a:lstStyle/>
+          <a:p>
+            <a:pPr algn="ctr">
+              <a:defRPr sz="1100" b="1">
+                <a:solidFill>
+                  <a:srgbClr val="2563EB"/>
+                </a:solidFill>
+                <a:latin typeface="Segoe UI"/>
+              </a:defRPr>
+            </a:pPr>
+            <a:r>
+              <a:t>LOAN D (COMMERCIAL BANK)</a:t>
+            </a:r>
+          </a:p>
+          <a:p>
+            <a:pPr>
+              <a:spcAft>
+                <a:spcPts val="800"/>
+              </a:spcAft>
+              <a:defRPr sz="2400" b="1">
+                <a:solidFill>
+                  <a:srgbClr val="0F172A"/>
+                </a:solidFill>
+                <a:latin typeface="Segoe UI"/>
+              </a:defRPr>
+            </a:pPr>
+            <a:r>
+              <a:t>$169.65 / month</a:t>
+            </a:r>
+          </a:p>
+          <a:p>
+            <a:pPr>
+              <a:spcAft>
+                <a:spcPts val="300"/>
+              </a:spcAft>
+              <a:defRPr sz="1100">
+                <a:solidFill>
+                  <a:srgbClr val="1E293B"/>
+                </a:solidFill>
+                <a:latin typeface="Segoe UI"/>
+              </a:defRPr>
+            </a:pPr>
+            <a:r>
+              <a:t>• 5.1% Compound Interest (Daily) / 6 Years (72 months)</a:t>
+            </a:r>
+          </a:p>
+          <a:p>
+            <a:pPr>
+              <a:spcAft>
+                <a:spcPts val="300"/>
+              </a:spcAft>
+              <a:defRPr sz="1100">
+                <a:solidFill>
+                  <a:srgbClr val="1E293B"/>
+                </a:solidFill>
+                <a:latin typeface="Segoe UI"/>
+              </a:defRPr>
+            </a:pPr>
+            <a:r>
+              <a:t>• Formula: $8,995 × (1 + 0.051/365)^2190 = $12,214.79</a:t>
+            </a:r>
+          </a:p>
+          <a:p>
+            <a:pPr>
+              <a:spcAft>
+                <a:spcPts val="300"/>
+              </a:spcAft>
+              <a:defRPr sz="1100">
+                <a:solidFill>
+                  <a:srgbClr val="1E293B"/>
+                </a:solidFill>
+                <a:latin typeface="Segoe UI"/>
+              </a:defRPr>
+            </a:pPr>
+            <a:r>
+              <a:t>• Total Interest Paid: $12,214.79 - $8,995 = $3,219.79</a:t>
+            </a:r>
+          </a:p>
+          <a:p>
+            <a:pPr>
+              <a:spcAft>
+                <a:spcPts val="300"/>
+              </a:spcAft>
+              <a:defRPr sz="1100">
+                <a:solidFill>
+                  <a:srgbClr val="1E293B"/>
+                </a:solidFill>
+                <a:latin typeface="Segoe UI"/>
+              </a:defRPr>
+            </a:pPr>
+            <a:r>
+              <a:t>• Monthly Payment: $12,214.79 ÷ 72 = $169.65 / mo</a:t>
+            </a:r>
+          </a:p>
+          <a:p>
+            <a:pPr>
+              <a:spcAft>
+                <a:spcPts val="300"/>
+              </a:spcAft>
+              <a:defRPr sz="1100">
+                <a:solidFill>
+                  <a:srgbClr val="1E293B"/>
+                </a:solidFill>
+                <a:latin typeface="Segoe UI"/>
+              </a:defRPr>
+            </a:pPr>
+            <a:r>
+              <a:t>• Daily compounding adds $1,330 in extra interest.</a:t>
+            </a:r>
+          </a:p>
+        </p:txBody>
+      </p:sp>
+      <p:sp>
+        <p:nvSpPr>
+          <p:cNvPr id="9" name="Rounded Rectangle 8"/>
+          <p:cNvSpPr/>
+          <p:nvPr/>
+        </p:nvSpPr>
+        <p:spPr>
+          <a:xfrm>
+            <a:off x="731520" y="4983480"/>
+            <a:ext cx="10728655" cy="1325880"/>
           </a:xfrm>
           <a:prstGeom prst="roundRect">
             <a:avLst/>
@@ -6545,391 +6269,6 @@
           </a:fontRef>
         </p:style>
         <p:txBody>
-          <a:bodyPr rtlCol="0" anchor="ctr"/>
-          <a:lstStyle/>
-          <a:p>
-            <a:pPr algn="ctr">
-              <a:defRPr sz="950" b="1">
-                <a:solidFill>
-                  <a:srgbClr val="059669"/>
-                </a:solidFill>
-                <a:latin typeface="Segoe UI"/>
-              </a:defRPr>
-            </a:pPr>
-            <a:r>
-              <a:t>★ RECOMMENDED: LOAN C (PARENTS SIMPLE INTEREST)</a:t>
-            </a:r>
-          </a:p>
-        </p:txBody>
-      </p:sp>
-      <p:sp>
-        <p:nvSpPr>
-          <p:cNvPr id="9" name="Rounded Rectangle 8"/>
-          <p:cNvSpPr/>
-          <p:nvPr/>
-        </p:nvSpPr>
-        <p:spPr>
-          <a:xfrm>
-            <a:off x="5029200" y="1371600"/>
-            <a:ext cx="4114800" cy="3474720"/>
-          </a:xfrm>
-          <a:prstGeom prst="roundRect">
-            <a:avLst/>
-          </a:prstGeom>
-          <a:solidFill>
-            <a:srgbClr val="FFFFFF"/>
-          </a:solidFill>
-          <a:ln w="12700">
-            <a:solidFill>
-              <a:srgbClr val="E2E8F0"/>
-            </a:solidFill>
-          </a:ln>
-        </p:spPr>
-        <p:style>
-          <a:lnRef idx="1">
-            <a:schemeClr val="accent1"/>
-          </a:lnRef>
-          <a:fillRef idx="3">
-            <a:schemeClr val="accent1"/>
-          </a:fillRef>
-          <a:effectRef idx="2">
-            <a:schemeClr val="accent1"/>
-          </a:effectRef>
-          <a:fontRef idx="minor">
-            <a:schemeClr val="lt1"/>
-          </a:fontRef>
-        </p:style>
-        <p:txBody>
-          <a:bodyPr rtlCol="0" anchor="ctr" tIns="502920" lIns="274320" rIns="274320"/>
-          <a:lstStyle/>
-          <a:p>
-            <a:pPr algn="ctr">
-              <a:spcAft>
-                <a:spcPts val="800"/>
-              </a:spcAft>
-              <a:defRPr sz="2400" b="1">
-                <a:solidFill>
-                  <a:srgbClr val="0F172A"/>
-                </a:solidFill>
-                <a:latin typeface="Segoe UI"/>
-              </a:defRPr>
-            </a:pPr>
-            <a:r>
-              <a:t>$169.65 / month</a:t>
-            </a:r>
-          </a:p>
-          <a:p>
-            <a:pPr>
-              <a:spcAft>
-                <a:spcPts val="300"/>
-              </a:spcAft>
-              <a:defRPr b="1" sz="1050">
-                <a:solidFill>
-                  <a:srgbClr val="0F172A"/>
-                </a:solidFill>
-                <a:latin typeface="Segoe UI"/>
-              </a:defRPr>
-            </a:pPr>
-            <a:r>
-              <a:t>• Terms: </a:t>
-            </a:r>
-            <a:r>
-              <a:rPr>
-                <a:solidFill>
-                  <a:srgbClr val="1E293B"/>
-                </a:solidFill>
-                <a:latin typeface="Segoe UI"/>
-              </a:rPr>
-              <a:t>5.1% Compounded Daily (365) / 6 Years (72 Mos)</a:t>
-            </a:r>
-          </a:p>
-          <a:p>
-            <a:pPr>
-              <a:spcAft>
-                <a:spcPts val="300"/>
-              </a:spcAft>
-              <a:defRPr b="1" sz="1050">
-                <a:solidFill>
-                  <a:srgbClr val="0F172A"/>
-                </a:solidFill>
-                <a:latin typeface="Segoe UI"/>
-              </a:defRPr>
-            </a:pPr>
-            <a:r>
-              <a:t>• Compound Formula: </a:t>
-            </a:r>
-            <a:r>
-              <a:rPr>
-                <a:solidFill>
-                  <a:srgbClr val="1E293B"/>
-                </a:solidFill>
-                <a:latin typeface="Segoe UI"/>
-              </a:rPr>
-              <a:t>$8,995 × (1 + 0.051/365)^2190</a:t>
-            </a:r>
-          </a:p>
-          <a:p>
-            <a:pPr>
-              <a:spcAft>
-                <a:spcPts val="300"/>
-              </a:spcAft>
-              <a:defRPr b="1" sz="1050">
-                <a:solidFill>
-                  <a:srgbClr val="0F172A"/>
-                </a:solidFill>
-                <a:latin typeface="Segoe UI"/>
-              </a:defRPr>
-            </a:pPr>
-            <a:r>
-              <a:t>• Total Repayment: </a:t>
-            </a:r>
-            <a:r>
-              <a:rPr>
-                <a:solidFill>
-                  <a:srgbClr val="1E293B"/>
-                </a:solidFill>
-                <a:latin typeface="Segoe UI"/>
-              </a:rPr>
-              <a:t>$12,214.79 principal + interest</a:t>
-            </a:r>
-          </a:p>
-          <a:p>
-            <a:pPr>
-              <a:spcAft>
-                <a:spcPts val="300"/>
-              </a:spcAft>
-              <a:defRPr b="1" sz="1050">
-                <a:solidFill>
-                  <a:srgbClr val="0F172A"/>
-                </a:solidFill>
-                <a:latin typeface="Segoe UI"/>
-              </a:defRPr>
-            </a:pPr>
-            <a:r>
-              <a:t>• Total Interest Paid: </a:t>
-            </a:r>
-            <a:r>
-              <a:rPr>
-                <a:solidFill>
-                  <a:srgbClr val="1E293B"/>
-                </a:solidFill>
-                <a:latin typeface="Segoe UI"/>
-              </a:rPr>
-              <a:t>$12,214.79 - $8,995 = $3,219.79</a:t>
-            </a:r>
-          </a:p>
-          <a:p>
-            <a:pPr>
-              <a:spcAft>
-                <a:spcPts val="300"/>
-              </a:spcAft>
-              <a:defRPr b="1" sz="1050">
-                <a:solidFill>
-                  <a:srgbClr val="0F172A"/>
-                </a:solidFill>
-                <a:latin typeface="Segoe UI"/>
-              </a:defRPr>
-            </a:pPr>
-            <a:r>
-              <a:t>• Monthly Payment: </a:t>
-            </a:r>
-            <a:r>
-              <a:rPr>
-                <a:solidFill>
-                  <a:srgbClr val="1E293B"/>
-                </a:solidFill>
-                <a:latin typeface="Segoe UI"/>
-              </a:rPr>
-              <a:t>$12,214.79 ÷ 72 months = $169.65 / mo</a:t>
-            </a:r>
-          </a:p>
-        </p:txBody>
-      </p:sp>
-      <p:sp>
-        <p:nvSpPr>
-          <p:cNvPr id="10" name="Rounded Rectangle 9"/>
-          <p:cNvSpPr/>
-          <p:nvPr/>
-        </p:nvSpPr>
-        <p:spPr>
-          <a:xfrm>
-            <a:off x="5029200" y="1371600"/>
-            <a:ext cx="4114800" cy="365760"/>
-          </a:xfrm>
-          <a:prstGeom prst="roundRect">
-            <a:avLst/>
-          </a:prstGeom>
-          <a:solidFill>
-            <a:srgbClr val="EFF6FF"/>
-          </a:solidFill>
-          <a:ln w="12700">
-            <a:solidFill>
-              <a:srgbClr val="BFDBFE"/>
-            </a:solidFill>
-          </a:ln>
-        </p:spPr>
-        <p:style>
-          <a:lnRef idx="1">
-            <a:schemeClr val="accent1"/>
-          </a:lnRef>
-          <a:fillRef idx="3">
-            <a:schemeClr val="accent1"/>
-          </a:fillRef>
-          <a:effectRef idx="2">
-            <a:schemeClr val="accent1"/>
-          </a:effectRef>
-          <a:fontRef idx="minor">
-            <a:schemeClr val="lt1"/>
-          </a:fontRef>
-        </p:style>
-        <p:txBody>
-          <a:bodyPr rtlCol="0" anchor="ctr"/>
-          <a:lstStyle/>
-          <a:p>
-            <a:pPr algn="ctr">
-              <a:defRPr sz="950" b="1">
-                <a:solidFill>
-                  <a:srgbClr val="2563EB"/>
-                </a:solidFill>
-                <a:latin typeface="Segoe UI"/>
-              </a:defRPr>
-            </a:pPr>
-            <a:r>
-              <a:t>LOAN D: COMMERCIAL BANK (COMPOUND INTEREST)</a:t>
-            </a:r>
-          </a:p>
-        </p:txBody>
-      </p:sp>
-      <p:sp>
-        <p:nvSpPr>
-          <p:cNvPr id="11" name="Rounded Rectangle 10"/>
-          <p:cNvSpPr/>
-          <p:nvPr/>
-        </p:nvSpPr>
-        <p:spPr>
-          <a:xfrm>
-            <a:off x="9326880" y="1371600"/>
-            <a:ext cx="2133295" cy="3474720"/>
-          </a:xfrm>
-          <a:prstGeom prst="roundRect">
-            <a:avLst/>
-          </a:prstGeom>
-          <a:solidFill>
-            <a:srgbClr val="FFFFFF"/>
-          </a:solidFill>
-          <a:ln w="12700">
-            <a:solidFill>
-              <a:srgbClr val="E2E8F0"/>
-            </a:solidFill>
-          </a:ln>
-        </p:spPr>
-        <p:style>
-          <a:lnRef idx="1">
-            <a:schemeClr val="accent1"/>
-          </a:lnRef>
-          <a:fillRef idx="3">
-            <a:schemeClr val="accent1"/>
-          </a:fillRef>
-          <a:effectRef idx="2">
-            <a:schemeClr val="accent1"/>
-          </a:effectRef>
-          <a:fontRef idx="minor">
-            <a:schemeClr val="lt1"/>
-          </a:fontRef>
-        </p:style>
-        <p:txBody>
-          <a:bodyPr rtlCol="0" anchor="ctr" tIns="2468880" lIns="182880" rIns="182880"/>
-          <a:lstStyle/>
-          <a:p>
-            <a:pPr algn="ctr">
-              <a:defRPr sz="1000" b="1">
-                <a:solidFill>
-                  <a:srgbClr val="0F172A"/>
-                </a:solidFill>
-                <a:latin typeface="Segoe UI"/>
-              </a:defRPr>
-            </a:pPr>
-            <a:r>
-              <a:t>COMPOUNDING LOSS:</a:t>
-            </a:r>
-          </a:p>
-          <a:p>
-            <a:pPr>
-              <a:defRPr sz="950">
-                <a:solidFill>
-                  <a:srgbClr val="475569"/>
-                </a:solidFill>
-                <a:latin typeface="Segoe UI"/>
-              </a:defRPr>
-            </a:pPr>
-            <a:r>
-              <a:t>Commercial daily compounding causes over $3,219 to be lost strictly to interest.</a:t>
-            </a:r>
-          </a:p>
-        </p:txBody>
-      </p:sp>
-      <p:pic>
-        <p:nvPicPr>
-          <p:cNvPr id="12" name="Picture 11" descr="bank_savings.jpg"/>
-          <p:cNvPicPr>
-            <a:picLocks noChangeAspect="1"/>
-          </p:cNvPicPr>
-          <p:nvPr/>
-        </p:nvPicPr>
-        <p:blipFill>
-          <a:blip r:embed="rId2"/>
-          <a:stretch>
-            <a:fillRect/>
-          </a:stretch>
-        </p:blipFill>
-        <p:spPr>
-          <a:xfrm>
-            <a:off x="9464040" y="1508760"/>
-            <a:ext cx="1858975" cy="2194560"/>
-          </a:xfrm>
-          <a:prstGeom prst="rect">
-            <a:avLst/>
-          </a:prstGeom>
-        </p:spPr>
-      </p:pic>
-      <p:sp>
-        <p:nvSpPr>
-          <p:cNvPr id="13" name="Rounded Rectangle 12"/>
-          <p:cNvSpPr/>
-          <p:nvPr/>
-        </p:nvSpPr>
-        <p:spPr>
-          <a:xfrm>
-            <a:off x="731520" y="5029200"/>
-            <a:ext cx="10728655" cy="1280160"/>
-          </a:xfrm>
-          <a:prstGeom prst="roundRect">
-            <a:avLst/>
-          </a:prstGeom>
-          <a:solidFill>
-            <a:srgbClr val="ECFDF5"/>
-          </a:solidFill>
-          <a:ln w="12700">
-            <a:solidFill>
-              <a:srgbClr val="A7F3D0"/>
-            </a:solidFill>
-          </a:ln>
-        </p:spPr>
-        <p:style>
-          <a:lnRef idx="1">
-            <a:schemeClr val="accent1"/>
-          </a:lnRef>
-          <a:fillRef idx="3">
-            <a:schemeClr val="accent1"/>
-          </a:fillRef>
-          <a:effectRef idx="2">
-            <a:schemeClr val="accent1"/>
-          </a:effectRef>
-          <a:fontRef idx="minor">
-            <a:schemeClr val="lt1"/>
-          </a:fontRef>
-        </p:style>
-        <p:txBody>
           <a:bodyPr rtlCol="0" anchor="ctr" lIns="320040" rIns="320040" tIns="164592"/>
           <a:lstStyle/>
           <a:p>
@@ -6942,7 +6281,7 @@
               </a:defRPr>
             </a:pPr>
             <a:r>
-              <a:t>WHICH LOAN WOULD YOU CHOOSE?  —  FINAL DECISION: LOAN C (PARENTS)</a:t>
+              <a:t>WHICH LOAN WOULD YOU CHOOSE?</a:t>
             </a:r>
           </a:p>
           <a:p>
@@ -6955,15 +6294,15 @@
               </a:defRPr>
             </a:pPr>
             <a:r>
-              <a:t>• Lowest Monthly Payment: Loan D has the lower monthly payment ($169.65/mo vs. $181.40/mo — $11.75 cheaper per month).</a:t>
+              <a:t>• Lowest Monthly Payment: Loan D ($169.65/mo vs. $181.40/mo — $11.75 cheaper per month).</a:t>
             </a:r>
             <a:br/>
             <a:r>
-              <a:t>• Lowest Total Interest Paid: Loan C saves $1,330.84 in total interest ($1,888.95 vs. $3,219.79).</a:t>
+              <a:t>• Lowest Total Interest: Loan C ($1,888.95 vs. $3,219.79 — saves $1,330.84).</a:t>
             </a:r>
             <a:br/>
             <a:r>
-              <a:t>• Recommendation: I choose Loan C. Paying $11.75 more per month saves over $1,330 in interest and finishes 12 months sooner.</a:t>
+              <a:t>• My Choice: Loan C. Paying $11.75 more per month saves over $1,330 in interest and finishes 12 months sooner.</a:t>
             </a:r>
           </a:p>
         </p:txBody>
@@ -7038,7 +6377,7 @@
         <p:spPr>
           <a:xfrm>
             <a:off x="731520" y="365760"/>
-            <a:ext cx="2377440" cy="292608"/>
+            <a:ext cx="2103120" cy="292608"/>
           </a:xfrm>
           <a:prstGeom prst="roundRect">
             <a:avLst/>
@@ -7067,7 +6406,7 @@
           </a:fontRef>
         </p:style>
         <p:txBody>
-          <a:bodyPr rtlCol="0" anchor="ctr" wrap="square" tIns="0"/>
+          <a:bodyPr rtlCol="0" anchor="ctr" tIns="0"/>
           <a:lstStyle/>
           <a:p>
             <a:pPr algn="ctr">
@@ -7079,7 +6418,7 @@
               </a:defRPr>
             </a:pPr>
             <a:r>
-              <a:t>PARENT PITCH &amp; ACTION PLAN</a:t>
+              <a:t>PARENT PITCH</a:t>
             </a:r>
           </a:p>
         </p:txBody>
@@ -7101,7 +6440,7 @@
           <a:noFill/>
         </p:spPr>
         <p:txBody>
-          <a:bodyPr wrap="square" tIns="0">
+          <a:bodyPr wrap="none" tIns="0">
             <a:spAutoFit/>
           </a:bodyPr>
           <a:lstStyle/>
@@ -7115,7 +6454,7 @@
               </a:defRPr>
             </a:pPr>
             <a:r>
-              <a:t>Career &amp; Budget Reflection: Pitch to Parents</a:t>
+              <a:t>Pitch to Parents: Follow-Up Questions</a:t>
             </a:r>
           </a:p>
         </p:txBody>
@@ -7227,7 +6566,7 @@
         <p:spPr>
           <a:xfrm>
             <a:off x="731520" y="1371600"/>
-            <a:ext cx="6217920" cy="2377440"/>
+            <a:ext cx="6217920" cy="4937760"/>
           </a:xfrm>
           <a:prstGeom prst="roundRect">
             <a:avLst/>
@@ -7256,14 +6595,14 @@
           </a:fontRef>
         </p:style>
         <p:txBody>
-          <a:bodyPr rtlCol="0" anchor="ctr" lIns="320040" rIns="320040" tIns="182880"/>
+          <a:bodyPr rtlCol="0" anchor="ctr" lIns="365760" rIns="365760" tIns="274320"/>
           <a:lstStyle/>
           <a:p>
             <a:pPr algn="ctr">
               <a:spcAft>
-                <a:spcPts val="400"/>
+                <a:spcPts val="1000"/>
               </a:spcAft>
-              <a:defRPr sz="1100" b="1">
+              <a:defRPr sz="1400" b="1">
                 <a:solidFill>
                   <a:srgbClr val="2563EB"/>
                 </a:solidFill>
@@ -7271,32 +6610,129 @@
               </a:defRPr>
             </a:pPr>
             <a:r>
-              <a:t>1. VEHICLE SELECTION &amp; INITIAL BUDGET ALIGNMENT</a:t>
+              <a:t>Follow-Up Questions</a:t>
             </a:r>
           </a:p>
           <a:p>
             <a:pPr>
-              <a:defRPr sz="1050">
+              <a:spcAft>
+                <a:spcPts val="600"/>
+              </a:spcAft>
+              <a:defRPr b="1" sz="1100">
+                <a:solidFill>
+                  <a:srgbClr val="0F172A"/>
+                </a:solidFill>
+                <a:latin typeface="Segoe UI"/>
+              </a:defRPr>
+            </a:pPr>
+            <a:r>
+              <a:t>1. Chosen Car &amp; Loan: </a:t>
+            </a:r>
+            <a:r>
+              <a:rPr b="0">
                 <a:solidFill>
                   <a:srgbClr val="1E293B"/>
                 </a:solidFill>
-                <a:latin typeface="Segoe UI"/>
-              </a:defRPr>
-            </a:pPr>
-            <a:r>
-              <a:t>• Primary Vehicle Option: 2023 Nissan Rogue S AWD with Loan A ($229.42 / mo) or Loan B ($214.56 / mo).</a:t>
-            </a:r>
-            <a:br/>
-            <a:r>
-              <a:t>• Budget Alternative Option: 2012 Jeep Wrangler Unlimited with Loan C ($181.40 / mo) or Loan D ($169.65 / mo).</a:t>
-            </a:r>
-            <a:br/>
-            <a:r>
-              <a:t>• Baseline Transportation Budget (11%): $150.48 / month ($1,368.00 gross income × 0.11).</a:t>
-            </a:r>
-            <a:br/>
-            <a:r>
-              <a:t>• Does it fit into your initial budget? No. Neither car fits unassisted, but the Jeep is remarkably close (exceeding by only $19.17/mo on Loan D vs. $78.94/mo for the Rogue).</a:t>
+              </a:rPr>
+              <a:t>2023 Nissan Rogue S AWD with Loan A ($229.42 / mo).
+   (Alternative: 2012 Jeep Wrangler with Loan C at $181.40 / mo).</a:t>
+            </a:r>
+          </a:p>
+          <a:p>
+            <a:pPr>
+              <a:spcAft>
+                <a:spcPts val="600"/>
+              </a:spcAft>
+              <a:defRPr b="1" sz="1100">
+                <a:solidFill>
+                  <a:srgbClr val="0F172A"/>
+                </a:solidFill>
+                <a:latin typeface="Segoe UI"/>
+              </a:defRPr>
+            </a:pPr>
+            <a:r>
+              <a:t>2. Transportation Budget (11%): </a:t>
+            </a:r>
+            <a:r>
+              <a:rPr b="0">
+                <a:solidFill>
+                  <a:srgbClr val="1E293B"/>
+                </a:solidFill>
+              </a:rPr>
+              <a:t>$150.48 / month ($1,368.00 gross income × 0.11).</a:t>
+            </a:r>
+          </a:p>
+          <a:p>
+            <a:pPr>
+              <a:spcAft>
+                <a:spcPts val="600"/>
+              </a:spcAft>
+              <a:defRPr b="1" sz="1100">
+                <a:solidFill>
+                  <a:srgbClr val="0F172A"/>
+                </a:solidFill>
+                <a:latin typeface="Segoe UI"/>
+              </a:defRPr>
+            </a:pPr>
+            <a:r>
+              <a:t>3. Does it fit your budget?: </a:t>
+            </a:r>
+            <a:r>
+              <a:rPr b="0">
+                <a:solidFill>
+                  <a:srgbClr val="1E293B"/>
+                </a:solidFill>
+              </a:rPr>
+              <a:t>No. The car payment exceeds my $150.48 budget by $78.94 (Rogue) or $30.92 (Jeep) before insurance.</a:t>
+            </a:r>
+          </a:p>
+          <a:p>
+            <a:pPr>
+              <a:spcAft>
+                <a:spcPts val="600"/>
+              </a:spcAft>
+              <a:defRPr b="1" sz="1100">
+                <a:solidFill>
+                  <a:srgbClr val="0F172A"/>
+                </a:solidFill>
+                <a:latin typeface="Segoe UI"/>
+              </a:defRPr>
+            </a:pPr>
+            <a:r>
+              <a:t>4. Researched Car Insurance: </a:t>
+            </a:r>
+            <a:r>
+              <a:rPr b="0">
+                <a:solidFill>
+                  <a:srgbClr val="1E293B"/>
+                </a:solidFill>
+              </a:rPr>
+              <a:t>$245.00 / month (average teen rate on parents' policy).</a:t>
+            </a:r>
+          </a:p>
+          <a:p>
+            <a:pPr>
+              <a:spcAft>
+                <a:spcPts val="600"/>
+              </a:spcAft>
+              <a:defRPr b="1" sz="1100">
+                <a:solidFill>
+                  <a:srgbClr val="0F172A"/>
+                </a:solidFill>
+                <a:latin typeface="Segoe UI"/>
+              </a:defRPr>
+            </a:pPr>
+            <a:r>
+              <a:t>5. Total Monthly Payment: </a:t>
+            </a:r>
+            <a:r>
+              <a:rPr b="0">
+                <a:solidFill>
+                  <a:srgbClr val="1E293B"/>
+                </a:solidFill>
+              </a:rPr>
+              <a:t>$474.42 / month ($229.42 loan + $245.00 insurance;
+or $426.40 / mo for the Jeep).</a:t>
             </a:r>
           </a:p>
         </p:txBody>
@@ -7309,8 +6745,8 @@
         </p:nvSpPr>
         <p:spPr>
           <a:xfrm>
-            <a:off x="731520" y="3931920"/>
-            <a:ext cx="6217920" cy="2377440"/>
+            <a:off x="7132320" y="1371600"/>
+            <a:ext cx="4327855" cy="4937760"/>
           </a:xfrm>
           <a:prstGeom prst="roundRect">
             <a:avLst/>
@@ -7339,97 +6775,6 @@
           </a:fontRef>
         </p:style>
         <p:txBody>
-          <a:bodyPr rtlCol="0" anchor="ctr" lIns="320040" rIns="320040" tIns="182880"/>
-          <a:lstStyle/>
-          <a:p>
-            <a:pPr algn="ctr">
-              <a:spcAft>
-                <a:spcPts val="400"/>
-              </a:spcAft>
-              <a:defRPr sz="1100" b="1">
-                <a:solidFill>
-                  <a:srgbClr val="059669"/>
-                </a:solidFill>
-                <a:latin typeface="Segoe UI"/>
-              </a:defRPr>
-            </a:pPr>
-            <a:r>
-              <a:t>2. INSURANCE, TOTAL COMMITMENT &amp; ACTION PLAN</a:t>
-            </a:r>
-          </a:p>
-          <a:p>
-            <a:pPr>
-              <a:defRPr sz="1050">
-                <a:solidFill>
-                  <a:srgbClr val="1E293B"/>
-                </a:solidFill>
-                <a:latin typeface="Segoe UI"/>
-              </a:defRPr>
-            </a:pPr>
-            <a:r>
-              <a:t>• Researched Teen Car Insurance: $245.00 / month (average for teen added to family policy).</a:t>
-            </a:r>
-            <a:br/>
-            <a:r>
-              <a:t>• Total Monthly Transportation Commitment: $474.42 / month ($229.42 loan + $245.00 insurance; or $459.56 with Loan B).</a:t>
-            </a:r>
-            <a:br/>
-            <a:r>
-              <a:t>• Three Budget Modifications to Afford It:</a:t>
-            </a:r>
-            <a:br/>
-            <a:r>
-              <a:t>   1) Increase Target hours from 24 to 32 hrs/wk (+1 shift = +$456/mo gross = $1,824/mo total income);</a:t>
-            </a:r>
-            <a:br/>
-            <a:r>
-              <a:t>   2) Eliminate non-essential spending on dining out &amp; entertainment ($150+/mo);</a:t>
-            </a:r>
-            <a:br/>
-            <a:r>
-              <a:t>   3) Save an upfront cash down payment of $1,500–$2,000 beforehand.</a:t>
-            </a:r>
-          </a:p>
-        </p:txBody>
-      </p:sp>
-      <p:sp>
-        <p:nvSpPr>
-          <p:cNvPr id="9" name="Rounded Rectangle 8"/>
-          <p:cNvSpPr/>
-          <p:nvPr/>
-        </p:nvSpPr>
-        <p:spPr>
-          <a:xfrm>
-            <a:off x="7132320" y="1371600"/>
-            <a:ext cx="4327855" cy="4937760"/>
-          </a:xfrm>
-          <a:prstGeom prst="roundRect">
-            <a:avLst/>
-          </a:prstGeom>
-          <a:solidFill>
-            <a:srgbClr val="FFFFFF"/>
-          </a:solidFill>
-          <a:ln w="12700">
-            <a:solidFill>
-              <a:srgbClr val="E2E8F0"/>
-            </a:solidFill>
-          </a:ln>
-        </p:spPr>
-        <p:style>
-          <a:lnRef idx="1">
-            <a:schemeClr val="accent1"/>
-          </a:lnRef>
-          <a:fillRef idx="3">
-            <a:schemeClr val="accent1"/>
-          </a:fillRef>
-          <a:effectRef idx="2">
-            <a:schemeClr val="accent1"/>
-          </a:effectRef>
-          <a:fontRef idx="minor">
-            <a:schemeClr val="lt1"/>
-          </a:fontRef>
-        </p:style>
-        <p:txBody>
           <a:bodyPr rtlCol="0" anchor="ctr"/>
           <a:lstStyle/>
           <a:p>
@@ -7439,7 +6784,7 @@
       </p:sp>
       <p:pic>
         <p:nvPicPr>
-          <p:cNvPr id="10" name="Picture 9" descr="car_dealership.jpg"/>
+          <p:cNvPr id="9" name="Picture 8" descr="car_dealership.jpg"/>
           <p:cNvPicPr>
             <a:picLocks noChangeAspect="1"/>
           </p:cNvPicPr>
@@ -7454,7 +6799,7 @@
         <p:spPr>
           <a:xfrm>
             <a:off x="7360920" y="1600200"/>
-            <a:ext cx="3870655" cy="2423160"/>
+            <a:ext cx="3870655" cy="2286000"/>
           </a:xfrm>
           <a:prstGeom prst="rect">
             <a:avLst/>
@@ -7463,14 +6808,14 @@
       </p:pic>
       <p:sp>
         <p:nvSpPr>
-          <p:cNvPr id="11" name="Rounded Rectangle 10"/>
+          <p:cNvPr id="10" name="Rounded Rectangle 9"/>
           <p:cNvSpPr/>
           <p:nvPr/>
         </p:nvSpPr>
         <p:spPr>
           <a:xfrm>
-            <a:off x="7360920" y="4206240"/>
-            <a:ext cx="3870655" cy="1874519"/>
+            <a:off x="7360920" y="4069080"/>
+            <a:ext cx="3870655" cy="2011680"/>
           </a:xfrm>
           <a:prstGeom prst="roundRect">
             <a:avLst/>
@@ -7499,11 +6844,14 @@
           </a:fontRef>
         </p:style>
         <p:txBody>
-          <a:bodyPr rtlCol="0" anchor="ctr" lIns="228600" rIns="228600" tIns="182880"/>
+          <a:bodyPr rtlCol="0" anchor="ctr" lIns="228600" rIns="228600" tIns="164592"/>
           <a:lstStyle/>
           <a:p>
             <a:pPr algn="ctr">
-              <a:defRPr sz="1000" b="1">
+              <a:spcAft>
+                <a:spcPts val="400"/>
+              </a:spcAft>
+              <a:defRPr sz="1150" b="1">
                 <a:solidFill>
                   <a:srgbClr val="059669"/>
                 </a:solidFill>
@@ -7511,11 +6859,14 @@
               </a:defRPr>
             </a:pPr>
             <a:r>
-              <a:t>MY COMMITMENT TO MY PARENTS</a:t>
+              <a:t>How I Will Afford It</a:t>
             </a:r>
           </a:p>
           <a:p>
             <a:pPr>
+              <a:spcAft>
+                <a:spcPts val="200"/>
+              </a:spcAft>
               <a:defRPr sz="1000">
                 <a:solidFill>
                   <a:srgbClr val="1E293B"/>
@@ -7524,7 +6875,39 @@
               </a:defRPr>
             </a:pPr>
             <a:r>
-              <a:t>By taking on one additional shift at Target each week, I will generate an extra $456.00/month gross. This surplus completely covers my total monthly car and insurance obligation of $474.42 while maintaining personal savings and building verifiable credit and financial responsibility.</a:t>
+              <a:t>• Pick up 1 extra Target shift per week (32 hrs/wk = +$456/mo gross).</a:t>
+            </a:r>
+          </a:p>
+          <a:p>
+            <a:pPr>
+              <a:spcAft>
+                <a:spcPts val="200"/>
+              </a:spcAft>
+              <a:defRPr sz="1000">
+                <a:solidFill>
+                  <a:srgbClr val="1E293B"/>
+                </a:solidFill>
+                <a:latin typeface="Segoe UI"/>
+              </a:defRPr>
+            </a:pPr>
+            <a:r>
+              <a:t>• Cut dining out and entertainment spending ($100+/mo).</a:t>
+            </a:r>
+          </a:p>
+          <a:p>
+            <a:pPr>
+              <a:spcAft>
+                <a:spcPts val="200"/>
+              </a:spcAft>
+              <a:defRPr sz="1000">
+                <a:solidFill>
+                  <a:srgbClr val="1E293B"/>
+                </a:solidFill>
+                <a:latin typeface="Segoe UI"/>
+              </a:defRPr>
+            </a:pPr>
+            <a:r>
+              <a:t>• Put down $1,500 cash from savings to lower loan payments.</a:t>
             </a:r>
           </a:p>
         </p:txBody>

</xml_diff>